<commit_message>
auto commit 2026-05-10 17:54:30
</commit_message>
<xml_diff>
--- a/revision [Autosaved].pptx
+++ b/revision [Autosaved].pptx
@@ -12,6 +12,7 @@
     <p:sldId id="260" r:id="rId6"/>
     <p:sldId id="261" r:id="rId7"/>
     <p:sldId id="262" r:id="rId8"/>
+    <p:sldId id="263" r:id="rId9"/>
   </p:sldIdLst>
   <p:sldSz cx="12192000" cy="6858000"/>
   <p:notesSz cx="6858000" cy="9144000"/>
@@ -265,9 +266,9 @@
           <a:p>
             <a:fld id="{6F584DAC-AA37-8C49-B5B6-53E9519E19BB}" type="datetimeFigureOut">
               <a:rPr lang="en-US" smtClean="0"/>
-              <a:t>5/1/26</a:t>
+              <a:t>5/9/26</a:t>
             </a:fld>
-            <a:endParaRPr lang="en-US"/>
+            <a:endParaRPr lang="en-US" dirty="0"/>
           </a:p>
         </p:txBody>
       </p:sp>
@@ -292,7 +293,7 @@
           <a:bodyPr/>
           <a:lstStyle/>
           <a:p>
-            <a:endParaRPr lang="en-US"/>
+            <a:endParaRPr lang="en-US" dirty="0"/>
           </a:p>
         </p:txBody>
       </p:sp>
@@ -321,7 +322,7 @@
               <a:rPr lang="en-US" smtClean="0"/>
               <a:t>‹#›</a:t>
             </a:fld>
-            <a:endParaRPr lang="en-US"/>
+            <a:endParaRPr lang="en-US" dirty="0"/>
           </a:p>
         </p:txBody>
       </p:sp>
@@ -463,9 +464,9 @@
           <a:p>
             <a:fld id="{6F584DAC-AA37-8C49-B5B6-53E9519E19BB}" type="datetimeFigureOut">
               <a:rPr lang="en-US" smtClean="0"/>
-              <a:t>5/1/26</a:t>
+              <a:t>5/9/26</a:t>
             </a:fld>
-            <a:endParaRPr lang="en-US"/>
+            <a:endParaRPr lang="en-US" dirty="0"/>
           </a:p>
         </p:txBody>
       </p:sp>
@@ -490,7 +491,7 @@
           <a:bodyPr/>
           <a:lstStyle/>
           <a:p>
-            <a:endParaRPr lang="en-US"/>
+            <a:endParaRPr lang="en-US" dirty="0"/>
           </a:p>
         </p:txBody>
       </p:sp>
@@ -519,7 +520,7 @@
               <a:rPr lang="en-US" smtClean="0"/>
               <a:t>‹#›</a:t>
             </a:fld>
-            <a:endParaRPr lang="en-US"/>
+            <a:endParaRPr lang="en-US" dirty="0"/>
           </a:p>
         </p:txBody>
       </p:sp>
@@ -671,9 +672,9 @@
           <a:p>
             <a:fld id="{6F584DAC-AA37-8C49-B5B6-53E9519E19BB}" type="datetimeFigureOut">
               <a:rPr lang="en-US" smtClean="0"/>
-              <a:t>5/1/26</a:t>
+              <a:t>5/9/26</a:t>
             </a:fld>
-            <a:endParaRPr lang="en-US"/>
+            <a:endParaRPr lang="en-US" dirty="0"/>
           </a:p>
         </p:txBody>
       </p:sp>
@@ -698,7 +699,7 @@
           <a:bodyPr/>
           <a:lstStyle/>
           <a:p>
-            <a:endParaRPr lang="en-US"/>
+            <a:endParaRPr lang="en-US" dirty="0"/>
           </a:p>
         </p:txBody>
       </p:sp>
@@ -727,7 +728,7 @@
               <a:rPr lang="en-US" smtClean="0"/>
               <a:t>‹#›</a:t>
             </a:fld>
-            <a:endParaRPr lang="en-US"/>
+            <a:endParaRPr lang="en-US" dirty="0"/>
           </a:p>
         </p:txBody>
       </p:sp>
@@ -869,9 +870,9 @@
           <a:p>
             <a:fld id="{6F584DAC-AA37-8C49-B5B6-53E9519E19BB}" type="datetimeFigureOut">
               <a:rPr lang="en-US" smtClean="0"/>
-              <a:t>5/1/26</a:t>
+              <a:t>5/9/26</a:t>
             </a:fld>
-            <a:endParaRPr lang="en-US"/>
+            <a:endParaRPr lang="en-US" dirty="0"/>
           </a:p>
         </p:txBody>
       </p:sp>
@@ -896,7 +897,7 @@
           <a:bodyPr/>
           <a:lstStyle/>
           <a:p>
-            <a:endParaRPr lang="en-US"/>
+            <a:endParaRPr lang="en-US" dirty="0"/>
           </a:p>
         </p:txBody>
       </p:sp>
@@ -925,7 +926,7 @@
               <a:rPr lang="en-US" smtClean="0"/>
               <a:t>‹#›</a:t>
             </a:fld>
-            <a:endParaRPr lang="en-US"/>
+            <a:endParaRPr lang="en-US" dirty="0"/>
           </a:p>
         </p:txBody>
       </p:sp>
@@ -1144,9 +1145,9 @@
           <a:p>
             <a:fld id="{6F584DAC-AA37-8C49-B5B6-53E9519E19BB}" type="datetimeFigureOut">
               <a:rPr lang="en-US" smtClean="0"/>
-              <a:t>5/1/26</a:t>
+              <a:t>5/9/26</a:t>
             </a:fld>
-            <a:endParaRPr lang="en-US"/>
+            <a:endParaRPr lang="en-US" dirty="0"/>
           </a:p>
         </p:txBody>
       </p:sp>
@@ -1171,7 +1172,7 @@
           <a:bodyPr/>
           <a:lstStyle/>
           <a:p>
-            <a:endParaRPr lang="en-US"/>
+            <a:endParaRPr lang="en-US" dirty="0"/>
           </a:p>
         </p:txBody>
       </p:sp>
@@ -1200,7 +1201,7 @@
               <a:rPr lang="en-US" smtClean="0"/>
               <a:t>‹#›</a:t>
             </a:fld>
-            <a:endParaRPr lang="en-US"/>
+            <a:endParaRPr lang="en-US" dirty="0"/>
           </a:p>
         </p:txBody>
       </p:sp>
@@ -1409,9 +1410,9 @@
           <a:p>
             <a:fld id="{6F584DAC-AA37-8C49-B5B6-53E9519E19BB}" type="datetimeFigureOut">
               <a:rPr lang="en-US" smtClean="0"/>
-              <a:t>5/1/26</a:t>
+              <a:t>5/9/26</a:t>
             </a:fld>
-            <a:endParaRPr lang="en-US"/>
+            <a:endParaRPr lang="en-US" dirty="0"/>
           </a:p>
         </p:txBody>
       </p:sp>
@@ -1436,7 +1437,7 @@
           <a:bodyPr/>
           <a:lstStyle/>
           <a:p>
-            <a:endParaRPr lang="en-US"/>
+            <a:endParaRPr lang="en-US" dirty="0"/>
           </a:p>
         </p:txBody>
       </p:sp>
@@ -1465,7 +1466,7 @@
               <a:rPr lang="en-US" smtClean="0"/>
               <a:t>‹#›</a:t>
             </a:fld>
-            <a:endParaRPr lang="en-US"/>
+            <a:endParaRPr lang="en-US" dirty="0"/>
           </a:p>
         </p:txBody>
       </p:sp>
@@ -1821,9 +1822,9 @@
           <a:p>
             <a:fld id="{6F584DAC-AA37-8C49-B5B6-53E9519E19BB}" type="datetimeFigureOut">
               <a:rPr lang="en-US" smtClean="0"/>
-              <a:t>5/1/26</a:t>
+              <a:t>5/9/26</a:t>
             </a:fld>
-            <a:endParaRPr lang="en-US"/>
+            <a:endParaRPr lang="en-US" dirty="0"/>
           </a:p>
         </p:txBody>
       </p:sp>
@@ -1848,7 +1849,7 @@
           <a:bodyPr/>
           <a:lstStyle/>
           <a:p>
-            <a:endParaRPr lang="en-US"/>
+            <a:endParaRPr lang="en-US" dirty="0"/>
           </a:p>
         </p:txBody>
       </p:sp>
@@ -1877,7 +1878,7 @@
               <a:rPr lang="en-US" smtClean="0"/>
               <a:t>‹#›</a:t>
             </a:fld>
-            <a:endParaRPr lang="en-US"/>
+            <a:endParaRPr lang="en-US" dirty="0"/>
           </a:p>
         </p:txBody>
       </p:sp>
@@ -1962,9 +1963,9 @@
           <a:p>
             <a:fld id="{6F584DAC-AA37-8C49-B5B6-53E9519E19BB}" type="datetimeFigureOut">
               <a:rPr lang="en-US" smtClean="0"/>
-              <a:t>5/1/26</a:t>
+              <a:t>5/9/26</a:t>
             </a:fld>
-            <a:endParaRPr lang="en-US"/>
+            <a:endParaRPr lang="en-US" dirty="0"/>
           </a:p>
         </p:txBody>
       </p:sp>
@@ -1989,7 +1990,7 @@
           <a:bodyPr/>
           <a:lstStyle/>
           <a:p>
-            <a:endParaRPr lang="en-US"/>
+            <a:endParaRPr lang="en-US" dirty="0"/>
           </a:p>
         </p:txBody>
       </p:sp>
@@ -2018,7 +2019,7 @@
               <a:rPr lang="en-US" smtClean="0"/>
               <a:t>‹#›</a:t>
             </a:fld>
-            <a:endParaRPr lang="en-US"/>
+            <a:endParaRPr lang="en-US" dirty="0"/>
           </a:p>
         </p:txBody>
       </p:sp>
@@ -2075,9 +2076,9 @@
           <a:p>
             <a:fld id="{6F584DAC-AA37-8C49-B5B6-53E9519E19BB}" type="datetimeFigureOut">
               <a:rPr lang="en-US" smtClean="0"/>
-              <a:t>5/1/26</a:t>
+              <a:t>5/9/26</a:t>
             </a:fld>
-            <a:endParaRPr lang="en-US"/>
+            <a:endParaRPr lang="en-US" dirty="0"/>
           </a:p>
         </p:txBody>
       </p:sp>
@@ -2102,7 +2103,7 @@
           <a:bodyPr/>
           <a:lstStyle/>
           <a:p>
-            <a:endParaRPr lang="en-US"/>
+            <a:endParaRPr lang="en-US" dirty="0"/>
           </a:p>
         </p:txBody>
       </p:sp>
@@ -2131,7 +2132,7 @@
               <a:rPr lang="en-US" smtClean="0"/>
               <a:t>‹#›</a:t>
             </a:fld>
-            <a:endParaRPr lang="en-US"/>
+            <a:endParaRPr lang="en-US" dirty="0"/>
           </a:p>
         </p:txBody>
       </p:sp>
@@ -2386,9 +2387,9 @@
           <a:p>
             <a:fld id="{6F584DAC-AA37-8C49-B5B6-53E9519E19BB}" type="datetimeFigureOut">
               <a:rPr lang="en-US" smtClean="0"/>
-              <a:t>5/1/26</a:t>
+              <a:t>5/9/26</a:t>
             </a:fld>
-            <a:endParaRPr lang="en-US"/>
+            <a:endParaRPr lang="en-US" dirty="0"/>
           </a:p>
         </p:txBody>
       </p:sp>
@@ -2413,7 +2414,7 @@
           <a:bodyPr/>
           <a:lstStyle/>
           <a:p>
-            <a:endParaRPr lang="en-US"/>
+            <a:endParaRPr lang="en-US" dirty="0"/>
           </a:p>
         </p:txBody>
       </p:sp>
@@ -2442,7 +2443,7 @@
               <a:rPr lang="en-US" smtClean="0"/>
               <a:t>‹#›</a:t>
             </a:fld>
-            <a:endParaRPr lang="en-US"/>
+            <a:endParaRPr lang="en-US" dirty="0"/>
           </a:p>
         </p:txBody>
       </p:sp>
@@ -2576,7 +2577,7 @@
             </a:lvl9pPr>
           </a:lstStyle>
           <a:p>
-            <a:endParaRPr lang="en-US"/>
+            <a:endParaRPr lang="en-US" dirty="0"/>
           </a:p>
         </p:txBody>
       </p:sp>
@@ -2674,9 +2675,9 @@
           <a:p>
             <a:fld id="{6F584DAC-AA37-8C49-B5B6-53E9519E19BB}" type="datetimeFigureOut">
               <a:rPr lang="en-US" smtClean="0"/>
-              <a:t>5/1/26</a:t>
+              <a:t>5/9/26</a:t>
             </a:fld>
-            <a:endParaRPr lang="en-US"/>
+            <a:endParaRPr lang="en-US" dirty="0"/>
           </a:p>
         </p:txBody>
       </p:sp>
@@ -2701,7 +2702,7 @@
           <a:bodyPr/>
           <a:lstStyle/>
           <a:p>
-            <a:endParaRPr lang="en-US"/>
+            <a:endParaRPr lang="en-US" dirty="0"/>
           </a:p>
         </p:txBody>
       </p:sp>
@@ -2730,7 +2731,7 @@
               <a:rPr lang="en-US" smtClean="0"/>
               <a:t>‹#›</a:t>
             </a:fld>
-            <a:endParaRPr lang="en-US"/>
+            <a:endParaRPr lang="en-US" dirty="0"/>
           </a:p>
         </p:txBody>
       </p:sp>
@@ -2915,9 +2916,9 @@
           <a:p>
             <a:fld id="{6F584DAC-AA37-8C49-B5B6-53E9519E19BB}" type="datetimeFigureOut">
               <a:rPr lang="en-US" smtClean="0"/>
-              <a:t>5/1/26</a:t>
+              <a:t>5/9/26</a:t>
             </a:fld>
-            <a:endParaRPr lang="en-US"/>
+            <a:endParaRPr lang="en-US" dirty="0"/>
           </a:p>
         </p:txBody>
       </p:sp>
@@ -2960,7 +2961,7 @@
             </a:lvl1pPr>
           </a:lstStyle>
           <a:p>
-            <a:endParaRPr lang="en-US"/>
+            <a:endParaRPr lang="en-US" dirty="0"/>
           </a:p>
         </p:txBody>
       </p:sp>
@@ -3007,7 +3008,7 @@
               <a:rPr lang="en-US" smtClean="0"/>
               <a:t>‹#›</a:t>
             </a:fld>
-            <a:endParaRPr lang="en-US"/>
+            <a:endParaRPr lang="en-US" dirty="0"/>
           </a:p>
         </p:txBody>
       </p:sp>
@@ -3436,10 +3437,9 @@
           </a:p>
           <a:p>
             <a:r>
-              <a:rPr lang="en-US" b="1" dirty="0" err="1"/>
+              <a:rPr lang="en-US" b="1" dirty="0"/>
               <a:t>wikipedia_link_ru</a:t>
             </a:r>
-            <a:endParaRPr lang="en-US" b="1" dirty="0"/>
           </a:p>
           <a:p>
             <a:r>
@@ -3585,7 +3585,7 @@
           <a:lstStyle/>
           <a:p>
             <a:pPr algn="ctr"/>
-            <a:endParaRPr lang="en-US"/>
+            <a:endParaRPr lang="en-US" dirty="0"/>
           </a:p>
         </p:txBody>
       </p:sp>
@@ -3631,7 +3631,7 @@
           <a:lstStyle/>
           <a:p>
             <a:pPr algn="ctr"/>
-            <a:endParaRPr lang="en-US"/>
+            <a:endParaRPr lang="en-US" dirty="0"/>
           </a:p>
         </p:txBody>
       </p:sp>
@@ -3677,7 +3677,7 @@
           <a:lstStyle/>
           <a:p>
             <a:pPr algn="ctr"/>
-            <a:endParaRPr lang="en-US"/>
+            <a:endParaRPr lang="en-US" dirty="0"/>
           </a:p>
         </p:txBody>
       </p:sp>
@@ -3723,7 +3723,7 @@
           <a:lstStyle/>
           <a:p>
             <a:pPr algn="ctr"/>
-            <a:endParaRPr lang="en-US"/>
+            <a:endParaRPr lang="en-US" dirty="0"/>
           </a:p>
         </p:txBody>
       </p:sp>
@@ -3769,7 +3769,7 @@
           <a:lstStyle/>
           <a:p>
             <a:pPr algn="ctr"/>
-            <a:endParaRPr lang="en-US"/>
+            <a:endParaRPr lang="en-US" dirty="0"/>
           </a:p>
         </p:txBody>
       </p:sp>
@@ -3815,7 +3815,7 @@
           <a:lstStyle/>
           <a:p>
             <a:pPr algn="ctr"/>
-            <a:endParaRPr lang="en-US"/>
+            <a:endParaRPr lang="en-US" dirty="0"/>
           </a:p>
         </p:txBody>
       </p:sp>
@@ -3861,7 +3861,7 @@
           <a:lstStyle/>
           <a:p>
             <a:pPr algn="ctr"/>
-            <a:endParaRPr lang="en-US"/>
+            <a:endParaRPr lang="en-US" dirty="0"/>
           </a:p>
         </p:txBody>
       </p:sp>
@@ -3907,7 +3907,7 @@
           <a:lstStyle/>
           <a:p>
             <a:pPr algn="ctr"/>
-            <a:endParaRPr lang="en-US"/>
+            <a:endParaRPr lang="en-US" dirty="0"/>
           </a:p>
         </p:txBody>
       </p:sp>
@@ -3953,7 +3953,7 @@
           <a:lstStyle/>
           <a:p>
             <a:pPr algn="ctr"/>
-            <a:endParaRPr lang="en-US"/>
+            <a:endParaRPr lang="en-US" dirty="0"/>
           </a:p>
         </p:txBody>
       </p:sp>
@@ -3999,7 +3999,7 @@
           <a:lstStyle/>
           <a:p>
             <a:pPr algn="ctr"/>
-            <a:endParaRPr lang="en-US"/>
+            <a:endParaRPr lang="en-US" dirty="0"/>
           </a:p>
         </p:txBody>
       </p:sp>
@@ -4045,7 +4045,7 @@
           <a:lstStyle/>
           <a:p>
             <a:pPr algn="ctr"/>
-            <a:endParaRPr lang="en-US"/>
+            <a:endParaRPr lang="en-US" dirty="0"/>
           </a:p>
         </p:txBody>
       </p:sp>
@@ -4091,7 +4091,7 @@
           <a:lstStyle/>
           <a:p>
             <a:pPr algn="ctr"/>
-            <a:endParaRPr lang="en-US"/>
+            <a:endParaRPr lang="en-US" dirty="0"/>
           </a:p>
         </p:txBody>
       </p:sp>
@@ -4125,10 +4125,9 @@
           <a:p>
             <a:pPr algn="ctr"/>
             <a:r>
-              <a:rPr lang="en-US" dirty="0" err="1"/>
+              <a:rPr lang="en-US" dirty="0"/>
               <a:t>Brd</a:t>
             </a:r>
-            <a:endParaRPr lang="en-US" dirty="0"/>
           </a:p>
         </p:txBody>
       </p:sp>
@@ -4208,7 +4207,7 @@
           <a:lstStyle/>
           <a:p>
             <a:pPr algn="ctr"/>
-            <a:endParaRPr lang="en-US"/>
+            <a:endParaRPr lang="en-US" dirty="0"/>
           </a:p>
         </p:txBody>
       </p:sp>
@@ -4252,7 +4251,7 @@
           <a:lstStyle/>
           <a:p>
             <a:pPr algn="ctr"/>
-            <a:endParaRPr lang="en-US"/>
+            <a:endParaRPr lang="en-US" dirty="0"/>
           </a:p>
         </p:txBody>
       </p:sp>
@@ -4296,7 +4295,7 @@
           <a:lstStyle/>
           <a:p>
             <a:pPr algn="ctr"/>
-            <a:endParaRPr lang="en-US"/>
+            <a:endParaRPr lang="en-US" dirty="0"/>
           </a:p>
         </p:txBody>
       </p:sp>
@@ -4446,10 +4445,9 @@
           <a:lstStyle/>
           <a:p>
             <a:r>
-              <a:rPr lang="en-US" b="1" dirty="0" err="1"/>
+              <a:rPr lang="en-US" b="1" dirty="0"/>
               <a:t>wikipedia_link_ru</a:t>
             </a:r>
-            <a:endParaRPr lang="en-US" b="1" dirty="0"/>
           </a:p>
           <a:p>
             <a:r>
@@ -4595,7 +4593,7 @@
           <a:lstStyle/>
           <a:p>
             <a:pPr algn="ctr"/>
-            <a:endParaRPr lang="en-US"/>
+            <a:endParaRPr lang="en-US" dirty="0"/>
           </a:p>
         </p:txBody>
       </p:sp>
@@ -4641,7 +4639,7 @@
           <a:lstStyle/>
           <a:p>
             <a:pPr algn="ctr"/>
-            <a:endParaRPr lang="en-US"/>
+            <a:endParaRPr lang="en-US" dirty="0"/>
           </a:p>
         </p:txBody>
       </p:sp>
@@ -4687,7 +4685,7 @@
           <a:lstStyle/>
           <a:p>
             <a:pPr algn="ctr"/>
-            <a:endParaRPr lang="en-US"/>
+            <a:endParaRPr lang="en-US" dirty="0"/>
           </a:p>
         </p:txBody>
       </p:sp>
@@ -4733,7 +4731,7 @@
           <a:lstStyle/>
           <a:p>
             <a:pPr algn="ctr"/>
-            <a:endParaRPr lang="en-US"/>
+            <a:endParaRPr lang="en-US" dirty="0"/>
           </a:p>
         </p:txBody>
       </p:sp>
@@ -4779,7 +4777,7 @@
           <a:lstStyle/>
           <a:p>
             <a:pPr algn="ctr"/>
-            <a:endParaRPr lang="en-US"/>
+            <a:endParaRPr lang="en-US" dirty="0"/>
           </a:p>
         </p:txBody>
       </p:sp>
@@ -4825,7 +4823,7 @@
           <a:lstStyle/>
           <a:p>
             <a:pPr algn="ctr"/>
-            <a:endParaRPr lang="en-US"/>
+            <a:endParaRPr lang="en-US" dirty="0"/>
           </a:p>
         </p:txBody>
       </p:sp>
@@ -4871,7 +4869,7 @@
           <a:lstStyle/>
           <a:p>
             <a:pPr algn="ctr"/>
-            <a:endParaRPr lang="en-US"/>
+            <a:endParaRPr lang="en-US" dirty="0"/>
           </a:p>
         </p:txBody>
       </p:sp>
@@ -4917,7 +4915,7 @@
           <a:lstStyle/>
           <a:p>
             <a:pPr algn="ctr"/>
-            <a:endParaRPr lang="en-US"/>
+            <a:endParaRPr lang="en-US" dirty="0"/>
           </a:p>
         </p:txBody>
       </p:sp>
@@ -4963,7 +4961,7 @@
           <a:lstStyle/>
           <a:p>
             <a:pPr algn="ctr"/>
-            <a:endParaRPr lang="en-US"/>
+            <a:endParaRPr lang="en-US" dirty="0"/>
           </a:p>
         </p:txBody>
       </p:sp>
@@ -5009,7 +5007,7 @@
           <a:lstStyle/>
           <a:p>
             <a:pPr algn="ctr"/>
-            <a:endParaRPr lang="en-US"/>
+            <a:endParaRPr lang="en-US" dirty="0"/>
           </a:p>
         </p:txBody>
       </p:sp>
@@ -5055,7 +5053,7 @@
           <a:lstStyle/>
           <a:p>
             <a:pPr algn="ctr"/>
-            <a:endParaRPr lang="en-US"/>
+            <a:endParaRPr lang="en-US" dirty="0"/>
           </a:p>
         </p:txBody>
       </p:sp>
@@ -5101,7 +5099,7 @@
           <a:lstStyle/>
           <a:p>
             <a:pPr algn="ctr"/>
-            <a:endParaRPr lang="en-US"/>
+            <a:endParaRPr lang="en-US" dirty="0"/>
           </a:p>
         </p:txBody>
       </p:sp>
@@ -5135,10 +5133,9 @@
           <a:p>
             <a:pPr algn="ctr"/>
             <a:r>
-              <a:rPr lang="en-US" dirty="0" err="1"/>
+              <a:rPr lang="en-US" dirty="0"/>
               <a:t>Brd</a:t>
             </a:r>
-            <a:endParaRPr lang="en-US" dirty="0"/>
           </a:p>
         </p:txBody>
       </p:sp>
@@ -5218,7 +5215,7 @@
           <a:lstStyle/>
           <a:p>
             <a:pPr algn="ctr"/>
-            <a:endParaRPr lang="en-US"/>
+            <a:endParaRPr lang="en-US" dirty="0"/>
           </a:p>
         </p:txBody>
       </p:sp>
@@ -5262,7 +5259,7 @@
           <a:lstStyle/>
           <a:p>
             <a:pPr algn="ctr"/>
-            <a:endParaRPr lang="en-US"/>
+            <a:endParaRPr lang="en-US" dirty="0"/>
           </a:p>
         </p:txBody>
       </p:sp>
@@ -5306,7 +5303,7 @@
           <a:lstStyle/>
           <a:p>
             <a:pPr algn="ctr"/>
-            <a:endParaRPr lang="en-US"/>
+            <a:endParaRPr lang="en-US" dirty="0"/>
           </a:p>
         </p:txBody>
       </p:sp>
@@ -5409,10 +5406,9 @@
           <a:p>
             <a:pPr algn="ctr"/>
             <a:r>
-              <a:rPr lang="en-US" dirty="0" err="1"/>
+              <a:rPr lang="en-US" dirty="0"/>
               <a:t>Bwr</a:t>
             </a:r>
-            <a:endParaRPr lang="en-US" dirty="0"/>
           </a:p>
         </p:txBody>
       </p:sp>
@@ -5701,10 +5697,9 @@
           <a:p>
             <a:pPr algn="ctr"/>
             <a:r>
-              <a:rPr lang="en-US" dirty="0" err="1"/>
+              <a:rPr lang="en-US" dirty="0"/>
               <a:t>Bwr</a:t>
             </a:r>
-            <a:endParaRPr lang="en-US" dirty="0"/>
           </a:p>
         </p:txBody>
       </p:sp>
@@ -5942,20 +5937,12 @@
           <a:lstStyle/>
           <a:p>
             <a:r>
-              <a:rPr lang="en-US" dirty="0" err="1">
-                <a:solidFill>
-                  <a:schemeClr val="accent1"/>
-                </a:solidFill>
-              </a:rPr>
-              <a:t>wikipedia_link_fr</a:t>
-            </a:r>
-            <a:r>
               <a:rPr lang="en-US" dirty="0">
                 <a:solidFill>
                   <a:schemeClr val="accent1"/>
                 </a:solidFill>
               </a:rPr>
-              <a:t> is facing this situation. How to address it??</a:t>
+              <a:t>wikipedia_link_fr is facing this situation. How to address it??</a:t>
             </a:r>
           </a:p>
         </p:txBody>
@@ -6144,7 +6131,7 @@
           <a:lstStyle/>
           <a:p>
             <a:pPr algn="ctr"/>
-            <a:endParaRPr lang="en-US"/>
+            <a:endParaRPr lang="en-US" dirty="0"/>
           </a:p>
         </p:txBody>
       </p:sp>
@@ -6237,7 +6224,7 @@
             <a:lstStyle/>
             <a:p>
               <a:pPr algn="ctr"/>
-              <a:endParaRPr lang="en-US"/>
+              <a:endParaRPr lang="en-US" dirty="0"/>
             </a:p>
           </p:txBody>
         </p:sp>
@@ -6296,7 +6283,7 @@
             <a:lstStyle/>
             <a:p>
               <a:pPr algn="ctr"/>
-              <a:endParaRPr lang="en-US"/>
+              <a:endParaRPr lang="en-US" dirty="0"/>
             </a:p>
           </p:txBody>
         </p:sp>
@@ -6355,7 +6342,7 @@
             <a:lstStyle/>
             <a:p>
               <a:pPr algn="ctr"/>
-              <a:endParaRPr lang="en-US"/>
+              <a:endParaRPr lang="en-US" dirty="0"/>
             </a:p>
           </p:txBody>
         </p:sp>
@@ -6426,7 +6413,7 @@
           <a:lstStyle/>
           <a:p>
             <a:pPr algn="ctr"/>
-            <a:endParaRPr lang="en-US"/>
+            <a:endParaRPr lang="en-US" dirty="0"/>
           </a:p>
         </p:txBody>
       </p:sp>
@@ -6635,7 +6622,7 @@
                         <a:buNone/>
                       </a:pPr>
                       <a:r>
-                        <a:rPr lang="en-US" sz="2000" b="1" i="0" u="none" strike="noStrike">
+                        <a:rPr lang="en-US" sz="2000" b="1" i="0" u="none" strike="noStrike" dirty="0">
                           <a:solidFill>
                             <a:srgbClr val="FFFFFF"/>
                           </a:solidFill>
@@ -6644,7 +6631,7 @@
                         </a:rPr>
                         <a:t>dataset</a:t>
                       </a:r>
-                      <a:endParaRPr lang="en-US" sz="2300" b="0" i="0" u="none" strike="noStrike">
+                      <a:endParaRPr lang="en-US" sz="2300" b="0" i="0" u="none" strike="noStrike" dirty="0">
                         <a:effectLst/>
                         <a:latin typeface="Arial" panose="020B0604020202020204" pitchFamily="34" charset="0"/>
                       </a:endParaRPr>
@@ -6695,7 +6682,7 @@
                         <a:buNone/>
                       </a:pPr>
                       <a:r>
-                        <a:rPr lang="en-US" sz="2000" b="1" i="0" u="none" strike="noStrike">
+                        <a:rPr lang="en-US" sz="2000" b="1" i="0" u="none" strike="noStrike" dirty="0">
                           <a:solidFill>
                             <a:srgbClr val="FFFFFF"/>
                           </a:solidFill>
@@ -6704,7 +6691,7 @@
                         </a:rPr>
                         <a:t>V</a:t>
                       </a:r>
-                      <a:endParaRPr lang="en-US" sz="2300" b="0" i="0" u="none" strike="noStrike">
+                      <a:endParaRPr lang="en-US" sz="2300" b="0" i="0" u="none" strike="noStrike" dirty="0">
                         <a:effectLst/>
                         <a:latin typeface="Arial" panose="020B0604020202020204" pitchFamily="34" charset="0"/>
                       </a:endParaRPr>
@@ -6749,7 +6736,7 @@
                         <a:buNone/>
                       </a:pPr>
                       <a:r>
-                        <a:rPr lang="en-US" sz="2000" b="1" i="0" u="none" strike="noStrike">
+                        <a:rPr lang="en-US" sz="2000" b="1" i="0" u="none" strike="noStrike" dirty="0">
                           <a:solidFill>
                             <a:srgbClr val="FFFFFF"/>
                           </a:solidFill>
@@ -6758,7 +6745,7 @@
                         </a:rPr>
                         <a:t>E</a:t>
                       </a:r>
-                      <a:endParaRPr lang="en-US" sz="2300" b="0" i="0" u="none" strike="noStrike">
+                      <a:endParaRPr lang="en-US" sz="2300" b="0" i="0" u="none" strike="noStrike" dirty="0">
                         <a:effectLst/>
                         <a:latin typeface="Arial" panose="020B0604020202020204" pitchFamily="34" charset="0"/>
                       </a:endParaRPr>
@@ -6803,7 +6790,7 @@
                         <a:buNone/>
                       </a:pPr>
                       <a:r>
-                        <a:rPr lang="el-GR" sz="2000" b="1" i="0" u="none" strike="noStrike">
+                        <a:rPr lang="el-GR" sz="2000" b="1" i="0" u="none" strike="noStrike" dirty="0">
                           <a:solidFill>
                             <a:srgbClr val="FFFFFF"/>
                           </a:solidFill>
@@ -6812,7 +6799,7 @@
                         </a:rPr>
                         <a:t>θ</a:t>
                       </a:r>
-                      <a:endParaRPr lang="en-US" sz="2300" b="0" i="0" u="none" strike="noStrike">
+                      <a:endParaRPr lang="en-US" sz="2300" b="0" i="0" u="none" strike="noStrike" dirty="0">
                         <a:effectLst/>
                         <a:latin typeface="Arial" panose="020B0604020202020204" pitchFamily="34" charset="0"/>
                       </a:endParaRPr>
@@ -6857,7 +6844,7 @@
                         <a:buNone/>
                       </a:pPr>
                       <a:r>
-                        <a:rPr lang="el-GR" sz="2000" b="1" i="0" u="none" strike="noStrike">
+                        <a:rPr lang="el-GR" sz="2000" b="1" i="0" u="none" strike="noStrike" dirty="0">
                           <a:solidFill>
                             <a:srgbClr val="FFFFFF"/>
                           </a:solidFill>
@@ -6866,7 +6853,7 @@
                         </a:rPr>
                         <a:t>γ</a:t>
                       </a:r>
-                      <a:endParaRPr lang="en-US" sz="2300" b="0" i="0" u="none" strike="noStrike">
+                      <a:endParaRPr lang="en-US" sz="2300" b="0" i="0" u="none" strike="noStrike" dirty="0">
                         <a:effectLst/>
                         <a:latin typeface="Arial" panose="020B0604020202020204" pitchFamily="34" charset="0"/>
                       </a:endParaRPr>
@@ -6911,7 +6898,7 @@
                         <a:buNone/>
                       </a:pPr>
                       <a:r>
-                        <a:rPr lang="en-US" sz="2000" b="1" i="0" u="none" strike="noStrike">
+                        <a:rPr lang="en-US" sz="2000" b="1" i="0" u="none" strike="noStrike" dirty="0">
                           <a:solidFill>
                             <a:srgbClr val="FFFFFF"/>
                           </a:solidFill>
@@ -6920,7 +6907,7 @@
                         </a:rPr>
                         <a:t>#MQC</a:t>
                       </a:r>
-                      <a:endParaRPr lang="en-US" sz="2300" b="0" i="0" u="none" strike="noStrike">
+                      <a:endParaRPr lang="en-US" sz="2300" b="0" i="0" u="none" strike="noStrike" dirty="0">
                         <a:effectLst/>
                         <a:latin typeface="Arial" panose="020B0604020202020204" pitchFamily="34" charset="0"/>
                       </a:endParaRPr>
@@ -6965,16 +6952,6 @@
                         <a:buNone/>
                       </a:pPr>
                       <a:r>
-                        <a:rPr lang="en-US" sz="2000" b="1" i="0" u="none" strike="noStrike" dirty="0" err="1">
-                          <a:solidFill>
-                            <a:srgbClr val="FFFFFF"/>
-                          </a:solidFill>
-                          <a:effectLst/>
-                          <a:latin typeface="Aptos Narrow" panose="020B0004020202020204" pitchFamily="34" charset="0"/>
-                        </a:rPr>
-                        <a:t>Gthinker</a:t>
-                      </a:r>
-                      <a:r>
                         <a:rPr lang="en-US" sz="2000" b="1" i="0" u="none" strike="noStrike" dirty="0">
                           <a:solidFill>
                             <a:srgbClr val="FFFFFF"/>
@@ -6982,7 +6959,7 @@
                           <a:effectLst/>
                           <a:latin typeface="Aptos Narrow" panose="020B0004020202020204" pitchFamily="34" charset="0"/>
                         </a:rPr>
-                        <a:t>-CG</a:t>
+                        <a:t>Gthinker-CG</a:t>
                       </a:r>
                       <a:endParaRPr lang="en-US" sz="2300" b="0" i="0" u="none" strike="noStrike" dirty="0">
                         <a:effectLst/>
@@ -7029,7 +7006,7 @@
                         <a:buNone/>
                       </a:pPr>
                       <a:r>
-                        <a:rPr lang="en-US" sz="2000" b="1" i="0" u="none" strike="noStrike">
+                        <a:rPr lang="en-US" sz="2000" b="1" i="0" u="none" strike="noStrike" dirty="0">
                           <a:solidFill>
                             <a:srgbClr val="FFFFFF"/>
                           </a:solidFill>
@@ -7038,7 +7015,7 @@
                         </a:rPr>
                         <a:t>DCFastQC</a:t>
                       </a:r>
-                      <a:endParaRPr lang="en-US" sz="2300" b="0" i="0" u="none" strike="noStrike">
+                      <a:endParaRPr lang="en-US" sz="2300" b="0" i="0" u="none" strike="noStrike" dirty="0">
                         <a:effectLst/>
                         <a:latin typeface="Arial" panose="020B0604020202020204" pitchFamily="34" charset="0"/>
                       </a:endParaRPr>
@@ -7137,7 +7114,7 @@
                         <a:buNone/>
                       </a:pPr>
                       <a:r>
-                        <a:rPr lang="en-US" sz="2000" b="1" i="0" u="none" strike="noStrike">
+                        <a:rPr lang="en-US" sz="2000" b="1" i="0" u="none" strike="noStrike" dirty="0">
                           <a:solidFill>
                             <a:srgbClr val="FFFFFF"/>
                           </a:solidFill>
@@ -7146,7 +7123,7 @@
                         </a:rPr>
                         <a:t>cu-QC</a:t>
                       </a:r>
-                      <a:endParaRPr lang="en-US" sz="2300" b="0" i="0" u="none" strike="noStrike">
+                      <a:endParaRPr lang="en-US" sz="2300" b="0" i="0" u="none" strike="noStrike" dirty="0">
                         <a:effectLst/>
                         <a:latin typeface="Arial" panose="020B0604020202020204" pitchFamily="34" charset="0"/>
                       </a:endParaRPr>
@@ -7191,7 +7168,7 @@
                         <a:buNone/>
                       </a:pPr>
                       <a:r>
-                        <a:rPr lang="en-US" sz="2000" b="1" i="0" u="none" strike="noStrike">
+                        <a:rPr lang="en-US" sz="2000" b="1" i="0" u="none" strike="noStrike" dirty="0">
                           <a:solidFill>
                             <a:srgbClr val="FFFFFF"/>
                           </a:solidFill>
@@ -7200,7 +7177,7 @@
                         </a:rPr>
                         <a:t>#{cu-QC} </a:t>
                       </a:r>
-                      <a:endParaRPr lang="en-US" sz="2300" b="0" i="0" u="none" strike="noStrike">
+                      <a:endParaRPr lang="en-US" sz="2300" b="0" i="0" u="none" strike="noStrike" dirty="0">
                         <a:effectLst/>
                         <a:latin typeface="Arial" panose="020B0604020202020204" pitchFamily="34" charset="0"/>
                       </a:endParaRPr>
@@ -7258,7 +7235,7 @@
                         <a:buNone/>
                       </a:pPr>
                       <a:r>
-                        <a:rPr lang="en-US" sz="2000" b="0" i="0" u="none" strike="noStrike">
+                        <a:rPr lang="en-US" sz="2000" b="0" i="0" u="none" strike="noStrike" dirty="0">
                           <a:solidFill>
                             <a:srgbClr val="000000"/>
                           </a:solidFill>
@@ -7267,7 +7244,7 @@
                         </a:rPr>
                         <a:t>ca-GrQc</a:t>
                       </a:r>
-                      <a:endParaRPr lang="en-US" sz="2300" b="0" i="0" u="none" strike="noStrike">
+                      <a:endParaRPr lang="en-US" sz="2300" b="0" i="0" u="none" strike="noStrike" dirty="0">
                         <a:effectLst/>
                         <a:latin typeface="Arial" panose="020B0604020202020204" pitchFamily="34" charset="0"/>
                       </a:endParaRPr>
@@ -7316,7 +7293,7 @@
                         <a:buNone/>
                       </a:pPr>
                       <a:r>
-                        <a:rPr lang="en-US" sz="1500" b="0" i="0" u="none" strike="noStrike">
+                        <a:rPr lang="en-US" sz="1500" b="0" i="0" u="none" strike="noStrike" dirty="0">
                           <a:solidFill>
                             <a:srgbClr val="000000"/>
                           </a:solidFill>
@@ -7325,7 +7302,7 @@
                         </a:rPr>
                         <a:t>                   26,198 </a:t>
                       </a:r>
-                      <a:endParaRPr lang="en-US" sz="2300" b="0" i="0" u="none" strike="noStrike">
+                      <a:endParaRPr lang="en-US" sz="2300" b="0" i="0" u="none" strike="noStrike" dirty="0">
                         <a:effectLst/>
                         <a:latin typeface="Arial" panose="020B0604020202020204" pitchFamily="34" charset="0"/>
                       </a:endParaRPr>
@@ -7368,7 +7345,7 @@
                         <a:buNone/>
                       </a:pPr>
                       <a:r>
-                        <a:rPr lang="en-US" sz="1800" b="0" i="0" u="none" strike="noStrike">
+                        <a:rPr lang="en-US" sz="1800" b="0" i="0" u="none" strike="noStrike" dirty="0">
                           <a:solidFill>
                             <a:srgbClr val="000000"/>
                           </a:solidFill>
@@ -7377,7 +7354,7 @@
                         </a:rPr>
                         <a:t>14,490</a:t>
                       </a:r>
-                      <a:endParaRPr lang="en-US" sz="2300" b="0" i="0" u="none" strike="noStrike">
+                      <a:endParaRPr lang="en-US" sz="2300" b="0" i="0" u="none" strike="noStrike" dirty="0">
                         <a:effectLst/>
                         <a:latin typeface="Arial" panose="020B0604020202020204" pitchFamily="34" charset="0"/>
                       </a:endParaRPr>
@@ -7420,7 +7397,7 @@
                         <a:buNone/>
                       </a:pPr>
                       <a:r>
-                        <a:rPr lang="en-US" sz="1800" b="0" i="0" u="none" strike="noStrike">
+                        <a:rPr lang="en-US" sz="1800" b="0" i="0" u="none" strike="noStrike" dirty="0">
                           <a:solidFill>
                             <a:srgbClr val="000000"/>
                           </a:solidFill>
@@ -7429,7 +7406,7 @@
                         </a:rPr>
                         <a:t>10</a:t>
                       </a:r>
-                      <a:endParaRPr lang="en-US" sz="2300" b="0" i="0" u="none" strike="noStrike">
+                      <a:endParaRPr lang="en-US" sz="2300" b="0" i="0" u="none" strike="noStrike" dirty="0">
                         <a:effectLst/>
                         <a:latin typeface="Arial" panose="020B0604020202020204" pitchFamily="34" charset="0"/>
                       </a:endParaRPr>
@@ -7472,7 +7449,7 @@
                         <a:buNone/>
                       </a:pPr>
                       <a:r>
-                        <a:rPr lang="en-US" sz="1800" b="0" i="0" u="none" strike="noStrike">
+                        <a:rPr lang="en-US" sz="1800" b="0" i="0" u="none" strike="noStrike" dirty="0">
                           <a:solidFill>
                             <a:srgbClr val="000000"/>
                           </a:solidFill>
@@ -7481,7 +7458,7 @@
                         </a:rPr>
                         <a:t>0.9</a:t>
                       </a:r>
-                      <a:endParaRPr lang="en-US" sz="2300" b="0" i="0" u="none" strike="noStrike">
+                      <a:endParaRPr lang="en-US" sz="2300" b="0" i="0" u="none" strike="noStrike" dirty="0">
                         <a:effectLst/>
                         <a:latin typeface="Arial" panose="020B0604020202020204" pitchFamily="34" charset="0"/>
                       </a:endParaRPr>
@@ -7628,7 +7605,7 @@
                         <a:buNone/>
                       </a:pPr>
                       <a:r>
-                        <a:rPr lang="en-US" sz="2300" b="0" i="0" u="none" strike="noStrike">
+                        <a:rPr lang="en-US" sz="2300" b="0" i="0" u="none" strike="noStrike" dirty="0">
                           <a:solidFill>
                             <a:srgbClr val="000000"/>
                           </a:solidFill>
@@ -7637,7 +7614,7 @@
                         </a:rPr>
                         <a:t>0.1</a:t>
                       </a:r>
-                      <a:endParaRPr lang="en-US" sz="2300" b="0" i="0" u="none" strike="noStrike">
+                      <a:endParaRPr lang="en-US" sz="2300" b="0" i="0" u="none" strike="noStrike" dirty="0">
                         <a:effectLst/>
                         <a:latin typeface="Arial" panose="020B0604020202020204" pitchFamily="34" charset="0"/>
                       </a:endParaRPr>
@@ -7849,7 +7826,7 @@
                         <a:buNone/>
                       </a:pPr>
                       <a:r>
-                        <a:rPr lang="en-US" sz="2000" b="0" i="0" u="none" strike="noStrike">
+                        <a:rPr lang="en-US" sz="2000" b="0" i="0" u="none" strike="noStrike" dirty="0">
                           <a:solidFill>
                             <a:srgbClr val="000000"/>
                           </a:solidFill>
@@ -7858,7 +7835,7 @@
                         </a:rPr>
                         <a:t>condmat-dimacs</a:t>
                       </a:r>
-                      <a:endParaRPr lang="en-US" sz="2300" b="0" i="0" u="none" strike="noStrike">
+                      <a:endParaRPr lang="en-US" sz="2300" b="0" i="0" u="none" strike="noStrike" dirty="0">
                         <a:effectLst/>
                         <a:latin typeface="Arial" panose="020B0604020202020204" pitchFamily="34" charset="0"/>
                       </a:endParaRPr>
@@ -7907,7 +7884,7 @@
                         <a:buNone/>
                       </a:pPr>
                       <a:r>
-                        <a:rPr lang="en-US" sz="1500" b="0" i="0" u="none" strike="noStrike">
+                        <a:rPr lang="en-US" sz="1500" b="0" i="0" u="none" strike="noStrike" dirty="0">
                           <a:solidFill>
                             <a:srgbClr val="000000"/>
                           </a:solidFill>
@@ -7916,7 +7893,7 @@
                         </a:rPr>
                         <a:t>                   39,577 </a:t>
                       </a:r>
-                      <a:endParaRPr lang="en-US" sz="2300" b="0" i="0" u="none" strike="noStrike">
+                      <a:endParaRPr lang="en-US" sz="2300" b="0" i="0" u="none" strike="noStrike" dirty="0">
                         <a:effectLst/>
                         <a:latin typeface="Arial" panose="020B0604020202020204" pitchFamily="34" charset="0"/>
                       </a:endParaRPr>
@@ -7959,7 +7936,7 @@
                         <a:buNone/>
                       </a:pPr>
                       <a:r>
-                        <a:rPr lang="en-US" sz="1800" b="0" i="0" u="none" strike="noStrike">
+                        <a:rPr lang="en-US" sz="1800" b="0" i="0" u="none" strike="noStrike" dirty="0">
                           <a:solidFill>
                             <a:srgbClr val="000000"/>
                           </a:solidFill>
@@ -7968,7 +7945,7 @@
                         </a:rPr>
                         <a:t>175,691</a:t>
                       </a:r>
-                      <a:endParaRPr lang="en-US" sz="2300" b="0" i="0" u="none" strike="noStrike">
+                      <a:endParaRPr lang="en-US" sz="2300" b="0" i="0" u="none" strike="noStrike" dirty="0">
                         <a:effectLst/>
                         <a:latin typeface="Arial" panose="020B0604020202020204" pitchFamily="34" charset="0"/>
                       </a:endParaRPr>
@@ -8011,7 +7988,7 @@
                         <a:buNone/>
                       </a:pPr>
                       <a:r>
-                        <a:rPr lang="en-US" sz="1800" b="0" i="0" u="none" strike="noStrike">
+                        <a:rPr lang="en-US" sz="1800" b="0" i="0" u="none" strike="noStrike" dirty="0">
                           <a:solidFill>
                             <a:srgbClr val="000000"/>
                           </a:solidFill>
@@ -8020,7 +7997,7 @@
                         </a:rPr>
                         <a:t>10</a:t>
                       </a:r>
-                      <a:endParaRPr lang="en-US" sz="2300" b="0" i="0" u="none" strike="noStrike">
+                      <a:endParaRPr lang="en-US" sz="2300" b="0" i="0" u="none" strike="noStrike" dirty="0">
                         <a:effectLst/>
                         <a:latin typeface="Arial" panose="020B0604020202020204" pitchFamily="34" charset="0"/>
                       </a:endParaRPr>
@@ -8063,7 +8040,7 @@
                         <a:buNone/>
                       </a:pPr>
                       <a:r>
-                        <a:rPr lang="en-US" sz="1800" b="0" i="0" u="none" strike="noStrike">
+                        <a:rPr lang="en-US" sz="1800" b="0" i="0" u="none" strike="noStrike" dirty="0">
                           <a:solidFill>
                             <a:srgbClr val="000000"/>
                           </a:solidFill>
@@ -8072,7 +8049,7 @@
                         </a:rPr>
                         <a:t>0.9</a:t>
                       </a:r>
-                      <a:endParaRPr lang="en-US" sz="2300" b="0" i="0" u="none" strike="noStrike">
+                      <a:endParaRPr lang="en-US" sz="2300" b="0" i="0" u="none" strike="noStrike" dirty="0">
                         <a:effectLst/>
                         <a:latin typeface="Arial" panose="020B0604020202020204" pitchFamily="34" charset="0"/>
                       </a:endParaRPr>
@@ -8219,7 +8196,7 @@
                         <a:buNone/>
                       </a:pPr>
                       <a:r>
-                        <a:rPr lang="en-US" sz="2300" b="0" i="0" u="none" strike="noStrike">
+                        <a:rPr lang="en-US" sz="2300" b="0" i="0" u="none" strike="noStrike" dirty="0">
                           <a:solidFill>
                             <a:srgbClr val="000000"/>
                           </a:solidFill>
@@ -8228,7 +8205,7 @@
                         </a:rPr>
                         <a:t>0.2</a:t>
                       </a:r>
-                      <a:endParaRPr lang="en-US" sz="2300" b="0" i="0" u="none" strike="noStrike">
+                      <a:endParaRPr lang="en-US" sz="2300" b="0" i="0" u="none" strike="noStrike" dirty="0">
                         <a:effectLst/>
                         <a:latin typeface="Arial" panose="020B0604020202020204" pitchFamily="34" charset="0"/>
                       </a:endParaRPr>
@@ -8440,7 +8417,7 @@
                         <a:buNone/>
                       </a:pPr>
                       <a:r>
-                        <a:rPr lang="en-US" sz="2000" b="0" i="0" u="none" strike="noStrike">
+                        <a:rPr lang="en-US" sz="2000" b="0" i="0" u="none" strike="noStrike" dirty="0">
                           <a:solidFill>
                             <a:srgbClr val="000000"/>
                           </a:solidFill>
@@ -8449,7 +8426,7 @@
                         </a:rPr>
                         <a:t>condmat</a:t>
                       </a:r>
-                      <a:endParaRPr lang="en-US" sz="2300" b="0" i="0" u="none" strike="noStrike">
+                      <a:endParaRPr lang="en-US" sz="2300" b="0" i="0" u="none" strike="noStrike" dirty="0">
                         <a:effectLst/>
                         <a:latin typeface="Arial" panose="020B0604020202020204" pitchFamily="34" charset="0"/>
                       </a:endParaRPr>
@@ -8498,7 +8475,7 @@
                         <a:buNone/>
                       </a:pPr>
                       <a:r>
-                        <a:rPr lang="en-US" sz="1500" b="0" i="0" u="none" strike="noStrike">
+                        <a:rPr lang="en-US" sz="1500" b="0" i="0" u="none" strike="noStrike" dirty="0">
                           <a:solidFill>
                             <a:srgbClr val="000000"/>
                           </a:solidFill>
@@ -8507,7 +8484,7 @@
                         </a:rPr>
                         <a:t>                108,301 </a:t>
                       </a:r>
-                      <a:endParaRPr lang="en-US" sz="2300" b="0" i="0" u="none" strike="noStrike">
+                      <a:endParaRPr lang="en-US" sz="2300" b="0" i="0" u="none" strike="noStrike" dirty="0">
                         <a:effectLst/>
                         <a:latin typeface="Arial" panose="020B0604020202020204" pitchFamily="34" charset="0"/>
                       </a:endParaRPr>
@@ -8550,7 +8527,7 @@
                         <a:buNone/>
                       </a:pPr>
                       <a:r>
-                        <a:rPr lang="en-US" sz="1800" b="0" i="0" u="none" strike="noStrike">
+                        <a:rPr lang="en-US" sz="1800" b="0" i="0" u="none" strike="noStrike" dirty="0">
                           <a:solidFill>
                             <a:srgbClr val="000000"/>
                           </a:solidFill>
@@ -8559,7 +8536,7 @@
                         </a:rPr>
                         <a:t>93,468</a:t>
                       </a:r>
-                      <a:endParaRPr lang="en-US" sz="2300" b="0" i="0" u="none" strike="noStrike">
+                      <a:endParaRPr lang="en-US" sz="2300" b="0" i="0" u="none" strike="noStrike" dirty="0">
                         <a:effectLst/>
                         <a:latin typeface="Arial" panose="020B0604020202020204" pitchFamily="34" charset="0"/>
                       </a:endParaRPr>
@@ -8602,7 +8579,7 @@
                         <a:buNone/>
                       </a:pPr>
                       <a:r>
-                        <a:rPr lang="en-US" sz="1800" b="0" i="0" u="none" strike="noStrike">
+                        <a:rPr lang="en-US" sz="1800" b="0" i="0" u="none" strike="noStrike" dirty="0">
                           <a:solidFill>
                             <a:srgbClr val="000000"/>
                           </a:solidFill>
@@ -8611,7 +8588,7 @@
                         </a:rPr>
                         <a:t>15</a:t>
                       </a:r>
-                      <a:endParaRPr lang="en-US" sz="2300" b="0" i="0" u="none" strike="noStrike">
+                      <a:endParaRPr lang="en-US" sz="2300" b="0" i="0" u="none" strike="noStrike" dirty="0">
                         <a:effectLst/>
                         <a:latin typeface="Arial" panose="020B0604020202020204" pitchFamily="34" charset="0"/>
                       </a:endParaRPr>
@@ -8654,7 +8631,7 @@
                         <a:buNone/>
                       </a:pPr>
                       <a:r>
-                        <a:rPr lang="en-US" sz="1800" b="0" i="0" u="none" strike="noStrike">
+                        <a:rPr lang="en-US" sz="1800" b="0" i="0" u="none" strike="noStrike" dirty="0">
                           <a:solidFill>
                             <a:srgbClr val="000000"/>
                           </a:solidFill>
@@ -8663,7 +8640,7 @@
                         </a:rPr>
                         <a:t>0.8</a:t>
                       </a:r>
-                      <a:endParaRPr lang="en-US" sz="2300" b="0" i="0" u="none" strike="noStrike">
+                      <a:endParaRPr lang="en-US" sz="2300" b="0" i="0" u="none" strike="noStrike" dirty="0">
                         <a:effectLst/>
                         <a:latin typeface="Arial" panose="020B0604020202020204" pitchFamily="34" charset="0"/>
                       </a:endParaRPr>
@@ -8810,7 +8787,7 @@
                         <a:buNone/>
                       </a:pPr>
                       <a:r>
-                        <a:rPr lang="en-US" sz="2300" b="0" i="0" u="none" strike="noStrike">
+                        <a:rPr lang="en-US" sz="2300" b="0" i="0" u="none" strike="noStrike" dirty="0">
                           <a:solidFill>
                             <a:srgbClr val="000000"/>
                           </a:solidFill>
@@ -8819,7 +8796,7 @@
                         </a:rPr>
                         <a:t>0.1</a:t>
                       </a:r>
-                      <a:endParaRPr lang="en-US" sz="2300" b="0" i="0" u="none" strike="noStrike">
+                      <a:endParaRPr lang="en-US" sz="2300" b="0" i="0" u="none" strike="noStrike" dirty="0">
                         <a:effectLst/>
                         <a:latin typeface="Arial" panose="020B0604020202020204" pitchFamily="34" charset="0"/>
                       </a:endParaRPr>
@@ -9031,7 +9008,7 @@
                         <a:buNone/>
                       </a:pPr>
                       <a:r>
-                        <a:rPr lang="en-US" sz="2000" b="0" i="0" u="none" strike="noStrike">
+                        <a:rPr lang="en-US" sz="2000" b="0" i="0" u="none" strike="noStrike" dirty="0">
                           <a:solidFill>
                             <a:srgbClr val="000000"/>
                           </a:solidFill>
@@ -9040,7 +9017,7 @@
                         </a:rPr>
                         <a:t>enron</a:t>
                       </a:r>
-                      <a:endParaRPr lang="en-US" sz="2300" b="0" i="0" u="none" strike="noStrike">
+                      <a:endParaRPr lang="en-US" sz="2300" b="0" i="0" u="none" strike="noStrike" dirty="0">
                         <a:effectLst/>
                         <a:latin typeface="Arial" panose="020B0604020202020204" pitchFamily="34" charset="0"/>
                       </a:endParaRPr>
@@ -9089,7 +9066,7 @@
                         <a:buNone/>
                       </a:pPr>
                       <a:r>
-                        <a:rPr lang="en-US" sz="1500" b="0" i="0" u="none" strike="noStrike">
+                        <a:rPr lang="en-US" sz="1500" b="0" i="0" u="none" strike="noStrike" dirty="0">
                           <a:solidFill>
                             <a:srgbClr val="000000"/>
                           </a:solidFill>
@@ -9098,7 +9075,7 @@
                         </a:rPr>
                         <a:t>                   36,692 </a:t>
                       </a:r>
-                      <a:endParaRPr lang="en-US" sz="2300" b="0" i="0" u="none" strike="noStrike">
+                      <a:endParaRPr lang="en-US" sz="2300" b="0" i="0" u="none" strike="noStrike" dirty="0">
                         <a:effectLst/>
                         <a:latin typeface="Arial" panose="020B0604020202020204" pitchFamily="34" charset="0"/>
                       </a:endParaRPr>
@@ -9141,7 +9118,7 @@
                         <a:buNone/>
                       </a:pPr>
                       <a:r>
-                        <a:rPr lang="en-US" sz="1800" b="0" i="0" u="none" strike="noStrike">
+                        <a:rPr lang="en-US" sz="1800" b="0" i="0" u="none" strike="noStrike" dirty="0">
                           <a:solidFill>
                             <a:srgbClr val="000000"/>
                           </a:solidFill>
@@ -9150,7 +9127,7 @@
                         </a:rPr>
                         <a:t>183,831</a:t>
                       </a:r>
-                      <a:endParaRPr lang="en-US" sz="2300" b="0" i="0" u="none" strike="noStrike">
+                      <a:endParaRPr lang="en-US" sz="2300" b="0" i="0" u="none" strike="noStrike" dirty="0">
                         <a:effectLst/>
                         <a:latin typeface="Arial" panose="020B0604020202020204" pitchFamily="34" charset="0"/>
                       </a:endParaRPr>
@@ -9193,7 +9170,7 @@
                         <a:buNone/>
                       </a:pPr>
                       <a:r>
-                        <a:rPr lang="en-US" sz="1800" b="0" i="0" u="none" strike="noStrike">
+                        <a:rPr lang="en-US" sz="1800" b="0" i="0" u="none" strike="noStrike" dirty="0">
                           <a:solidFill>
                             <a:srgbClr val="000000"/>
                           </a:solidFill>
@@ -9202,7 +9179,7 @@
                         </a:rPr>
                         <a:t>23</a:t>
                       </a:r>
-                      <a:endParaRPr lang="en-US" sz="2300" b="0" i="0" u="none" strike="noStrike">
+                      <a:endParaRPr lang="en-US" sz="2300" b="0" i="0" u="none" strike="noStrike" dirty="0">
                         <a:effectLst/>
                         <a:latin typeface="Arial" panose="020B0604020202020204" pitchFamily="34" charset="0"/>
                       </a:endParaRPr>
@@ -9245,7 +9222,7 @@
                         <a:buNone/>
                       </a:pPr>
                       <a:r>
-                        <a:rPr lang="en-US" sz="1800" b="0" i="0" u="none" strike="noStrike">
+                        <a:rPr lang="en-US" sz="1800" b="0" i="0" u="none" strike="noStrike" dirty="0">
                           <a:solidFill>
                             <a:srgbClr val="000000"/>
                           </a:solidFill>
@@ -9254,7 +9231,7 @@
                         </a:rPr>
                         <a:t>0.9</a:t>
                       </a:r>
-                      <a:endParaRPr lang="en-US" sz="2300" b="0" i="0" u="none" strike="noStrike">
+                      <a:endParaRPr lang="en-US" sz="2300" b="0" i="0" u="none" strike="noStrike" dirty="0">
                         <a:effectLst/>
                         <a:latin typeface="Arial" panose="020B0604020202020204" pitchFamily="34" charset="0"/>
                       </a:endParaRPr>
@@ -9401,7 +9378,7 @@
                         <a:buNone/>
                       </a:pPr>
                       <a:r>
-                        <a:rPr lang="en-US" sz="2300" b="0" i="0" u="none" strike="noStrike">
+                        <a:rPr lang="en-US" sz="2300" b="0" i="0" u="none" strike="noStrike" dirty="0">
                           <a:solidFill>
                             <a:srgbClr val="000000"/>
                           </a:solidFill>
@@ -9410,7 +9387,7 @@
                         </a:rPr>
                         <a:t>12.8</a:t>
                       </a:r>
-                      <a:endParaRPr lang="en-US" sz="2300" b="0" i="0" u="none" strike="noStrike">
+                      <a:endParaRPr lang="en-US" sz="2300" b="0" i="0" u="none" strike="noStrike" dirty="0">
                         <a:effectLst/>
                         <a:latin typeface="Arial" panose="020B0604020202020204" pitchFamily="34" charset="0"/>
                       </a:endParaRPr>
@@ -9622,7 +9599,7 @@
                         <a:buNone/>
                       </a:pPr>
                       <a:r>
-                        <a:rPr lang="en-US" sz="2000" b="0" i="0" u="none" strike="noStrike">
+                        <a:rPr lang="en-US" sz="2000" b="0" i="0" u="none" strike="noStrike" dirty="0">
                           <a:solidFill>
                             <a:srgbClr val="000000"/>
                           </a:solidFill>
@@ -9631,7 +9608,7 @@
                         </a:rPr>
                         <a:t>facebook</a:t>
                       </a:r>
-                      <a:endParaRPr lang="en-US" sz="2300" b="0" i="0" u="none" strike="noStrike">
+                      <a:endParaRPr lang="en-US" sz="2300" b="0" i="0" u="none" strike="noStrike" dirty="0">
                         <a:effectLst/>
                         <a:latin typeface="Arial" panose="020B0604020202020204" pitchFamily="34" charset="0"/>
                       </a:endParaRPr>
@@ -9680,7 +9657,7 @@
                         <a:buNone/>
                       </a:pPr>
                       <a:r>
-                        <a:rPr lang="en-US" sz="1500" b="0" i="0" u="none" strike="noStrike">
+                        <a:rPr lang="en-US" sz="1500" b="0" i="0" u="none" strike="noStrike" dirty="0">
                           <a:solidFill>
                             <a:srgbClr val="000000"/>
                           </a:solidFill>
@@ -9689,7 +9666,7 @@
                         </a:rPr>
                         <a:t>                      4,039 </a:t>
                       </a:r>
-                      <a:endParaRPr lang="en-US" sz="2300" b="0" i="0" u="none" strike="noStrike">
+                      <a:endParaRPr lang="en-US" sz="2300" b="0" i="0" u="none" strike="noStrike" dirty="0">
                         <a:effectLst/>
                         <a:latin typeface="Arial" panose="020B0604020202020204" pitchFamily="34" charset="0"/>
                       </a:endParaRPr>
@@ -9732,7 +9709,7 @@
                         <a:buNone/>
                       </a:pPr>
                       <a:r>
-                        <a:rPr lang="en-US" sz="1800" b="0" i="0" u="none" strike="noStrike">
+                        <a:rPr lang="en-US" sz="1800" b="0" i="0" u="none" strike="noStrike" dirty="0">
                           <a:solidFill>
                             <a:srgbClr val="000000"/>
                           </a:solidFill>
@@ -9741,7 +9718,7 @@
                         </a:rPr>
                         <a:t>88,234</a:t>
                       </a:r>
-                      <a:endParaRPr lang="en-US" sz="2300" b="0" i="0" u="none" strike="noStrike">
+                      <a:endParaRPr lang="en-US" sz="2300" b="0" i="0" u="none" strike="noStrike" dirty="0">
                         <a:effectLst/>
                         <a:latin typeface="Arial" panose="020B0604020202020204" pitchFamily="34" charset="0"/>
                       </a:endParaRPr>
@@ -9784,7 +9761,7 @@
                         <a:buNone/>
                       </a:pPr>
                       <a:r>
-                        <a:rPr lang="en-US" sz="1800" b="0" i="0" u="none" strike="noStrike">
+                        <a:rPr lang="en-US" sz="1800" b="0" i="0" u="none" strike="noStrike" dirty="0">
                           <a:solidFill>
                             <a:srgbClr val="000000"/>
                           </a:solidFill>
@@ -9793,7 +9770,7 @@
                         </a:rPr>
                         <a:t>103</a:t>
                       </a:r>
-                      <a:endParaRPr lang="en-US" sz="2300" b="0" i="0" u="none" strike="noStrike">
+                      <a:endParaRPr lang="en-US" sz="2300" b="0" i="0" u="none" strike="noStrike" dirty="0">
                         <a:effectLst/>
                         <a:latin typeface="Arial" panose="020B0604020202020204" pitchFamily="34" charset="0"/>
                       </a:endParaRPr>
@@ -9836,7 +9813,7 @@
                         <a:buNone/>
                       </a:pPr>
                       <a:r>
-                        <a:rPr lang="en-US" sz="1800" b="0" i="0" u="none" strike="noStrike">
+                        <a:rPr lang="en-US" sz="1800" b="0" i="0" u="none" strike="noStrike" dirty="0">
                           <a:solidFill>
                             <a:srgbClr val="000000"/>
                           </a:solidFill>
@@ -9845,7 +9822,7 @@
                         </a:rPr>
                         <a:t>0.95</a:t>
                       </a:r>
-                      <a:endParaRPr lang="en-US" sz="2300" b="0" i="0" u="none" strike="noStrike">
+                      <a:endParaRPr lang="en-US" sz="2300" b="0" i="0" u="none" strike="noStrike" dirty="0">
                         <a:effectLst/>
                         <a:latin typeface="Arial" panose="020B0604020202020204" pitchFamily="34" charset="0"/>
                       </a:endParaRPr>
@@ -9992,7 +9969,7 @@
                         <a:buNone/>
                       </a:pPr>
                       <a:r>
-                        <a:rPr lang="en-US" sz="2300" b="0" i="0" u="none" strike="noStrike">
+                        <a:rPr lang="en-US" sz="2300" b="0" i="0" u="none" strike="noStrike" dirty="0">
                           <a:solidFill>
                             <a:srgbClr val="000000"/>
                           </a:solidFill>
@@ -10001,7 +9978,7 @@
                         </a:rPr>
                         <a:t>282.9</a:t>
                       </a:r>
-                      <a:endParaRPr lang="en-US" sz="2300" b="0" i="0" u="none" strike="noStrike">
+                      <a:endParaRPr lang="en-US" sz="2300" b="0" i="0" u="none" strike="noStrike" dirty="0">
                         <a:effectLst/>
                         <a:latin typeface="Arial" panose="020B0604020202020204" pitchFamily="34" charset="0"/>
                       </a:endParaRPr>
@@ -10291,15 +10268,7 @@
             </a:pPr>
             <a:r>
               <a:rPr lang="en-US" dirty="0"/>
-              <a:t>Earlier CPU workers takes fixed number of tasks/vertices (</a:t>
-            </a:r>
-            <a:r>
-              <a:rPr lang="en-US" dirty="0" err="1"/>
-              <a:t>cpuchunk</a:t>
-            </a:r>
-            <a:r>
-              <a:rPr lang="en-US" dirty="0"/>
-              <a:t>)</a:t>
+              <a:t>Earlier CPU workers takes fixed number of tasks/vertices (cpuchunk)</a:t>
             </a:r>
           </a:p>
           <a:p>
@@ -10329,15 +10298,7 @@
             </a:pPr>
             <a:r>
               <a:rPr lang="en-US" dirty="0"/>
-              <a:t>min(#tasks / #workers, </a:t>
-            </a:r>
-            <a:r>
-              <a:rPr lang="en-US" dirty="0" err="1"/>
-              <a:t>cpuchunk</a:t>
-            </a:r>
-            <a:r>
-              <a:rPr lang="en-US" dirty="0"/>
-              <a:t>)</a:t>
+              <a:t>min(#tasks / #workers, cpuchunk)</a:t>
             </a:r>
           </a:p>
         </p:txBody>
@@ -10393,7 +10354,10 @@
           <a:bodyPr/>
           <a:lstStyle/>
           <a:p>
-            <a:endParaRPr lang="en-US" dirty="0"/>
+            <a:r>
+              <a:rPr lang="en-US" dirty="0"/>
+              <a:t>Distributing Small No. of Tasks</a:t>
+            </a:r>
           </a:p>
         </p:txBody>
       </p:sp>
@@ -10413,12 +10377,26 @@
             <p:ph idx="1"/>
           </p:nvPr>
         </p:nvSpPr>
-        <p:spPr/>
+        <p:spPr>
+          <a:xfrm>
+            <a:off x="838200" y="1825625"/>
+            <a:ext cx="10515600" cy="1325563"/>
+          </a:xfrm>
+        </p:spPr>
         <p:txBody>
           <a:bodyPr/>
           <a:lstStyle/>
           <a:p>
-            <a:endParaRPr lang="en-US"/>
+            <a:r>
+              <a:rPr lang="en-US" dirty="0"/>
+              <a:t>Ideally, GPU should get large number of initial tasks</a:t>
+            </a:r>
+          </a:p>
+          <a:p>
+            <a:r>
+              <a:rPr lang="en-US" dirty="0"/>
+              <a:t>If the no. of tasks less, then divide percentage of tasks to GPU</a:t>
+            </a:r>
           </a:p>
         </p:txBody>
       </p:sp>
@@ -10426,6 +10404,639 @@
     <p:extLst>
       <p:ext uri="{BB962C8B-B14F-4D97-AF65-F5344CB8AC3E}">
         <p14:creationId xmlns:p14="http://schemas.microsoft.com/office/powerpoint/2010/main" val="2665304279"/>
+      </p:ext>
+    </p:extLst>
+  </p:cSld>
+  <p:clrMapOvr>
+    <a:masterClrMapping/>
+  </p:clrMapOvr>
+</p:sld>
+</file>
+
+<file path=ppt/slides/slide8.xml><?xml version="1.0" encoding="utf-8"?>
+<p:sld xmlns:a="http://schemas.openxmlformats.org/drawingml/2006/main" xmlns:r="http://schemas.openxmlformats.org/officeDocument/2006/relationships" xmlns:p="http://schemas.openxmlformats.org/presentationml/2006/main">
+  <p:cSld>
+    <p:spTree>
+      <p:nvGrpSpPr>
+        <p:cNvPr id="1" name=""/>
+        <p:cNvGrpSpPr/>
+        <p:nvPr/>
+      </p:nvGrpSpPr>
+      <p:grpSpPr>
+        <a:xfrm>
+          <a:off x="0" y="0"/>
+          <a:ext cx="0" cy="0"/>
+          <a:chOff x="0" y="0"/>
+          <a:chExt cx="0" cy="0"/>
+        </a:xfrm>
+      </p:grpSpPr>
+      <p:sp>
+        <p:nvSpPr>
+          <p:cNvPr id="2" name="Title 1">
+            <a:extLst>
+              <a:ext uri="{FF2B5EF4-FFF2-40B4-BE49-F238E27FC236}">
+                <a16:creationId xmlns:a16="http://schemas.microsoft.com/office/drawing/2014/main" id="{CB128F2B-E76F-40B0-7063-17E52B8EEA63}"/>
+              </a:ext>
+            </a:extLst>
+          </p:cNvPr>
+          <p:cNvSpPr>
+            <a:spLocks noGrp="1"/>
+          </p:cNvSpPr>
+          <p:nvPr>
+            <p:ph type="title"/>
+          </p:nvPr>
+        </p:nvSpPr>
+        <p:spPr/>
+        <p:txBody>
+          <a:bodyPr/>
+          <a:lstStyle/>
+          <a:p>
+            <a:r>
+              <a:rPr lang="en-US" dirty="0"/>
+              <a:t>div_factor experiments</a:t>
+            </a:r>
+          </a:p>
+        </p:txBody>
+      </p:sp>
+      <p:graphicFrame>
+        <p:nvGraphicFramePr>
+          <p:cNvPr id="4" name="Content Placeholder 3">
+            <a:extLst>
+              <a:ext uri="{FF2B5EF4-FFF2-40B4-BE49-F238E27FC236}">
+                <a16:creationId xmlns:a16="http://schemas.microsoft.com/office/drawing/2014/main" id="{A737DA67-F41C-DE21-0056-63C624630942}"/>
+              </a:ext>
+            </a:extLst>
+          </p:cNvPr>
+          <p:cNvGraphicFramePr>
+            <a:graphicFrameLocks noGrp="1"/>
+          </p:cNvGraphicFramePr>
+          <p:nvPr>
+            <p:ph idx="1"/>
+            <p:extLst>
+              <p:ext uri="{D42A27DB-BD31-4B8C-83A1-F6EECF244321}">
+                <p14:modId xmlns:p14="http://schemas.microsoft.com/office/powerpoint/2010/main" val="1211437656"/>
+              </p:ext>
+            </p:extLst>
+          </p:nvPr>
+        </p:nvGraphicFramePr>
+        <p:xfrm>
+          <a:off x="3647559" y="2502019"/>
+          <a:ext cx="3617432" cy="2251710"/>
+        </p:xfrm>
+        <a:graphic>
+          <a:graphicData uri="http://schemas.openxmlformats.org/drawingml/2006/table">
+            <a:tbl>
+              <a:tblPr>
+                <a:tableStyleId>{5C22544A-7EE6-4342-B048-85BDC9FD1C3A}</a:tableStyleId>
+              </a:tblPr>
+              <a:tblGrid>
+                <a:gridCol w="1808716">
+                  <a:extLst>
+                    <a:ext uri="{9D8B030D-6E8A-4147-A177-3AD203B41FA5}">
+                      <a16:colId xmlns:a16="http://schemas.microsoft.com/office/drawing/2014/main" val="260910380"/>
+                    </a:ext>
+                  </a:extLst>
+                </a:gridCol>
+                <a:gridCol w="1808716">
+                  <a:extLst>
+                    <a:ext uri="{9D8B030D-6E8A-4147-A177-3AD203B41FA5}">
+                      <a16:colId xmlns:a16="http://schemas.microsoft.com/office/drawing/2014/main" val="976477695"/>
+                    </a:ext>
+                  </a:extLst>
+                </a:gridCol>
+              </a:tblGrid>
+              <a:tr h="203200">
+                <a:tc>
+                  <a:txBody>
+                    <a:bodyPr/>
+                    <a:lstStyle/>
+                    <a:p>
+                      <a:pPr algn="l" fontAlgn="b">
+                        <a:buNone/>
+                      </a:pPr>
+                      <a:r>
+                        <a:rPr lang="en-US" sz="2400" b="1" i="0" u="none" strike="noStrike" dirty="0">
+                          <a:solidFill>
+                            <a:srgbClr val="000000"/>
+                          </a:solidFill>
+                          <a:effectLst/>
+                          <a:latin typeface="Consolas" panose="020B0609020204030204" pitchFamily="49" charset="0"/>
+                          <a:cs typeface="Consolas" panose="020B0609020204030204" pitchFamily="49" charset="0"/>
+                        </a:rPr>
+                        <a:t>Div_factor</a:t>
+                      </a:r>
+                    </a:p>
+                  </a:txBody>
+                  <a:tcPr marL="9525" marR="9525" marT="9525" marB="0" anchor="b"/>
+                </a:tc>
+                <a:tc>
+                  <a:txBody>
+                    <a:bodyPr/>
+                    <a:lstStyle/>
+                    <a:p>
+                      <a:pPr algn="l" fontAlgn="b">
+                        <a:buNone/>
+                      </a:pPr>
+                      <a:r>
+                        <a:rPr lang="en-US" sz="2400" b="1" i="0" u="none" strike="noStrike" dirty="0">
+                          <a:solidFill>
+                            <a:srgbClr val="000000"/>
+                          </a:solidFill>
+                          <a:effectLst/>
+                          <a:latin typeface="Consolas" panose="020B0609020204030204" pitchFamily="49" charset="0"/>
+                          <a:cs typeface="Consolas" panose="020B0609020204030204" pitchFamily="49" charset="0"/>
+                        </a:rPr>
+                        <a:t>Time(sec)</a:t>
+                      </a:r>
+                    </a:p>
+                  </a:txBody>
+                  <a:tcPr marL="9525" marR="9525" marT="9525" marB="0" anchor="b"/>
+                </a:tc>
+                <a:extLst>
+                  <a:ext uri="{0D108BD9-81ED-4DB2-BD59-A6C34878D82A}">
+                    <a16:rowId xmlns:a16="http://schemas.microsoft.com/office/drawing/2014/main" val="1296845560"/>
+                  </a:ext>
+                </a:extLst>
+              </a:tr>
+              <a:tr h="279400">
+                <a:tc>
+                  <a:txBody>
+                    <a:bodyPr/>
+                    <a:lstStyle/>
+                    <a:p>
+                      <a:pPr algn="ctr" fontAlgn="b">
+                        <a:buNone/>
+                      </a:pPr>
+                      <a:r>
+                        <a:rPr lang="en-US" sz="2400" u="none" strike="noStrike" dirty="0">
+                          <a:effectLst/>
+                          <a:latin typeface="Consolas" panose="020B0609020204030204" pitchFamily="49" charset="0"/>
+                          <a:cs typeface="Consolas" panose="020B0609020204030204" pitchFamily="49" charset="0"/>
+                        </a:rPr>
+                        <a:t>0.70</a:t>
+                      </a:r>
+                      <a:endParaRPr lang="en-US" sz="2400" b="0" i="0" u="none" strike="noStrike" dirty="0">
+                        <a:solidFill>
+                          <a:srgbClr val="000000"/>
+                        </a:solidFill>
+                        <a:effectLst/>
+                        <a:latin typeface="Consolas" panose="020B0609020204030204" pitchFamily="49" charset="0"/>
+                        <a:cs typeface="Consolas" panose="020B0609020204030204" pitchFamily="49" charset="0"/>
+                      </a:endParaRPr>
+                    </a:p>
+                  </a:txBody>
+                  <a:tcPr marL="9525" marR="9525" marT="9525" marB="0" anchor="b"/>
+                </a:tc>
+                <a:tc>
+                  <a:txBody>
+                    <a:bodyPr/>
+                    <a:lstStyle/>
+                    <a:p>
+                      <a:pPr algn="ctr" fontAlgn="b">
+                        <a:buNone/>
+                      </a:pPr>
+                      <a:r>
+                        <a:rPr lang="en-US" sz="2400" u="none" strike="noStrike" dirty="0">
+                          <a:effectLst/>
+                          <a:latin typeface="Consolas" panose="020B0609020204030204" pitchFamily="49" charset="0"/>
+                          <a:cs typeface="Consolas" panose="020B0609020204030204" pitchFamily="49" charset="0"/>
+                        </a:rPr>
+                        <a:t>37.57</a:t>
+                      </a:r>
+                      <a:endParaRPr lang="en-US" sz="2400" b="0" i="0" u="none" strike="noStrike" dirty="0">
+                        <a:solidFill>
+                          <a:srgbClr val="000000"/>
+                        </a:solidFill>
+                        <a:effectLst/>
+                        <a:latin typeface="Consolas" panose="020B0609020204030204" pitchFamily="49" charset="0"/>
+                        <a:cs typeface="Consolas" panose="020B0609020204030204" pitchFamily="49" charset="0"/>
+                      </a:endParaRPr>
+                    </a:p>
+                  </a:txBody>
+                  <a:tcPr marL="9525" marR="9525" marT="9525" marB="0" anchor="b"/>
+                </a:tc>
+                <a:extLst>
+                  <a:ext uri="{0D108BD9-81ED-4DB2-BD59-A6C34878D82A}">
+                    <a16:rowId xmlns:a16="http://schemas.microsoft.com/office/drawing/2014/main" val="1568733737"/>
+                  </a:ext>
+                </a:extLst>
+              </a:tr>
+              <a:tr h="279400">
+                <a:tc>
+                  <a:txBody>
+                    <a:bodyPr/>
+                    <a:lstStyle/>
+                    <a:p>
+                      <a:pPr algn="ctr" fontAlgn="b">
+                        <a:buNone/>
+                      </a:pPr>
+                      <a:r>
+                        <a:rPr lang="en-US" sz="2400" u="none" strike="noStrike" dirty="0">
+                          <a:effectLst/>
+                          <a:latin typeface="Consolas" panose="020B0609020204030204" pitchFamily="49" charset="0"/>
+                          <a:cs typeface="Consolas" panose="020B0609020204030204" pitchFamily="49" charset="0"/>
+                        </a:rPr>
+                        <a:t>0.80</a:t>
+                      </a:r>
+                      <a:endParaRPr lang="en-US" sz="2400" b="0" i="0" u="none" strike="noStrike" dirty="0">
+                        <a:solidFill>
+                          <a:srgbClr val="000000"/>
+                        </a:solidFill>
+                        <a:effectLst/>
+                        <a:latin typeface="Consolas" panose="020B0609020204030204" pitchFamily="49" charset="0"/>
+                        <a:cs typeface="Consolas" panose="020B0609020204030204" pitchFamily="49" charset="0"/>
+                      </a:endParaRPr>
+                    </a:p>
+                  </a:txBody>
+                  <a:tcPr marL="9525" marR="9525" marT="9525" marB="0" anchor="b"/>
+                </a:tc>
+                <a:tc>
+                  <a:txBody>
+                    <a:bodyPr/>
+                    <a:lstStyle/>
+                    <a:p>
+                      <a:pPr algn="ctr" fontAlgn="b">
+                        <a:buNone/>
+                      </a:pPr>
+                      <a:r>
+                        <a:rPr lang="en-US" sz="2400" u="none" strike="noStrike" dirty="0">
+                          <a:effectLst/>
+                          <a:latin typeface="Consolas" panose="020B0609020204030204" pitchFamily="49" charset="0"/>
+                          <a:cs typeface="Consolas" panose="020B0609020204030204" pitchFamily="49" charset="0"/>
+                        </a:rPr>
+                        <a:t>29.64</a:t>
+                      </a:r>
+                      <a:endParaRPr lang="en-US" sz="2400" b="0" i="0" u="none" strike="noStrike" dirty="0">
+                        <a:solidFill>
+                          <a:srgbClr val="000000"/>
+                        </a:solidFill>
+                        <a:effectLst/>
+                        <a:latin typeface="Consolas" panose="020B0609020204030204" pitchFamily="49" charset="0"/>
+                        <a:cs typeface="Consolas" panose="020B0609020204030204" pitchFamily="49" charset="0"/>
+                      </a:endParaRPr>
+                    </a:p>
+                  </a:txBody>
+                  <a:tcPr marL="9525" marR="9525" marT="9525" marB="0" anchor="b"/>
+                </a:tc>
+                <a:extLst>
+                  <a:ext uri="{0D108BD9-81ED-4DB2-BD59-A6C34878D82A}">
+                    <a16:rowId xmlns:a16="http://schemas.microsoft.com/office/drawing/2014/main" val="3529051196"/>
+                  </a:ext>
+                </a:extLst>
+              </a:tr>
+              <a:tr h="342900">
+                <a:tc>
+                  <a:txBody>
+                    <a:bodyPr/>
+                    <a:lstStyle/>
+                    <a:p>
+                      <a:pPr algn="ctr" fontAlgn="b">
+                        <a:buNone/>
+                      </a:pPr>
+                      <a:r>
+                        <a:rPr lang="en-US" sz="2400" u="none" strike="noStrike">
+                          <a:effectLst/>
+                          <a:latin typeface="Consolas" panose="020B0609020204030204" pitchFamily="49" charset="0"/>
+                          <a:cs typeface="Consolas" panose="020B0609020204030204" pitchFamily="49" charset="0"/>
+                        </a:rPr>
+                        <a:t>0.90</a:t>
+                      </a:r>
+                      <a:endParaRPr lang="en-US" sz="2400" b="0" i="0" u="none" strike="noStrike">
+                        <a:solidFill>
+                          <a:srgbClr val="000000"/>
+                        </a:solidFill>
+                        <a:effectLst/>
+                        <a:latin typeface="Consolas" panose="020B0609020204030204" pitchFamily="49" charset="0"/>
+                        <a:cs typeface="Consolas" panose="020B0609020204030204" pitchFamily="49" charset="0"/>
+                      </a:endParaRPr>
+                    </a:p>
+                  </a:txBody>
+                  <a:tcPr marL="9525" marR="9525" marT="9525" marB="0" anchor="b"/>
+                </a:tc>
+                <a:tc>
+                  <a:txBody>
+                    <a:bodyPr/>
+                    <a:lstStyle/>
+                    <a:p>
+                      <a:pPr algn="ctr" fontAlgn="b">
+                        <a:buNone/>
+                      </a:pPr>
+                      <a:r>
+                        <a:rPr lang="en-US" sz="2400" u="none" strike="noStrike" dirty="0">
+                          <a:effectLst/>
+                          <a:latin typeface="Consolas" panose="020B0609020204030204" pitchFamily="49" charset="0"/>
+                          <a:cs typeface="Consolas" panose="020B0609020204030204" pitchFamily="49" charset="0"/>
+                        </a:rPr>
+                        <a:t>30.75</a:t>
+                      </a:r>
+                      <a:endParaRPr lang="en-US" sz="2400" b="0" i="0" u="none" strike="noStrike" dirty="0">
+                        <a:solidFill>
+                          <a:srgbClr val="000000"/>
+                        </a:solidFill>
+                        <a:effectLst/>
+                        <a:latin typeface="Consolas" panose="020B0609020204030204" pitchFamily="49" charset="0"/>
+                        <a:cs typeface="Consolas" panose="020B0609020204030204" pitchFamily="49" charset="0"/>
+                      </a:endParaRPr>
+                    </a:p>
+                  </a:txBody>
+                  <a:tcPr marL="9525" marR="9525" marT="9525" marB="0" anchor="b"/>
+                </a:tc>
+                <a:extLst>
+                  <a:ext uri="{0D108BD9-81ED-4DB2-BD59-A6C34878D82A}">
+                    <a16:rowId xmlns:a16="http://schemas.microsoft.com/office/drawing/2014/main" val="3796176425"/>
+                  </a:ext>
+                </a:extLst>
+              </a:tr>
+              <a:tr h="292100">
+                <a:tc>
+                  <a:txBody>
+                    <a:bodyPr/>
+                    <a:lstStyle/>
+                    <a:p>
+                      <a:pPr algn="ctr" fontAlgn="b">
+                        <a:buNone/>
+                      </a:pPr>
+                      <a:r>
+                        <a:rPr lang="en-US" sz="2400" u="none" strike="noStrike">
+                          <a:effectLst/>
+                          <a:latin typeface="Consolas" panose="020B0609020204030204" pitchFamily="49" charset="0"/>
+                          <a:cs typeface="Consolas" panose="020B0609020204030204" pitchFamily="49" charset="0"/>
+                        </a:rPr>
+                        <a:t>0.95</a:t>
+                      </a:r>
+                      <a:endParaRPr lang="en-US" sz="2400" b="0" i="0" u="none" strike="noStrike">
+                        <a:solidFill>
+                          <a:srgbClr val="000000"/>
+                        </a:solidFill>
+                        <a:effectLst/>
+                        <a:latin typeface="Consolas" panose="020B0609020204030204" pitchFamily="49" charset="0"/>
+                        <a:cs typeface="Consolas" panose="020B0609020204030204" pitchFamily="49" charset="0"/>
+                      </a:endParaRPr>
+                    </a:p>
+                  </a:txBody>
+                  <a:tcPr marL="9525" marR="9525" marT="9525" marB="0" anchor="b"/>
+                </a:tc>
+                <a:tc>
+                  <a:txBody>
+                    <a:bodyPr/>
+                    <a:lstStyle/>
+                    <a:p>
+                      <a:pPr algn="ctr" fontAlgn="b">
+                        <a:buNone/>
+                      </a:pPr>
+                      <a:r>
+                        <a:rPr lang="en-US" sz="2400" u="none" strike="noStrike" dirty="0">
+                          <a:effectLst/>
+                          <a:latin typeface="Consolas" panose="020B0609020204030204" pitchFamily="49" charset="0"/>
+                          <a:cs typeface="Consolas" panose="020B0609020204030204" pitchFamily="49" charset="0"/>
+                        </a:rPr>
+                        <a:t>32.06</a:t>
+                      </a:r>
+                      <a:endParaRPr lang="en-US" sz="2400" b="0" i="0" u="none" strike="noStrike" dirty="0">
+                        <a:solidFill>
+                          <a:srgbClr val="000000"/>
+                        </a:solidFill>
+                        <a:effectLst/>
+                        <a:latin typeface="Consolas" panose="020B0609020204030204" pitchFamily="49" charset="0"/>
+                        <a:cs typeface="Consolas" panose="020B0609020204030204" pitchFamily="49" charset="0"/>
+                      </a:endParaRPr>
+                    </a:p>
+                  </a:txBody>
+                  <a:tcPr marL="9525" marR="9525" marT="9525" marB="0" anchor="b"/>
+                </a:tc>
+                <a:extLst>
+                  <a:ext uri="{0D108BD9-81ED-4DB2-BD59-A6C34878D82A}">
+                    <a16:rowId xmlns:a16="http://schemas.microsoft.com/office/drawing/2014/main" val="1825153050"/>
+                  </a:ext>
+                </a:extLst>
+              </a:tr>
+              <a:tr h="292100">
+                <a:tc>
+                  <a:txBody>
+                    <a:bodyPr/>
+                    <a:lstStyle/>
+                    <a:p>
+                      <a:pPr algn="ctr" fontAlgn="b">
+                        <a:buNone/>
+                      </a:pPr>
+                      <a:r>
+                        <a:rPr lang="en-US" sz="2400" u="none" strike="noStrike" dirty="0">
+                          <a:effectLst/>
+                          <a:latin typeface="Consolas" panose="020B0609020204030204" pitchFamily="49" charset="0"/>
+                          <a:cs typeface="Consolas" panose="020B0609020204030204" pitchFamily="49" charset="0"/>
+                        </a:rPr>
+                        <a:t>1.00</a:t>
+                      </a:r>
+                      <a:endParaRPr lang="en-US" sz="2400" b="0" i="0" u="none" strike="noStrike" dirty="0">
+                        <a:solidFill>
+                          <a:srgbClr val="000000"/>
+                        </a:solidFill>
+                        <a:effectLst/>
+                        <a:latin typeface="Consolas" panose="020B0609020204030204" pitchFamily="49" charset="0"/>
+                        <a:cs typeface="Consolas" panose="020B0609020204030204" pitchFamily="49" charset="0"/>
+                      </a:endParaRPr>
+                    </a:p>
+                  </a:txBody>
+                  <a:tcPr marL="9525" marR="9525" marT="9525" marB="0" anchor="b"/>
+                </a:tc>
+                <a:tc>
+                  <a:txBody>
+                    <a:bodyPr/>
+                    <a:lstStyle/>
+                    <a:p>
+                      <a:pPr algn="ctr" fontAlgn="b">
+                        <a:buNone/>
+                      </a:pPr>
+                      <a:r>
+                        <a:rPr lang="en-US" sz="2400" u="none" strike="noStrike" dirty="0">
+                          <a:effectLst/>
+                          <a:latin typeface="Consolas" panose="020B0609020204030204" pitchFamily="49" charset="0"/>
+                          <a:cs typeface="Consolas" panose="020B0609020204030204" pitchFamily="49" charset="0"/>
+                        </a:rPr>
+                        <a:t>101.65</a:t>
+                      </a:r>
+                      <a:endParaRPr lang="en-US" sz="2400" b="0" i="0" u="none" strike="noStrike" dirty="0">
+                        <a:solidFill>
+                          <a:srgbClr val="000000"/>
+                        </a:solidFill>
+                        <a:effectLst/>
+                        <a:latin typeface="Consolas" panose="020B0609020204030204" pitchFamily="49" charset="0"/>
+                        <a:cs typeface="Consolas" panose="020B0609020204030204" pitchFamily="49" charset="0"/>
+                      </a:endParaRPr>
+                    </a:p>
+                  </a:txBody>
+                  <a:tcPr marL="9525" marR="9525" marT="9525" marB="0" anchor="b"/>
+                </a:tc>
+                <a:extLst>
+                  <a:ext uri="{0D108BD9-81ED-4DB2-BD59-A6C34878D82A}">
+                    <a16:rowId xmlns:a16="http://schemas.microsoft.com/office/drawing/2014/main" val="1693882087"/>
+                  </a:ext>
+                </a:extLst>
+              </a:tr>
+            </a:tbl>
+          </a:graphicData>
+        </a:graphic>
+      </p:graphicFrame>
+      <p:graphicFrame>
+        <p:nvGraphicFramePr>
+          <p:cNvPr id="5" name="Table 4">
+            <a:extLst>
+              <a:ext uri="{FF2B5EF4-FFF2-40B4-BE49-F238E27FC236}">
+                <a16:creationId xmlns:a16="http://schemas.microsoft.com/office/drawing/2014/main" id="{36A0CB83-5B57-EE5C-4EF1-3551705B24F2}"/>
+              </a:ext>
+            </a:extLst>
+          </p:cNvPr>
+          <p:cNvGraphicFramePr>
+            <a:graphicFrameLocks noGrp="1"/>
+          </p:cNvGraphicFramePr>
+          <p:nvPr>
+            <p:extLst>
+              <p:ext uri="{D42A27DB-BD31-4B8C-83A1-F6EECF244321}">
+                <p14:modId xmlns:p14="http://schemas.microsoft.com/office/powerpoint/2010/main" val="2073974449"/>
+              </p:ext>
+            </p:extLst>
+          </p:nvPr>
+        </p:nvGraphicFramePr>
+        <p:xfrm>
+          <a:off x="2743201" y="1855548"/>
+          <a:ext cx="5426148" cy="375285"/>
+        </p:xfrm>
+        <a:graphic>
+          <a:graphicData uri="http://schemas.openxmlformats.org/drawingml/2006/table">
+            <a:tbl>
+              <a:tblPr>
+                <a:tableStyleId>{5C22544A-7EE6-4342-B048-85BDC9FD1C3A}</a:tableStyleId>
+              </a:tblPr>
+              <a:tblGrid>
+                <a:gridCol w="1808716">
+                  <a:extLst>
+                    <a:ext uri="{9D8B030D-6E8A-4147-A177-3AD203B41FA5}">
+                      <a16:colId xmlns:a16="http://schemas.microsoft.com/office/drawing/2014/main" val="2063601532"/>
+                    </a:ext>
+                  </a:extLst>
+                </a:gridCol>
+                <a:gridCol w="1808716">
+                  <a:extLst>
+                    <a:ext uri="{9D8B030D-6E8A-4147-A177-3AD203B41FA5}">
+                      <a16:colId xmlns:a16="http://schemas.microsoft.com/office/drawing/2014/main" val="2721509019"/>
+                    </a:ext>
+                  </a:extLst>
+                </a:gridCol>
+                <a:gridCol w="1808716">
+                  <a:extLst>
+                    <a:ext uri="{9D8B030D-6E8A-4147-A177-3AD203B41FA5}">
+                      <a16:colId xmlns:a16="http://schemas.microsoft.com/office/drawing/2014/main" val="1347420145"/>
+                    </a:ext>
+                  </a:extLst>
+                </a:gridCol>
+              </a:tblGrid>
+              <a:tr h="349749">
+                <a:tc>
+                  <a:txBody>
+                    <a:bodyPr/>
+                    <a:lstStyle/>
+                    <a:p>
+                      <a:pPr algn="l" fontAlgn="b">
+                        <a:buNone/>
+                      </a:pPr>
+                      <a:r>
+                        <a:rPr lang="en-US" sz="2400" u="none" strike="noStrike" dirty="0" err="1">
+                          <a:effectLst/>
+                          <a:latin typeface="Consolas" panose="020B0609020204030204" pitchFamily="49" charset="0"/>
+                          <a:cs typeface="Consolas" panose="020B0609020204030204" pitchFamily="49" charset="0"/>
+                        </a:rPr>
+                        <a:t>Flixster</a:t>
+                      </a:r>
+                      <a:r>
+                        <a:rPr lang="en-US" sz="2400" u="none" strike="noStrike" dirty="0">
+                          <a:effectLst/>
+                          <a:latin typeface="Consolas" panose="020B0609020204030204" pitchFamily="49" charset="0"/>
+                          <a:cs typeface="Consolas" panose="020B0609020204030204" pitchFamily="49" charset="0"/>
+                        </a:rPr>
+                        <a:t> </a:t>
+                      </a:r>
+                      <a:endParaRPr lang="en-US" sz="2400" b="0" i="0" u="none" strike="noStrike" dirty="0">
+                        <a:solidFill>
+                          <a:srgbClr val="000000"/>
+                        </a:solidFill>
+                        <a:effectLst/>
+                        <a:latin typeface="Consolas" panose="020B0609020204030204" pitchFamily="49" charset="0"/>
+                        <a:cs typeface="Consolas" panose="020B0609020204030204" pitchFamily="49" charset="0"/>
+                      </a:endParaRPr>
+                    </a:p>
+                  </a:txBody>
+                  <a:tcPr marL="9525" marR="9525" marT="9525" marB="0" anchor="b"/>
+                </a:tc>
+                <a:tc>
+                  <a:txBody>
+                    <a:bodyPr/>
+                    <a:lstStyle/>
+                    <a:p>
+                      <a:pPr algn="r" fontAlgn="b">
+                        <a:buNone/>
+                      </a:pPr>
+                      <a:r>
+                        <a:rPr lang="en-US" sz="2400" u="none" strike="noStrike" dirty="0">
+                          <a:effectLst/>
+                          <a:latin typeface="Consolas" panose="020B0609020204030204" pitchFamily="49" charset="0"/>
+                          <a:cs typeface="Consolas" panose="020B0609020204030204" pitchFamily="49" charset="0"/>
+                        </a:rPr>
+                        <a:t>k=23</a:t>
+                      </a:r>
+                      <a:endParaRPr lang="en-US" sz="2400" b="0" i="0" u="none" strike="noStrike" dirty="0">
+                        <a:solidFill>
+                          <a:srgbClr val="000000"/>
+                        </a:solidFill>
+                        <a:effectLst/>
+                        <a:latin typeface="Consolas" panose="020B0609020204030204" pitchFamily="49" charset="0"/>
+                        <a:cs typeface="Consolas" panose="020B0609020204030204" pitchFamily="49" charset="0"/>
+                      </a:endParaRPr>
+                    </a:p>
+                  </a:txBody>
+                  <a:tcPr marL="9525" marR="9525" marT="9525" marB="0" anchor="b"/>
+                </a:tc>
+                <a:tc>
+                  <a:txBody>
+                    <a:bodyPr/>
+                    <a:lstStyle/>
+                    <a:p>
+                      <a:pPr algn="r" fontAlgn="b">
+                        <a:buNone/>
+                      </a:pPr>
+                      <a:r>
+                        <a:rPr lang="en-US" sz="2400" u="none" strike="noStrike" dirty="0">
+                          <a:effectLst/>
+                          <a:latin typeface="Consolas" panose="020B0609020204030204" pitchFamily="49" charset="0"/>
+                          <a:cs typeface="Consolas" panose="020B0609020204030204" pitchFamily="49" charset="0"/>
+                        </a:rPr>
+                        <a:t>g=0.95</a:t>
+                      </a:r>
+                      <a:endParaRPr lang="en-US" sz="2400" b="0" i="0" u="none" strike="noStrike" dirty="0">
+                        <a:solidFill>
+                          <a:srgbClr val="000000"/>
+                        </a:solidFill>
+                        <a:effectLst/>
+                        <a:latin typeface="Consolas" panose="020B0609020204030204" pitchFamily="49" charset="0"/>
+                        <a:cs typeface="Consolas" panose="020B0609020204030204" pitchFamily="49" charset="0"/>
+                      </a:endParaRPr>
+                    </a:p>
+                  </a:txBody>
+                  <a:tcPr marL="9525" marR="9525" marT="9525" marB="0" anchor="b"/>
+                </a:tc>
+                <a:extLst>
+                  <a:ext uri="{0D108BD9-81ED-4DB2-BD59-A6C34878D82A}">
+                    <a16:rowId xmlns:a16="http://schemas.microsoft.com/office/drawing/2014/main" val="16801465"/>
+                  </a:ext>
+                </a:extLst>
+              </a:tr>
+            </a:tbl>
+          </a:graphicData>
+        </a:graphic>
+      </p:graphicFrame>
+    </p:spTree>
+    <p:extLst>
+      <p:ext uri="{BB962C8B-B14F-4D97-AF65-F5344CB8AC3E}">
+        <p14:creationId xmlns:p14="http://schemas.microsoft.com/office/powerpoint/2010/main" val="4063290279"/>
       </p:ext>
     </p:extLst>
   </p:cSld>

</xml_diff>

<commit_message>
auto commit 2026-05-14 00:41:35
</commit_message>
<xml_diff>
--- a/revision [Autosaved].pptx
+++ b/revision [Autosaved].pptx
@@ -13,6 +13,8 @@
     <p:sldId id="261" r:id="rId7"/>
     <p:sldId id="262" r:id="rId8"/>
     <p:sldId id="263" r:id="rId9"/>
+    <p:sldId id="264" r:id="rId10"/>
+    <p:sldId id="265" r:id="rId11"/>
   </p:sldIdLst>
   <p:sldSz cx="12192000" cy="6858000"/>
   <p:notesSz cx="6858000" cy="9144000"/>
@@ -266,7 +268,7 @@
           <a:p>
             <a:fld id="{6F584DAC-AA37-8C49-B5B6-53E9519E19BB}" type="datetimeFigureOut">
               <a:rPr lang="en-US" smtClean="0"/>
-              <a:t>5/9/26</a:t>
+              <a:t>5/10/26</a:t>
             </a:fld>
             <a:endParaRPr lang="en-US" dirty="0"/>
           </a:p>
@@ -464,7 +466,7 @@
           <a:p>
             <a:fld id="{6F584DAC-AA37-8C49-B5B6-53E9519E19BB}" type="datetimeFigureOut">
               <a:rPr lang="en-US" smtClean="0"/>
-              <a:t>5/9/26</a:t>
+              <a:t>5/10/26</a:t>
             </a:fld>
             <a:endParaRPr lang="en-US" dirty="0"/>
           </a:p>
@@ -672,7 +674,7 @@
           <a:p>
             <a:fld id="{6F584DAC-AA37-8C49-B5B6-53E9519E19BB}" type="datetimeFigureOut">
               <a:rPr lang="en-US" smtClean="0"/>
-              <a:t>5/9/26</a:t>
+              <a:t>5/10/26</a:t>
             </a:fld>
             <a:endParaRPr lang="en-US" dirty="0"/>
           </a:p>
@@ -870,7 +872,7 @@
           <a:p>
             <a:fld id="{6F584DAC-AA37-8C49-B5B6-53E9519E19BB}" type="datetimeFigureOut">
               <a:rPr lang="en-US" smtClean="0"/>
-              <a:t>5/9/26</a:t>
+              <a:t>5/10/26</a:t>
             </a:fld>
             <a:endParaRPr lang="en-US" dirty="0"/>
           </a:p>
@@ -1145,7 +1147,7 @@
           <a:p>
             <a:fld id="{6F584DAC-AA37-8C49-B5B6-53E9519E19BB}" type="datetimeFigureOut">
               <a:rPr lang="en-US" smtClean="0"/>
-              <a:t>5/9/26</a:t>
+              <a:t>5/10/26</a:t>
             </a:fld>
             <a:endParaRPr lang="en-US" dirty="0"/>
           </a:p>
@@ -1410,7 +1412,7 @@
           <a:p>
             <a:fld id="{6F584DAC-AA37-8C49-B5B6-53E9519E19BB}" type="datetimeFigureOut">
               <a:rPr lang="en-US" smtClean="0"/>
-              <a:t>5/9/26</a:t>
+              <a:t>5/10/26</a:t>
             </a:fld>
             <a:endParaRPr lang="en-US" dirty="0"/>
           </a:p>
@@ -1822,7 +1824,7 @@
           <a:p>
             <a:fld id="{6F584DAC-AA37-8C49-B5B6-53E9519E19BB}" type="datetimeFigureOut">
               <a:rPr lang="en-US" smtClean="0"/>
-              <a:t>5/9/26</a:t>
+              <a:t>5/10/26</a:t>
             </a:fld>
             <a:endParaRPr lang="en-US" dirty="0"/>
           </a:p>
@@ -1963,7 +1965,7 @@
           <a:p>
             <a:fld id="{6F584DAC-AA37-8C49-B5B6-53E9519E19BB}" type="datetimeFigureOut">
               <a:rPr lang="en-US" smtClean="0"/>
-              <a:t>5/9/26</a:t>
+              <a:t>5/10/26</a:t>
             </a:fld>
             <a:endParaRPr lang="en-US" dirty="0"/>
           </a:p>
@@ -2076,7 +2078,7 @@
           <a:p>
             <a:fld id="{6F584DAC-AA37-8C49-B5B6-53E9519E19BB}" type="datetimeFigureOut">
               <a:rPr lang="en-US" smtClean="0"/>
-              <a:t>5/9/26</a:t>
+              <a:t>5/10/26</a:t>
             </a:fld>
             <a:endParaRPr lang="en-US" dirty="0"/>
           </a:p>
@@ -2387,7 +2389,7 @@
           <a:p>
             <a:fld id="{6F584DAC-AA37-8C49-B5B6-53E9519E19BB}" type="datetimeFigureOut">
               <a:rPr lang="en-US" smtClean="0"/>
-              <a:t>5/9/26</a:t>
+              <a:t>5/10/26</a:t>
             </a:fld>
             <a:endParaRPr lang="en-US" dirty="0"/>
           </a:p>
@@ -2675,7 +2677,7 @@
           <a:p>
             <a:fld id="{6F584DAC-AA37-8C49-B5B6-53E9519E19BB}" type="datetimeFigureOut">
               <a:rPr lang="en-US" smtClean="0"/>
-              <a:t>5/9/26</a:t>
+              <a:t>5/10/26</a:t>
             </a:fld>
             <a:endParaRPr lang="en-US" dirty="0"/>
           </a:p>
@@ -2916,7 +2918,7 @@
           <a:p>
             <a:fld id="{6F584DAC-AA37-8C49-B5B6-53E9519E19BB}" type="datetimeFigureOut">
               <a:rPr lang="en-US" smtClean="0"/>
-              <a:t>5/9/26</a:t>
+              <a:t>5/10/26</a:t>
             </a:fld>
             <a:endParaRPr lang="en-US" dirty="0"/>
           </a:p>
@@ -4303,6 +4305,1256 @@
     <p:extLst>
       <p:ext uri="{BB962C8B-B14F-4D97-AF65-F5344CB8AC3E}">
         <p14:creationId xmlns:p14="http://schemas.microsoft.com/office/powerpoint/2010/main" val="2022357004"/>
+      </p:ext>
+    </p:extLst>
+  </p:cSld>
+  <p:clrMapOvr>
+    <a:masterClrMapping/>
+  </p:clrMapOvr>
+</p:sld>
+</file>
+
+<file path=ppt/slides/slide10.xml><?xml version="1.0" encoding="utf-8"?>
+<p:sld xmlns:a="http://schemas.openxmlformats.org/drawingml/2006/main" xmlns:r="http://schemas.openxmlformats.org/officeDocument/2006/relationships" xmlns:p="http://schemas.openxmlformats.org/presentationml/2006/main">
+  <p:cSld>
+    <p:spTree>
+      <p:nvGrpSpPr>
+        <p:cNvPr id="1" name="">
+          <a:extLst>
+            <a:ext uri="{FF2B5EF4-FFF2-40B4-BE49-F238E27FC236}">
+              <a16:creationId xmlns:a16="http://schemas.microsoft.com/office/drawing/2014/main" id="{F11FE11A-ECA3-838C-41CD-EE71547B9406}"/>
+            </a:ext>
+          </a:extLst>
+        </p:cNvPr>
+        <p:cNvGrpSpPr/>
+        <p:nvPr/>
+      </p:nvGrpSpPr>
+      <p:grpSpPr>
+        <a:xfrm>
+          <a:off x="0" y="0"/>
+          <a:ext cx="0" cy="0"/>
+          <a:chOff x="0" y="0"/>
+          <a:chExt cx="0" cy="0"/>
+        </a:xfrm>
+      </p:grpSpPr>
+      <p:sp>
+        <p:nvSpPr>
+          <p:cNvPr id="2" name="Title 1">
+            <a:extLst>
+              <a:ext uri="{FF2B5EF4-FFF2-40B4-BE49-F238E27FC236}">
+                <a16:creationId xmlns:a16="http://schemas.microsoft.com/office/drawing/2014/main" id="{4BAE0244-DF45-9C9E-5A19-51E0A0456F1F}"/>
+              </a:ext>
+            </a:extLst>
+          </p:cNvPr>
+          <p:cNvSpPr>
+            <a:spLocks noGrp="1"/>
+          </p:cNvSpPr>
+          <p:nvPr>
+            <p:ph type="title"/>
+          </p:nvPr>
+        </p:nvSpPr>
+        <p:spPr/>
+        <p:txBody>
+          <a:bodyPr/>
+          <a:lstStyle/>
+          <a:p>
+            <a:r>
+              <a:rPr lang="en-US" dirty="0"/>
+              <a:t>Buffer</a:t>
+            </a:r>
+          </a:p>
+        </p:txBody>
+      </p:sp>
+      <p:sp>
+        <p:nvSpPr>
+          <p:cNvPr id="4" name="Rectangle 3">
+            <a:extLst>
+              <a:ext uri="{FF2B5EF4-FFF2-40B4-BE49-F238E27FC236}">
+                <a16:creationId xmlns:a16="http://schemas.microsoft.com/office/drawing/2014/main" id="{9F6DA451-AAF6-2A2E-097A-18DEDFB2D240}"/>
+              </a:ext>
+            </a:extLst>
+          </p:cNvPr>
+          <p:cNvSpPr/>
+          <p:nvPr/>
+        </p:nvSpPr>
+        <p:spPr>
+          <a:xfrm>
+            <a:off x="3391786" y="2679405"/>
+            <a:ext cx="5316279" cy="425302"/>
+          </a:xfrm>
+          <a:prstGeom prst="rect">
+            <a:avLst/>
+          </a:prstGeom>
+        </p:spPr>
+        <p:style>
+          <a:lnRef idx="2">
+            <a:schemeClr val="dk1"/>
+          </a:lnRef>
+          <a:fillRef idx="1">
+            <a:schemeClr val="lt1"/>
+          </a:fillRef>
+          <a:effectRef idx="0">
+            <a:schemeClr val="dk1"/>
+          </a:effectRef>
+          <a:fontRef idx="minor">
+            <a:schemeClr val="dk1"/>
+          </a:fontRef>
+        </p:style>
+        <p:txBody>
+          <a:bodyPr rtlCol="0" anchor="ctr"/>
+          <a:lstStyle/>
+          <a:p>
+            <a:pPr algn="ctr"/>
+            <a:endParaRPr lang="en-US"/>
+          </a:p>
+        </p:txBody>
+      </p:sp>
+      <p:sp>
+        <p:nvSpPr>
+          <p:cNvPr id="5" name="TextBox 4">
+            <a:extLst>
+              <a:ext uri="{FF2B5EF4-FFF2-40B4-BE49-F238E27FC236}">
+                <a16:creationId xmlns:a16="http://schemas.microsoft.com/office/drawing/2014/main" id="{1A56BCF2-032C-99A1-FCF6-54E19AB458D0}"/>
+              </a:ext>
+            </a:extLst>
+          </p:cNvPr>
+          <p:cNvSpPr txBox="1"/>
+          <p:nvPr/>
+        </p:nvSpPr>
+        <p:spPr>
+          <a:xfrm>
+            <a:off x="2413591" y="2456121"/>
+            <a:ext cx="866904" cy="369332"/>
+          </a:xfrm>
+          <a:prstGeom prst="rect">
+            <a:avLst/>
+          </a:prstGeom>
+          <a:noFill/>
+        </p:spPr>
+        <p:txBody>
+          <a:bodyPr wrap="none" rtlCol="0">
+            <a:spAutoFit/>
+          </a:bodyPr>
+          <a:lstStyle/>
+          <a:p>
+            <a:r>
+              <a:rPr lang="en-US" dirty="0"/>
+              <a:t>offsets</a:t>
+            </a:r>
+          </a:p>
+        </p:txBody>
+      </p:sp>
+      <p:sp>
+        <p:nvSpPr>
+          <p:cNvPr id="6" name="Rectangle 5">
+            <a:extLst>
+              <a:ext uri="{FF2B5EF4-FFF2-40B4-BE49-F238E27FC236}">
+                <a16:creationId xmlns:a16="http://schemas.microsoft.com/office/drawing/2014/main" id="{07CCB565-FAEC-2F70-D70F-2B79BD3D9768}"/>
+              </a:ext>
+            </a:extLst>
+          </p:cNvPr>
+          <p:cNvSpPr/>
+          <p:nvPr/>
+        </p:nvSpPr>
+        <p:spPr>
+          <a:xfrm>
+            <a:off x="3391786" y="3388868"/>
+            <a:ext cx="5316279" cy="425302"/>
+          </a:xfrm>
+          <a:prstGeom prst="rect">
+            <a:avLst/>
+          </a:prstGeom>
+        </p:spPr>
+        <p:style>
+          <a:lnRef idx="2">
+            <a:schemeClr val="dk1"/>
+          </a:lnRef>
+          <a:fillRef idx="1">
+            <a:schemeClr val="lt1"/>
+          </a:fillRef>
+          <a:effectRef idx="0">
+            <a:schemeClr val="dk1"/>
+          </a:effectRef>
+          <a:fontRef idx="minor">
+            <a:schemeClr val="dk1"/>
+          </a:fontRef>
+        </p:style>
+        <p:txBody>
+          <a:bodyPr rtlCol="0" anchor="ctr"/>
+          <a:lstStyle/>
+          <a:p>
+            <a:pPr algn="ctr"/>
+            <a:endParaRPr lang="en-US"/>
+          </a:p>
+        </p:txBody>
+      </p:sp>
+      <p:sp>
+        <p:nvSpPr>
+          <p:cNvPr id="7" name="TextBox 6">
+            <a:extLst>
+              <a:ext uri="{FF2B5EF4-FFF2-40B4-BE49-F238E27FC236}">
+                <a16:creationId xmlns:a16="http://schemas.microsoft.com/office/drawing/2014/main" id="{A074A73C-9F2A-2598-541F-63BD2DD6A0C6}"/>
+              </a:ext>
+            </a:extLst>
+          </p:cNvPr>
+          <p:cNvSpPr txBox="1"/>
+          <p:nvPr/>
+        </p:nvSpPr>
+        <p:spPr>
+          <a:xfrm>
+            <a:off x="2413591" y="3165584"/>
+            <a:ext cx="971100" cy="369332"/>
+          </a:xfrm>
+          <a:prstGeom prst="rect">
+            <a:avLst/>
+          </a:prstGeom>
+          <a:noFill/>
+        </p:spPr>
+        <p:txBody>
+          <a:bodyPr wrap="none" rtlCol="0">
+            <a:spAutoFit/>
+          </a:bodyPr>
+          <a:lstStyle/>
+          <a:p>
+            <a:r>
+              <a:rPr lang="en-US" dirty="0"/>
+              <a:t>vertices</a:t>
+            </a:r>
+          </a:p>
+        </p:txBody>
+      </p:sp>
+      <p:sp>
+        <p:nvSpPr>
+          <p:cNvPr id="10" name="Rectangle 9">
+            <a:extLst>
+              <a:ext uri="{FF2B5EF4-FFF2-40B4-BE49-F238E27FC236}">
+                <a16:creationId xmlns:a16="http://schemas.microsoft.com/office/drawing/2014/main" id="{62AD0422-46D4-B175-2C1C-8811E73E671C}"/>
+              </a:ext>
+            </a:extLst>
+          </p:cNvPr>
+          <p:cNvSpPr/>
+          <p:nvPr/>
+        </p:nvSpPr>
+        <p:spPr>
+          <a:xfrm>
+            <a:off x="5486398" y="2724853"/>
+            <a:ext cx="513907" cy="333779"/>
+          </a:xfrm>
+          <a:prstGeom prst="rect">
+            <a:avLst/>
+          </a:prstGeom>
+        </p:spPr>
+        <p:style>
+          <a:lnRef idx="2">
+            <a:schemeClr val="dk1"/>
+          </a:lnRef>
+          <a:fillRef idx="1">
+            <a:schemeClr val="lt1"/>
+          </a:fillRef>
+          <a:effectRef idx="0">
+            <a:schemeClr val="dk1"/>
+          </a:effectRef>
+          <a:fontRef idx="minor">
+            <a:schemeClr val="dk1"/>
+          </a:fontRef>
+        </p:style>
+        <p:txBody>
+          <a:bodyPr rtlCol="0" anchor="ctr"/>
+          <a:lstStyle/>
+          <a:p>
+            <a:pPr algn="ctr"/>
+            <a:r>
+              <a:rPr lang="en-US" sz="1000" dirty="0"/>
+              <a:t>md</a:t>
+            </a:r>
+          </a:p>
+        </p:txBody>
+      </p:sp>
+      <p:sp>
+        <p:nvSpPr>
+          <p:cNvPr id="11" name="Rectangle 10">
+            <a:extLst>
+              <a:ext uri="{FF2B5EF4-FFF2-40B4-BE49-F238E27FC236}">
+                <a16:creationId xmlns:a16="http://schemas.microsoft.com/office/drawing/2014/main" id="{D3CA4A19-A4CE-0469-607F-64B8AB72FE24}"/>
+              </a:ext>
+            </a:extLst>
+          </p:cNvPr>
+          <p:cNvSpPr/>
+          <p:nvPr/>
+        </p:nvSpPr>
+        <p:spPr>
+          <a:xfrm>
+            <a:off x="5922336" y="2724853"/>
+            <a:ext cx="340243" cy="333779"/>
+          </a:xfrm>
+          <a:prstGeom prst="rect">
+            <a:avLst/>
+          </a:prstGeom>
+        </p:spPr>
+        <p:style>
+          <a:lnRef idx="2">
+            <a:schemeClr val="dk1"/>
+          </a:lnRef>
+          <a:fillRef idx="1">
+            <a:schemeClr val="lt1"/>
+          </a:fillRef>
+          <a:effectRef idx="0">
+            <a:schemeClr val="dk1"/>
+          </a:effectRef>
+          <a:fontRef idx="minor">
+            <a:schemeClr val="dk1"/>
+          </a:fontRef>
+        </p:style>
+        <p:txBody>
+          <a:bodyPr rtlCol="0" anchor="ctr"/>
+          <a:lstStyle/>
+          <a:p>
+            <a:pPr algn="ctr"/>
+            <a:r>
+              <a:rPr lang="en-US" sz="1000" dirty="0" err="1"/>
+              <a:t>en</a:t>
+            </a:r>
+            <a:endParaRPr lang="en-US" sz="1000" dirty="0"/>
+          </a:p>
+        </p:txBody>
+      </p:sp>
+      <p:sp>
+        <p:nvSpPr>
+          <p:cNvPr id="9" name="Rectangle 8">
+            <a:extLst>
+              <a:ext uri="{FF2B5EF4-FFF2-40B4-BE49-F238E27FC236}">
+                <a16:creationId xmlns:a16="http://schemas.microsoft.com/office/drawing/2014/main" id="{E08D2CB3-2B84-BAFE-1CBA-63525158B8E0}"/>
+              </a:ext>
+            </a:extLst>
+          </p:cNvPr>
+          <p:cNvSpPr/>
+          <p:nvPr/>
+        </p:nvSpPr>
+        <p:spPr>
+          <a:xfrm>
+            <a:off x="5241850" y="2724853"/>
+            <a:ext cx="340243" cy="333779"/>
+          </a:xfrm>
+          <a:prstGeom prst="rect">
+            <a:avLst/>
+          </a:prstGeom>
+        </p:spPr>
+        <p:style>
+          <a:lnRef idx="2">
+            <a:schemeClr val="dk1"/>
+          </a:lnRef>
+          <a:fillRef idx="1">
+            <a:schemeClr val="lt1"/>
+          </a:fillRef>
+          <a:effectRef idx="0">
+            <a:schemeClr val="dk1"/>
+          </a:effectRef>
+          <a:fontRef idx="minor">
+            <a:schemeClr val="dk1"/>
+          </a:fontRef>
+        </p:style>
+        <p:txBody>
+          <a:bodyPr rtlCol="0" anchor="ctr"/>
+          <a:lstStyle/>
+          <a:p>
+            <a:pPr algn="ctr"/>
+            <a:r>
+              <a:rPr lang="en-US" sz="1000" dirty="0"/>
+              <a:t>st</a:t>
+            </a:r>
+          </a:p>
+        </p:txBody>
+      </p:sp>
+      <p:cxnSp>
+        <p:nvCxnSpPr>
+          <p:cNvPr id="13" name="Straight Arrow Connector 12">
+            <a:extLst>
+              <a:ext uri="{FF2B5EF4-FFF2-40B4-BE49-F238E27FC236}">
+                <a16:creationId xmlns:a16="http://schemas.microsoft.com/office/drawing/2014/main" id="{76A32FD7-01F0-6D2C-FBF8-BE7804C9DB4A}"/>
+              </a:ext>
+            </a:extLst>
+          </p:cNvPr>
+          <p:cNvCxnSpPr>
+            <a:stCxn id="9" idx="2"/>
+          </p:cNvCxnSpPr>
+          <p:nvPr/>
+        </p:nvCxnSpPr>
+        <p:spPr>
+          <a:xfrm flipH="1">
+            <a:off x="4880344" y="3058632"/>
+            <a:ext cx="531628" cy="330236"/>
+          </a:xfrm>
+          <a:prstGeom prst="straightConnector1">
+            <a:avLst/>
+          </a:prstGeom>
+          <a:ln>
+            <a:tailEnd type="triangle"/>
+          </a:ln>
+        </p:spPr>
+        <p:style>
+          <a:lnRef idx="2">
+            <a:schemeClr val="accent1"/>
+          </a:lnRef>
+          <a:fillRef idx="0">
+            <a:schemeClr val="accent1"/>
+          </a:fillRef>
+          <a:effectRef idx="1">
+            <a:schemeClr val="accent1"/>
+          </a:effectRef>
+          <a:fontRef idx="minor">
+            <a:schemeClr val="tx1"/>
+          </a:fontRef>
+        </p:style>
+      </p:cxnSp>
+      <p:cxnSp>
+        <p:nvCxnSpPr>
+          <p:cNvPr id="14" name="Straight Arrow Connector 13">
+            <a:extLst>
+              <a:ext uri="{FF2B5EF4-FFF2-40B4-BE49-F238E27FC236}">
+                <a16:creationId xmlns:a16="http://schemas.microsoft.com/office/drawing/2014/main" id="{C742EE21-C40F-BD49-9AA4-C3C8B6CF212C}"/>
+              </a:ext>
+            </a:extLst>
+          </p:cNvPr>
+          <p:cNvCxnSpPr>
+            <a:cxnSpLocks/>
+            <a:stCxn id="10" idx="2"/>
+          </p:cNvCxnSpPr>
+          <p:nvPr/>
+        </p:nvCxnSpPr>
+        <p:spPr>
+          <a:xfrm flipH="1">
+            <a:off x="5582093" y="3058632"/>
+            <a:ext cx="161259" cy="330236"/>
+          </a:xfrm>
+          <a:prstGeom prst="straightConnector1">
+            <a:avLst/>
+          </a:prstGeom>
+          <a:ln>
+            <a:tailEnd type="triangle"/>
+          </a:ln>
+        </p:spPr>
+        <p:style>
+          <a:lnRef idx="2">
+            <a:schemeClr val="accent1"/>
+          </a:lnRef>
+          <a:fillRef idx="0">
+            <a:schemeClr val="accent1"/>
+          </a:fillRef>
+          <a:effectRef idx="1">
+            <a:schemeClr val="accent1"/>
+          </a:effectRef>
+          <a:fontRef idx="minor">
+            <a:schemeClr val="tx1"/>
+          </a:fontRef>
+        </p:style>
+      </p:cxnSp>
+      <p:cxnSp>
+        <p:nvCxnSpPr>
+          <p:cNvPr id="17" name="Straight Arrow Connector 16">
+            <a:extLst>
+              <a:ext uri="{FF2B5EF4-FFF2-40B4-BE49-F238E27FC236}">
+                <a16:creationId xmlns:a16="http://schemas.microsoft.com/office/drawing/2014/main" id="{F4D1BDD9-07C8-6754-6A6F-95B524B0FA65}"/>
+              </a:ext>
+            </a:extLst>
+          </p:cNvPr>
+          <p:cNvCxnSpPr>
+            <a:cxnSpLocks/>
+          </p:cNvCxnSpPr>
+          <p:nvPr/>
+        </p:nvCxnSpPr>
+        <p:spPr>
+          <a:xfrm>
+            <a:off x="6128781" y="3058632"/>
+            <a:ext cx="312782" cy="330236"/>
+          </a:xfrm>
+          <a:prstGeom prst="straightConnector1">
+            <a:avLst/>
+          </a:prstGeom>
+          <a:ln>
+            <a:tailEnd type="triangle"/>
+          </a:ln>
+        </p:spPr>
+        <p:style>
+          <a:lnRef idx="2">
+            <a:schemeClr val="accent1"/>
+          </a:lnRef>
+          <a:fillRef idx="0">
+            <a:schemeClr val="accent1"/>
+          </a:fillRef>
+          <a:effectRef idx="1">
+            <a:schemeClr val="accent1"/>
+          </a:effectRef>
+          <a:fontRef idx="minor">
+            <a:schemeClr val="tx1"/>
+          </a:fontRef>
+        </p:style>
+      </p:cxnSp>
+      <p:sp>
+        <p:nvSpPr>
+          <p:cNvPr id="19" name="Rectangle 18">
+            <a:extLst>
+              <a:ext uri="{FF2B5EF4-FFF2-40B4-BE49-F238E27FC236}">
+                <a16:creationId xmlns:a16="http://schemas.microsoft.com/office/drawing/2014/main" id="{531A138B-A7B8-DB22-E217-A9AB8D23B595}"/>
+              </a:ext>
+            </a:extLst>
+          </p:cNvPr>
+          <p:cNvSpPr/>
+          <p:nvPr/>
+        </p:nvSpPr>
+        <p:spPr>
+          <a:xfrm>
+            <a:off x="4901607" y="3434317"/>
+            <a:ext cx="680486" cy="326064"/>
+          </a:xfrm>
+          <a:prstGeom prst="rect">
+            <a:avLst/>
+          </a:prstGeom>
+        </p:spPr>
+        <p:style>
+          <a:lnRef idx="2">
+            <a:schemeClr val="dk1"/>
+          </a:lnRef>
+          <a:fillRef idx="1">
+            <a:schemeClr val="lt1"/>
+          </a:fillRef>
+          <a:effectRef idx="0">
+            <a:schemeClr val="dk1"/>
+          </a:effectRef>
+          <a:fontRef idx="minor">
+            <a:schemeClr val="dk1"/>
+          </a:fontRef>
+        </p:style>
+        <p:txBody>
+          <a:bodyPr rtlCol="0" anchor="ctr"/>
+          <a:lstStyle/>
+          <a:p>
+            <a:pPr algn="ctr"/>
+            <a:r>
+              <a:rPr lang="en-US" dirty="0"/>
+              <a:t>S</a:t>
+            </a:r>
+          </a:p>
+        </p:txBody>
+      </p:sp>
+      <p:sp>
+        <p:nvSpPr>
+          <p:cNvPr id="20" name="Rectangle 19">
+            <a:extLst>
+              <a:ext uri="{FF2B5EF4-FFF2-40B4-BE49-F238E27FC236}">
+                <a16:creationId xmlns:a16="http://schemas.microsoft.com/office/drawing/2014/main" id="{BA91B2C4-9E07-E386-69E2-BC4C80D4C4B1}"/>
+              </a:ext>
+            </a:extLst>
+          </p:cNvPr>
+          <p:cNvSpPr/>
+          <p:nvPr/>
+        </p:nvSpPr>
+        <p:spPr>
+          <a:xfrm>
+            <a:off x="5583419" y="3426601"/>
+            <a:ext cx="858143" cy="333779"/>
+          </a:xfrm>
+          <a:prstGeom prst="rect">
+            <a:avLst/>
+          </a:prstGeom>
+        </p:spPr>
+        <p:style>
+          <a:lnRef idx="2">
+            <a:schemeClr val="dk1"/>
+          </a:lnRef>
+          <a:fillRef idx="1">
+            <a:schemeClr val="lt1"/>
+          </a:fillRef>
+          <a:effectRef idx="0">
+            <a:schemeClr val="dk1"/>
+          </a:effectRef>
+          <a:fontRef idx="minor">
+            <a:schemeClr val="dk1"/>
+          </a:fontRef>
+        </p:style>
+        <p:txBody>
+          <a:bodyPr rtlCol="0" anchor="ctr"/>
+          <a:lstStyle/>
+          <a:p>
+            <a:pPr algn="ctr"/>
+            <a:r>
+              <a:rPr lang="en-US" dirty="0"/>
+              <a:t>C</a:t>
+            </a:r>
+          </a:p>
+        </p:txBody>
+      </p:sp>
+      <p:sp>
+        <p:nvSpPr>
+          <p:cNvPr id="21" name="TextBox 20">
+            <a:extLst>
+              <a:ext uri="{FF2B5EF4-FFF2-40B4-BE49-F238E27FC236}">
+                <a16:creationId xmlns:a16="http://schemas.microsoft.com/office/drawing/2014/main" id="{1C3B2B14-4F49-8862-744A-C7D634740EA9}"/>
+              </a:ext>
+            </a:extLst>
+          </p:cNvPr>
+          <p:cNvSpPr txBox="1"/>
+          <p:nvPr/>
+        </p:nvSpPr>
+        <p:spPr>
+          <a:xfrm>
+            <a:off x="659219" y="2743200"/>
+            <a:ext cx="947760" cy="369332"/>
+          </a:xfrm>
+          <a:prstGeom prst="rect">
+            <a:avLst/>
+          </a:prstGeom>
+          <a:noFill/>
+        </p:spPr>
+        <p:txBody>
+          <a:bodyPr wrap="none" rtlCol="0">
+            <a:spAutoFit/>
+          </a:bodyPr>
+          <a:lstStyle/>
+          <a:p>
+            <a:r>
+              <a:rPr lang="en-US" dirty="0"/>
+              <a:t>Current</a:t>
+            </a:r>
+          </a:p>
+        </p:txBody>
+      </p:sp>
+      <p:sp>
+        <p:nvSpPr>
+          <p:cNvPr id="22" name="Rectangle 21">
+            <a:extLst>
+              <a:ext uri="{FF2B5EF4-FFF2-40B4-BE49-F238E27FC236}">
+                <a16:creationId xmlns:a16="http://schemas.microsoft.com/office/drawing/2014/main" id="{CF093E29-9F5A-93E6-85BF-70A9B4FD4ADF}"/>
+              </a:ext>
+            </a:extLst>
+          </p:cNvPr>
+          <p:cNvSpPr/>
+          <p:nvPr/>
+        </p:nvSpPr>
+        <p:spPr>
+          <a:xfrm>
+            <a:off x="3391786" y="4499560"/>
+            <a:ext cx="5316279" cy="425302"/>
+          </a:xfrm>
+          <a:prstGeom prst="rect">
+            <a:avLst/>
+          </a:prstGeom>
+        </p:spPr>
+        <p:style>
+          <a:lnRef idx="2">
+            <a:schemeClr val="dk1"/>
+          </a:lnRef>
+          <a:fillRef idx="1">
+            <a:schemeClr val="lt1"/>
+          </a:fillRef>
+          <a:effectRef idx="0">
+            <a:schemeClr val="dk1"/>
+          </a:effectRef>
+          <a:fontRef idx="minor">
+            <a:schemeClr val="dk1"/>
+          </a:fontRef>
+        </p:style>
+        <p:txBody>
+          <a:bodyPr rtlCol="0" anchor="ctr"/>
+          <a:lstStyle/>
+          <a:p>
+            <a:pPr algn="ctr"/>
+            <a:endParaRPr lang="en-US"/>
+          </a:p>
+        </p:txBody>
+      </p:sp>
+      <p:sp>
+        <p:nvSpPr>
+          <p:cNvPr id="23" name="TextBox 22">
+            <a:extLst>
+              <a:ext uri="{FF2B5EF4-FFF2-40B4-BE49-F238E27FC236}">
+                <a16:creationId xmlns:a16="http://schemas.microsoft.com/office/drawing/2014/main" id="{CA43E7F0-AAB0-6445-1E1E-D32D9845BB62}"/>
+              </a:ext>
+            </a:extLst>
+          </p:cNvPr>
+          <p:cNvSpPr txBox="1"/>
+          <p:nvPr/>
+        </p:nvSpPr>
+        <p:spPr>
+          <a:xfrm>
+            <a:off x="2413591" y="4276276"/>
+            <a:ext cx="866904" cy="369332"/>
+          </a:xfrm>
+          <a:prstGeom prst="rect">
+            <a:avLst/>
+          </a:prstGeom>
+          <a:noFill/>
+        </p:spPr>
+        <p:txBody>
+          <a:bodyPr wrap="none" rtlCol="0">
+            <a:spAutoFit/>
+          </a:bodyPr>
+          <a:lstStyle/>
+          <a:p>
+            <a:r>
+              <a:rPr lang="en-US" dirty="0"/>
+              <a:t>offsets</a:t>
+            </a:r>
+          </a:p>
+        </p:txBody>
+      </p:sp>
+      <p:sp>
+        <p:nvSpPr>
+          <p:cNvPr id="24" name="Rectangle 23">
+            <a:extLst>
+              <a:ext uri="{FF2B5EF4-FFF2-40B4-BE49-F238E27FC236}">
+                <a16:creationId xmlns:a16="http://schemas.microsoft.com/office/drawing/2014/main" id="{73B7727D-DCE4-4686-E7E8-E31B3E1E0E5C}"/>
+              </a:ext>
+            </a:extLst>
+          </p:cNvPr>
+          <p:cNvSpPr/>
+          <p:nvPr/>
+        </p:nvSpPr>
+        <p:spPr>
+          <a:xfrm>
+            <a:off x="3391786" y="5209023"/>
+            <a:ext cx="5316279" cy="425302"/>
+          </a:xfrm>
+          <a:prstGeom prst="rect">
+            <a:avLst/>
+          </a:prstGeom>
+        </p:spPr>
+        <p:style>
+          <a:lnRef idx="2">
+            <a:schemeClr val="dk1"/>
+          </a:lnRef>
+          <a:fillRef idx="1">
+            <a:schemeClr val="lt1"/>
+          </a:fillRef>
+          <a:effectRef idx="0">
+            <a:schemeClr val="dk1"/>
+          </a:effectRef>
+          <a:fontRef idx="minor">
+            <a:schemeClr val="dk1"/>
+          </a:fontRef>
+        </p:style>
+        <p:txBody>
+          <a:bodyPr rtlCol="0" anchor="ctr"/>
+          <a:lstStyle/>
+          <a:p>
+            <a:pPr algn="ctr"/>
+            <a:endParaRPr lang="en-US"/>
+          </a:p>
+        </p:txBody>
+      </p:sp>
+      <p:sp>
+        <p:nvSpPr>
+          <p:cNvPr id="25" name="TextBox 24">
+            <a:extLst>
+              <a:ext uri="{FF2B5EF4-FFF2-40B4-BE49-F238E27FC236}">
+                <a16:creationId xmlns:a16="http://schemas.microsoft.com/office/drawing/2014/main" id="{2F527B95-6603-B737-979E-E3FD277E2C30}"/>
+              </a:ext>
+            </a:extLst>
+          </p:cNvPr>
+          <p:cNvSpPr txBox="1"/>
+          <p:nvPr/>
+        </p:nvSpPr>
+        <p:spPr>
+          <a:xfrm>
+            <a:off x="2413591" y="4985739"/>
+            <a:ext cx="971100" cy="369332"/>
+          </a:xfrm>
+          <a:prstGeom prst="rect">
+            <a:avLst/>
+          </a:prstGeom>
+          <a:noFill/>
+        </p:spPr>
+        <p:txBody>
+          <a:bodyPr wrap="none" rtlCol="0">
+            <a:spAutoFit/>
+          </a:bodyPr>
+          <a:lstStyle/>
+          <a:p>
+            <a:r>
+              <a:rPr lang="en-US" dirty="0"/>
+              <a:t>vertices</a:t>
+            </a:r>
+          </a:p>
+        </p:txBody>
+      </p:sp>
+      <p:sp>
+        <p:nvSpPr>
+          <p:cNvPr id="27" name="Rectangle 26">
+            <a:extLst>
+              <a:ext uri="{FF2B5EF4-FFF2-40B4-BE49-F238E27FC236}">
+                <a16:creationId xmlns:a16="http://schemas.microsoft.com/office/drawing/2014/main" id="{C1E7F5E8-4092-056B-ADC6-01C67DCC733C}"/>
+              </a:ext>
+            </a:extLst>
+          </p:cNvPr>
+          <p:cNvSpPr/>
+          <p:nvPr/>
+        </p:nvSpPr>
+        <p:spPr>
+          <a:xfrm>
+            <a:off x="5743352" y="4545008"/>
+            <a:ext cx="519227" cy="333779"/>
+          </a:xfrm>
+          <a:prstGeom prst="rect">
+            <a:avLst/>
+          </a:prstGeom>
+        </p:spPr>
+        <p:style>
+          <a:lnRef idx="2">
+            <a:schemeClr val="dk1"/>
+          </a:lnRef>
+          <a:fillRef idx="1">
+            <a:schemeClr val="lt1"/>
+          </a:fillRef>
+          <a:effectRef idx="0">
+            <a:schemeClr val="dk1"/>
+          </a:effectRef>
+          <a:fontRef idx="minor">
+            <a:schemeClr val="dk1"/>
+          </a:fontRef>
+        </p:style>
+        <p:txBody>
+          <a:bodyPr rtlCol="0" anchor="ctr"/>
+          <a:lstStyle/>
+          <a:p>
+            <a:pPr algn="ctr"/>
+            <a:r>
+              <a:rPr lang="en-US" sz="1000" dirty="0" err="1"/>
+              <a:t>en</a:t>
+            </a:r>
+            <a:endParaRPr lang="en-US" sz="1000" dirty="0"/>
+          </a:p>
+        </p:txBody>
+      </p:sp>
+      <p:sp>
+        <p:nvSpPr>
+          <p:cNvPr id="28" name="Rectangle 27">
+            <a:extLst>
+              <a:ext uri="{FF2B5EF4-FFF2-40B4-BE49-F238E27FC236}">
+                <a16:creationId xmlns:a16="http://schemas.microsoft.com/office/drawing/2014/main" id="{767198B4-48C4-2218-38F9-5B779E71FA88}"/>
+              </a:ext>
+            </a:extLst>
+          </p:cNvPr>
+          <p:cNvSpPr/>
+          <p:nvPr/>
+        </p:nvSpPr>
+        <p:spPr>
+          <a:xfrm>
+            <a:off x="5241850" y="4545008"/>
+            <a:ext cx="501502" cy="333779"/>
+          </a:xfrm>
+          <a:prstGeom prst="rect">
+            <a:avLst/>
+          </a:prstGeom>
+        </p:spPr>
+        <p:style>
+          <a:lnRef idx="2">
+            <a:schemeClr val="dk1"/>
+          </a:lnRef>
+          <a:fillRef idx="1">
+            <a:schemeClr val="lt1"/>
+          </a:fillRef>
+          <a:effectRef idx="0">
+            <a:schemeClr val="dk1"/>
+          </a:effectRef>
+          <a:fontRef idx="minor">
+            <a:schemeClr val="dk1"/>
+          </a:fontRef>
+        </p:style>
+        <p:txBody>
+          <a:bodyPr rtlCol="0" anchor="ctr"/>
+          <a:lstStyle/>
+          <a:p>
+            <a:pPr algn="ctr"/>
+            <a:r>
+              <a:rPr lang="en-US" sz="1000" dirty="0"/>
+              <a:t>st</a:t>
+            </a:r>
+          </a:p>
+        </p:txBody>
+      </p:sp>
+      <p:cxnSp>
+        <p:nvCxnSpPr>
+          <p:cNvPr id="29" name="Straight Arrow Connector 28">
+            <a:extLst>
+              <a:ext uri="{FF2B5EF4-FFF2-40B4-BE49-F238E27FC236}">
+                <a16:creationId xmlns:a16="http://schemas.microsoft.com/office/drawing/2014/main" id="{E099448A-A50B-2CEC-502D-EDF359607F42}"/>
+              </a:ext>
+            </a:extLst>
+          </p:cNvPr>
+          <p:cNvCxnSpPr>
+            <a:cxnSpLocks/>
+            <a:stCxn id="28" idx="2"/>
+          </p:cNvCxnSpPr>
+          <p:nvPr/>
+        </p:nvCxnSpPr>
+        <p:spPr>
+          <a:xfrm flipH="1">
+            <a:off x="4880344" y="4878787"/>
+            <a:ext cx="612257" cy="330236"/>
+          </a:xfrm>
+          <a:prstGeom prst="straightConnector1">
+            <a:avLst/>
+          </a:prstGeom>
+          <a:ln>
+            <a:tailEnd type="triangle"/>
+          </a:ln>
+        </p:spPr>
+        <p:style>
+          <a:lnRef idx="2">
+            <a:schemeClr val="accent1"/>
+          </a:lnRef>
+          <a:fillRef idx="0">
+            <a:schemeClr val="accent1"/>
+          </a:fillRef>
+          <a:effectRef idx="1">
+            <a:schemeClr val="accent1"/>
+          </a:effectRef>
+          <a:fontRef idx="minor">
+            <a:schemeClr val="tx1"/>
+          </a:fontRef>
+        </p:style>
+      </p:cxnSp>
+      <p:cxnSp>
+        <p:nvCxnSpPr>
+          <p:cNvPr id="31" name="Straight Arrow Connector 30">
+            <a:extLst>
+              <a:ext uri="{FF2B5EF4-FFF2-40B4-BE49-F238E27FC236}">
+                <a16:creationId xmlns:a16="http://schemas.microsoft.com/office/drawing/2014/main" id="{A18A85B8-EA02-3130-FF0A-A1D6BF0E436E}"/>
+              </a:ext>
+            </a:extLst>
+          </p:cNvPr>
+          <p:cNvCxnSpPr>
+            <a:cxnSpLocks/>
+          </p:cNvCxnSpPr>
+          <p:nvPr/>
+        </p:nvCxnSpPr>
+        <p:spPr>
+          <a:xfrm>
+            <a:off x="6128781" y="4878787"/>
+            <a:ext cx="312782" cy="330236"/>
+          </a:xfrm>
+          <a:prstGeom prst="straightConnector1">
+            <a:avLst/>
+          </a:prstGeom>
+          <a:ln>
+            <a:tailEnd type="triangle"/>
+          </a:ln>
+        </p:spPr>
+        <p:style>
+          <a:lnRef idx="2">
+            <a:schemeClr val="accent1"/>
+          </a:lnRef>
+          <a:fillRef idx="0">
+            <a:schemeClr val="accent1"/>
+          </a:fillRef>
+          <a:effectRef idx="1">
+            <a:schemeClr val="accent1"/>
+          </a:effectRef>
+          <a:fontRef idx="minor">
+            <a:schemeClr val="tx1"/>
+          </a:fontRef>
+        </p:style>
+      </p:cxnSp>
+      <p:sp>
+        <p:nvSpPr>
+          <p:cNvPr id="32" name="Rectangle 31">
+            <a:extLst>
+              <a:ext uri="{FF2B5EF4-FFF2-40B4-BE49-F238E27FC236}">
+                <a16:creationId xmlns:a16="http://schemas.microsoft.com/office/drawing/2014/main" id="{89C5216C-664C-CAD0-AD04-901415E557E7}"/>
+              </a:ext>
+            </a:extLst>
+          </p:cNvPr>
+          <p:cNvSpPr/>
+          <p:nvPr/>
+        </p:nvSpPr>
+        <p:spPr>
+          <a:xfrm>
+            <a:off x="4901607" y="5254472"/>
+            <a:ext cx="680486" cy="326064"/>
+          </a:xfrm>
+          <a:prstGeom prst="rect">
+            <a:avLst/>
+          </a:prstGeom>
+        </p:spPr>
+        <p:style>
+          <a:lnRef idx="2">
+            <a:schemeClr val="dk1"/>
+          </a:lnRef>
+          <a:fillRef idx="1">
+            <a:schemeClr val="lt1"/>
+          </a:fillRef>
+          <a:effectRef idx="0">
+            <a:schemeClr val="dk1"/>
+          </a:effectRef>
+          <a:fontRef idx="minor">
+            <a:schemeClr val="dk1"/>
+          </a:fontRef>
+        </p:style>
+        <p:txBody>
+          <a:bodyPr rtlCol="0" anchor="ctr"/>
+          <a:lstStyle/>
+          <a:p>
+            <a:pPr algn="ctr"/>
+            <a:r>
+              <a:rPr lang="en-US" dirty="0"/>
+              <a:t>S</a:t>
+            </a:r>
+          </a:p>
+        </p:txBody>
+      </p:sp>
+      <p:sp>
+        <p:nvSpPr>
+          <p:cNvPr id="33" name="Rectangle 32">
+            <a:extLst>
+              <a:ext uri="{FF2B5EF4-FFF2-40B4-BE49-F238E27FC236}">
+                <a16:creationId xmlns:a16="http://schemas.microsoft.com/office/drawing/2014/main" id="{7E130D27-CD9F-0DC1-D27B-6ECC25E685D9}"/>
+              </a:ext>
+            </a:extLst>
+          </p:cNvPr>
+          <p:cNvSpPr/>
+          <p:nvPr/>
+        </p:nvSpPr>
+        <p:spPr>
+          <a:xfrm>
+            <a:off x="5583419" y="5246756"/>
+            <a:ext cx="858143" cy="333779"/>
+          </a:xfrm>
+          <a:prstGeom prst="rect">
+            <a:avLst/>
+          </a:prstGeom>
+        </p:spPr>
+        <p:style>
+          <a:lnRef idx="2">
+            <a:schemeClr val="dk1"/>
+          </a:lnRef>
+          <a:fillRef idx="1">
+            <a:schemeClr val="lt1"/>
+          </a:fillRef>
+          <a:effectRef idx="0">
+            <a:schemeClr val="dk1"/>
+          </a:effectRef>
+          <a:fontRef idx="minor">
+            <a:schemeClr val="dk1"/>
+          </a:fontRef>
+        </p:style>
+        <p:txBody>
+          <a:bodyPr rtlCol="0" anchor="ctr"/>
+          <a:lstStyle/>
+          <a:p>
+            <a:pPr algn="ctr"/>
+            <a:r>
+              <a:rPr lang="en-US" dirty="0"/>
+              <a:t>C</a:t>
+            </a:r>
+          </a:p>
+        </p:txBody>
+      </p:sp>
+      <p:sp>
+        <p:nvSpPr>
+          <p:cNvPr id="34" name="TextBox 33">
+            <a:extLst>
+              <a:ext uri="{FF2B5EF4-FFF2-40B4-BE49-F238E27FC236}">
+                <a16:creationId xmlns:a16="http://schemas.microsoft.com/office/drawing/2014/main" id="{F5C08B24-5E69-0AC2-B43C-158E3C442014}"/>
+              </a:ext>
+            </a:extLst>
+          </p:cNvPr>
+          <p:cNvSpPr txBox="1"/>
+          <p:nvPr/>
+        </p:nvSpPr>
+        <p:spPr>
+          <a:xfrm>
+            <a:off x="659219" y="4563355"/>
+            <a:ext cx="1136273" cy="369332"/>
+          </a:xfrm>
+          <a:prstGeom prst="rect">
+            <a:avLst/>
+          </a:prstGeom>
+          <a:noFill/>
+        </p:spPr>
+        <p:txBody>
+          <a:bodyPr wrap="none" rtlCol="0">
+            <a:spAutoFit/>
+          </a:bodyPr>
+          <a:lstStyle/>
+          <a:p>
+            <a:r>
+              <a:rPr lang="en-US" dirty="0"/>
+              <a:t>Proposed</a:t>
+            </a:r>
+          </a:p>
+        </p:txBody>
+      </p:sp>
+      <p:sp>
+        <p:nvSpPr>
+          <p:cNvPr id="36" name="Rectangle 35">
+            <a:extLst>
+              <a:ext uri="{FF2B5EF4-FFF2-40B4-BE49-F238E27FC236}">
+                <a16:creationId xmlns:a16="http://schemas.microsoft.com/office/drawing/2014/main" id="{874F4E16-8B94-A372-97AF-E154330A855B}"/>
+              </a:ext>
+            </a:extLst>
+          </p:cNvPr>
+          <p:cNvSpPr/>
+          <p:nvPr/>
+        </p:nvSpPr>
+        <p:spPr>
+          <a:xfrm>
+            <a:off x="3391786" y="5938194"/>
+            <a:ext cx="5316279" cy="425302"/>
+          </a:xfrm>
+          <a:prstGeom prst="rect">
+            <a:avLst/>
+          </a:prstGeom>
+        </p:spPr>
+        <p:style>
+          <a:lnRef idx="2">
+            <a:schemeClr val="dk1"/>
+          </a:lnRef>
+          <a:fillRef idx="1">
+            <a:schemeClr val="lt1"/>
+          </a:fillRef>
+          <a:effectRef idx="0">
+            <a:schemeClr val="dk1"/>
+          </a:effectRef>
+          <a:fontRef idx="minor">
+            <a:schemeClr val="dk1"/>
+          </a:fontRef>
+        </p:style>
+        <p:txBody>
+          <a:bodyPr rtlCol="0" anchor="ctr"/>
+          <a:lstStyle/>
+          <a:p>
+            <a:pPr algn="ctr"/>
+            <a:endParaRPr lang="en-US"/>
+          </a:p>
+        </p:txBody>
+      </p:sp>
+      <p:sp>
+        <p:nvSpPr>
+          <p:cNvPr id="37" name="TextBox 36">
+            <a:extLst>
+              <a:ext uri="{FF2B5EF4-FFF2-40B4-BE49-F238E27FC236}">
+                <a16:creationId xmlns:a16="http://schemas.microsoft.com/office/drawing/2014/main" id="{F86EED0A-3FF8-3A5C-B802-33B250767027}"/>
+              </a:ext>
+            </a:extLst>
+          </p:cNvPr>
+          <p:cNvSpPr txBox="1"/>
+          <p:nvPr/>
+        </p:nvSpPr>
+        <p:spPr>
+          <a:xfrm>
+            <a:off x="2413591" y="5911765"/>
+            <a:ext cx="566181" cy="369332"/>
+          </a:xfrm>
+          <a:prstGeom prst="rect">
+            <a:avLst/>
+          </a:prstGeom>
+          <a:noFill/>
+        </p:spPr>
+        <p:txBody>
+          <a:bodyPr wrap="none" rtlCol="0">
+            <a:spAutoFit/>
+          </a:bodyPr>
+          <a:lstStyle/>
+          <a:p>
+            <a:r>
+              <a:rPr lang="en-US" dirty="0"/>
+              <a:t>mid</a:t>
+            </a:r>
+          </a:p>
+        </p:txBody>
+      </p:sp>
+      <p:sp>
+        <p:nvSpPr>
+          <p:cNvPr id="38" name="Rectangle 37">
+            <a:extLst>
+              <a:ext uri="{FF2B5EF4-FFF2-40B4-BE49-F238E27FC236}">
+                <a16:creationId xmlns:a16="http://schemas.microsoft.com/office/drawing/2014/main" id="{FEF621C2-BCA8-070B-94AE-96A5250077B2}"/>
+              </a:ext>
+            </a:extLst>
+          </p:cNvPr>
+          <p:cNvSpPr/>
+          <p:nvPr/>
+        </p:nvSpPr>
+        <p:spPr>
+          <a:xfrm>
+            <a:off x="5331342" y="5983955"/>
+            <a:ext cx="501502" cy="333779"/>
+          </a:xfrm>
+          <a:prstGeom prst="rect">
+            <a:avLst/>
+          </a:prstGeom>
+        </p:spPr>
+        <p:style>
+          <a:lnRef idx="2">
+            <a:schemeClr val="dk1"/>
+          </a:lnRef>
+          <a:fillRef idx="1">
+            <a:schemeClr val="lt1"/>
+          </a:fillRef>
+          <a:effectRef idx="0">
+            <a:schemeClr val="dk1"/>
+          </a:effectRef>
+          <a:fontRef idx="minor">
+            <a:schemeClr val="dk1"/>
+          </a:fontRef>
+        </p:style>
+        <p:txBody>
+          <a:bodyPr rtlCol="0" anchor="ctr"/>
+          <a:lstStyle/>
+          <a:p>
+            <a:pPr algn="ctr"/>
+            <a:r>
+              <a:rPr lang="en-US" sz="1000" dirty="0"/>
+              <a:t>st</a:t>
+            </a:r>
+          </a:p>
+        </p:txBody>
+      </p:sp>
+      <p:cxnSp>
+        <p:nvCxnSpPr>
+          <p:cNvPr id="39" name="Straight Arrow Connector 38">
+            <a:extLst>
+              <a:ext uri="{FF2B5EF4-FFF2-40B4-BE49-F238E27FC236}">
+                <a16:creationId xmlns:a16="http://schemas.microsoft.com/office/drawing/2014/main" id="{913289F9-F0D1-88BF-2ACA-3B8455570628}"/>
+              </a:ext>
+            </a:extLst>
+          </p:cNvPr>
+          <p:cNvCxnSpPr>
+            <a:cxnSpLocks/>
+            <a:stCxn id="38" idx="0"/>
+          </p:cNvCxnSpPr>
+          <p:nvPr/>
+        </p:nvCxnSpPr>
+        <p:spPr>
+          <a:xfrm flipV="1">
+            <a:off x="5582093" y="5679774"/>
+            <a:ext cx="0" cy="304181"/>
+          </a:xfrm>
+          <a:prstGeom prst="straightConnector1">
+            <a:avLst/>
+          </a:prstGeom>
+          <a:ln>
+            <a:tailEnd type="triangle"/>
+          </a:ln>
+        </p:spPr>
+        <p:style>
+          <a:lnRef idx="2">
+            <a:schemeClr val="accent1"/>
+          </a:lnRef>
+          <a:fillRef idx="0">
+            <a:schemeClr val="accent1"/>
+          </a:fillRef>
+          <a:effectRef idx="1">
+            <a:schemeClr val="accent1"/>
+          </a:effectRef>
+          <a:fontRef idx="minor">
+            <a:schemeClr val="tx1"/>
+          </a:fontRef>
+        </p:style>
+      </p:cxnSp>
+    </p:spTree>
+    <p:extLst>
+      <p:ext uri="{BB962C8B-B14F-4D97-AF65-F5344CB8AC3E}">
+        <p14:creationId xmlns:p14="http://schemas.microsoft.com/office/powerpoint/2010/main" val="1485236632"/>
       </p:ext>
     </p:extLst>
   </p:cSld>
@@ -11046,6 +12298,617 @@
 </p:sld>
 </file>
 
+<file path=ppt/slides/slide9.xml><?xml version="1.0" encoding="utf-8"?>
+<p:sld xmlns:a="http://schemas.openxmlformats.org/drawingml/2006/main" xmlns:r="http://schemas.openxmlformats.org/officeDocument/2006/relationships" xmlns:p="http://schemas.openxmlformats.org/presentationml/2006/main">
+  <p:cSld>
+    <p:spTree>
+      <p:nvGrpSpPr>
+        <p:cNvPr id="1" name=""/>
+        <p:cNvGrpSpPr/>
+        <p:nvPr/>
+      </p:nvGrpSpPr>
+      <p:grpSpPr>
+        <a:xfrm>
+          <a:off x="0" y="0"/>
+          <a:ext cx="0" cy="0"/>
+          <a:chOff x="0" y="0"/>
+          <a:chExt cx="0" cy="0"/>
+        </a:xfrm>
+      </p:grpSpPr>
+      <p:sp>
+        <p:nvSpPr>
+          <p:cNvPr id="2" name="Title 1">
+            <a:extLst>
+              <a:ext uri="{FF2B5EF4-FFF2-40B4-BE49-F238E27FC236}">
+                <a16:creationId xmlns:a16="http://schemas.microsoft.com/office/drawing/2014/main" id="{53725A50-4677-63C7-039D-3F0060C6E2EE}"/>
+              </a:ext>
+            </a:extLst>
+          </p:cNvPr>
+          <p:cNvSpPr>
+            <a:spLocks noGrp="1"/>
+          </p:cNvSpPr>
+          <p:nvPr>
+            <p:ph type="title"/>
+          </p:nvPr>
+        </p:nvSpPr>
+        <p:spPr/>
+        <p:txBody>
+          <a:bodyPr/>
+          <a:lstStyle/>
+          <a:p>
+            <a:r>
+              <a:rPr lang="en-US" dirty="0"/>
+              <a:t>Buffer</a:t>
+            </a:r>
+          </a:p>
+        </p:txBody>
+      </p:sp>
+      <p:sp>
+        <p:nvSpPr>
+          <p:cNvPr id="4" name="Rectangle 3">
+            <a:extLst>
+              <a:ext uri="{FF2B5EF4-FFF2-40B4-BE49-F238E27FC236}">
+                <a16:creationId xmlns:a16="http://schemas.microsoft.com/office/drawing/2014/main" id="{E6120E09-39A9-6AA8-0784-ECB4BB3A6127}"/>
+              </a:ext>
+            </a:extLst>
+          </p:cNvPr>
+          <p:cNvSpPr/>
+          <p:nvPr/>
+        </p:nvSpPr>
+        <p:spPr>
+          <a:xfrm>
+            <a:off x="3391786" y="2679405"/>
+            <a:ext cx="5316279" cy="425302"/>
+          </a:xfrm>
+          <a:prstGeom prst="rect">
+            <a:avLst/>
+          </a:prstGeom>
+        </p:spPr>
+        <p:style>
+          <a:lnRef idx="2">
+            <a:schemeClr val="dk1"/>
+          </a:lnRef>
+          <a:fillRef idx="1">
+            <a:schemeClr val="lt1"/>
+          </a:fillRef>
+          <a:effectRef idx="0">
+            <a:schemeClr val="dk1"/>
+          </a:effectRef>
+          <a:fontRef idx="minor">
+            <a:schemeClr val="dk1"/>
+          </a:fontRef>
+        </p:style>
+        <p:txBody>
+          <a:bodyPr rtlCol="0" anchor="ctr"/>
+          <a:lstStyle/>
+          <a:p>
+            <a:pPr algn="ctr"/>
+            <a:endParaRPr lang="en-US"/>
+          </a:p>
+        </p:txBody>
+      </p:sp>
+      <p:sp>
+        <p:nvSpPr>
+          <p:cNvPr id="5" name="TextBox 4">
+            <a:extLst>
+              <a:ext uri="{FF2B5EF4-FFF2-40B4-BE49-F238E27FC236}">
+                <a16:creationId xmlns:a16="http://schemas.microsoft.com/office/drawing/2014/main" id="{795E0971-D818-29B0-5265-E69E15AA827F}"/>
+              </a:ext>
+            </a:extLst>
+          </p:cNvPr>
+          <p:cNvSpPr txBox="1"/>
+          <p:nvPr/>
+        </p:nvSpPr>
+        <p:spPr>
+          <a:xfrm>
+            <a:off x="2413591" y="2456121"/>
+            <a:ext cx="866904" cy="369332"/>
+          </a:xfrm>
+          <a:prstGeom prst="rect">
+            <a:avLst/>
+          </a:prstGeom>
+          <a:noFill/>
+        </p:spPr>
+        <p:txBody>
+          <a:bodyPr wrap="none" rtlCol="0">
+            <a:spAutoFit/>
+          </a:bodyPr>
+          <a:lstStyle/>
+          <a:p>
+            <a:r>
+              <a:rPr lang="en-US" dirty="0"/>
+              <a:t>offsets</a:t>
+            </a:r>
+          </a:p>
+        </p:txBody>
+      </p:sp>
+      <p:sp>
+        <p:nvSpPr>
+          <p:cNvPr id="6" name="Rectangle 5">
+            <a:extLst>
+              <a:ext uri="{FF2B5EF4-FFF2-40B4-BE49-F238E27FC236}">
+                <a16:creationId xmlns:a16="http://schemas.microsoft.com/office/drawing/2014/main" id="{8BB71A3D-6A1E-5974-D76E-A419FB7F88DC}"/>
+              </a:ext>
+            </a:extLst>
+          </p:cNvPr>
+          <p:cNvSpPr/>
+          <p:nvPr/>
+        </p:nvSpPr>
+        <p:spPr>
+          <a:xfrm>
+            <a:off x="3391786" y="3388868"/>
+            <a:ext cx="5316279" cy="425302"/>
+          </a:xfrm>
+          <a:prstGeom prst="rect">
+            <a:avLst/>
+          </a:prstGeom>
+        </p:spPr>
+        <p:style>
+          <a:lnRef idx="2">
+            <a:schemeClr val="dk1"/>
+          </a:lnRef>
+          <a:fillRef idx="1">
+            <a:schemeClr val="lt1"/>
+          </a:fillRef>
+          <a:effectRef idx="0">
+            <a:schemeClr val="dk1"/>
+          </a:effectRef>
+          <a:fontRef idx="minor">
+            <a:schemeClr val="dk1"/>
+          </a:fontRef>
+        </p:style>
+        <p:txBody>
+          <a:bodyPr rtlCol="0" anchor="ctr"/>
+          <a:lstStyle/>
+          <a:p>
+            <a:pPr algn="ctr"/>
+            <a:endParaRPr lang="en-US"/>
+          </a:p>
+        </p:txBody>
+      </p:sp>
+      <p:sp>
+        <p:nvSpPr>
+          <p:cNvPr id="7" name="TextBox 6">
+            <a:extLst>
+              <a:ext uri="{FF2B5EF4-FFF2-40B4-BE49-F238E27FC236}">
+                <a16:creationId xmlns:a16="http://schemas.microsoft.com/office/drawing/2014/main" id="{57E41D59-DF4C-D15C-E103-93044792499B}"/>
+              </a:ext>
+            </a:extLst>
+          </p:cNvPr>
+          <p:cNvSpPr txBox="1"/>
+          <p:nvPr/>
+        </p:nvSpPr>
+        <p:spPr>
+          <a:xfrm>
+            <a:off x="2413591" y="3165584"/>
+            <a:ext cx="971100" cy="369332"/>
+          </a:xfrm>
+          <a:prstGeom prst="rect">
+            <a:avLst/>
+          </a:prstGeom>
+          <a:noFill/>
+        </p:spPr>
+        <p:txBody>
+          <a:bodyPr wrap="none" rtlCol="0">
+            <a:spAutoFit/>
+          </a:bodyPr>
+          <a:lstStyle/>
+          <a:p>
+            <a:r>
+              <a:rPr lang="en-US" dirty="0"/>
+              <a:t>vertices</a:t>
+            </a:r>
+          </a:p>
+        </p:txBody>
+      </p:sp>
+      <p:sp>
+        <p:nvSpPr>
+          <p:cNvPr id="10" name="Rectangle 9">
+            <a:extLst>
+              <a:ext uri="{FF2B5EF4-FFF2-40B4-BE49-F238E27FC236}">
+                <a16:creationId xmlns:a16="http://schemas.microsoft.com/office/drawing/2014/main" id="{E0FB95C8-503A-DB2D-F3E0-B16775BC89EF}"/>
+              </a:ext>
+            </a:extLst>
+          </p:cNvPr>
+          <p:cNvSpPr/>
+          <p:nvPr/>
+        </p:nvSpPr>
+        <p:spPr>
+          <a:xfrm>
+            <a:off x="5486398" y="2724853"/>
+            <a:ext cx="513907" cy="333779"/>
+          </a:xfrm>
+          <a:prstGeom prst="rect">
+            <a:avLst/>
+          </a:prstGeom>
+        </p:spPr>
+        <p:style>
+          <a:lnRef idx="2">
+            <a:schemeClr val="dk1"/>
+          </a:lnRef>
+          <a:fillRef idx="1">
+            <a:schemeClr val="lt1"/>
+          </a:fillRef>
+          <a:effectRef idx="0">
+            <a:schemeClr val="dk1"/>
+          </a:effectRef>
+          <a:fontRef idx="minor">
+            <a:schemeClr val="dk1"/>
+          </a:fontRef>
+        </p:style>
+        <p:txBody>
+          <a:bodyPr rtlCol="0" anchor="ctr"/>
+          <a:lstStyle/>
+          <a:p>
+            <a:pPr algn="ctr"/>
+            <a:r>
+              <a:rPr lang="en-US" sz="1000" dirty="0"/>
+              <a:t>md</a:t>
+            </a:r>
+          </a:p>
+        </p:txBody>
+      </p:sp>
+      <p:sp>
+        <p:nvSpPr>
+          <p:cNvPr id="11" name="Rectangle 10">
+            <a:extLst>
+              <a:ext uri="{FF2B5EF4-FFF2-40B4-BE49-F238E27FC236}">
+                <a16:creationId xmlns:a16="http://schemas.microsoft.com/office/drawing/2014/main" id="{01912E3D-7D18-CCDA-6055-467BDCA8AC33}"/>
+              </a:ext>
+            </a:extLst>
+          </p:cNvPr>
+          <p:cNvSpPr/>
+          <p:nvPr/>
+        </p:nvSpPr>
+        <p:spPr>
+          <a:xfrm>
+            <a:off x="5922336" y="2724853"/>
+            <a:ext cx="340243" cy="333779"/>
+          </a:xfrm>
+          <a:prstGeom prst="rect">
+            <a:avLst/>
+          </a:prstGeom>
+        </p:spPr>
+        <p:style>
+          <a:lnRef idx="2">
+            <a:schemeClr val="dk1"/>
+          </a:lnRef>
+          <a:fillRef idx="1">
+            <a:schemeClr val="lt1"/>
+          </a:fillRef>
+          <a:effectRef idx="0">
+            <a:schemeClr val="dk1"/>
+          </a:effectRef>
+          <a:fontRef idx="minor">
+            <a:schemeClr val="dk1"/>
+          </a:fontRef>
+        </p:style>
+        <p:txBody>
+          <a:bodyPr rtlCol="0" anchor="ctr"/>
+          <a:lstStyle/>
+          <a:p>
+            <a:pPr algn="ctr"/>
+            <a:r>
+              <a:rPr lang="en-US" sz="1000" dirty="0" err="1"/>
+              <a:t>en</a:t>
+            </a:r>
+            <a:endParaRPr lang="en-US" sz="1000" dirty="0"/>
+          </a:p>
+        </p:txBody>
+      </p:sp>
+      <p:sp>
+        <p:nvSpPr>
+          <p:cNvPr id="9" name="Rectangle 8">
+            <a:extLst>
+              <a:ext uri="{FF2B5EF4-FFF2-40B4-BE49-F238E27FC236}">
+                <a16:creationId xmlns:a16="http://schemas.microsoft.com/office/drawing/2014/main" id="{77853AF3-01FA-0BE0-C594-CC2664B1A70C}"/>
+              </a:ext>
+            </a:extLst>
+          </p:cNvPr>
+          <p:cNvSpPr/>
+          <p:nvPr/>
+        </p:nvSpPr>
+        <p:spPr>
+          <a:xfrm>
+            <a:off x="5241850" y="2724853"/>
+            <a:ext cx="340243" cy="333779"/>
+          </a:xfrm>
+          <a:prstGeom prst="rect">
+            <a:avLst/>
+          </a:prstGeom>
+        </p:spPr>
+        <p:style>
+          <a:lnRef idx="2">
+            <a:schemeClr val="dk1"/>
+          </a:lnRef>
+          <a:fillRef idx="1">
+            <a:schemeClr val="lt1"/>
+          </a:fillRef>
+          <a:effectRef idx="0">
+            <a:schemeClr val="dk1"/>
+          </a:effectRef>
+          <a:fontRef idx="minor">
+            <a:schemeClr val="dk1"/>
+          </a:fontRef>
+        </p:style>
+        <p:txBody>
+          <a:bodyPr rtlCol="0" anchor="ctr"/>
+          <a:lstStyle/>
+          <a:p>
+            <a:pPr algn="ctr"/>
+            <a:r>
+              <a:rPr lang="en-US" sz="1000" dirty="0"/>
+              <a:t>st</a:t>
+            </a:r>
+          </a:p>
+        </p:txBody>
+      </p:sp>
+      <p:cxnSp>
+        <p:nvCxnSpPr>
+          <p:cNvPr id="13" name="Straight Arrow Connector 12">
+            <a:extLst>
+              <a:ext uri="{FF2B5EF4-FFF2-40B4-BE49-F238E27FC236}">
+                <a16:creationId xmlns:a16="http://schemas.microsoft.com/office/drawing/2014/main" id="{56ED1FB0-6F09-2A42-0BB6-074A40FCF304}"/>
+              </a:ext>
+            </a:extLst>
+          </p:cNvPr>
+          <p:cNvCxnSpPr>
+            <a:stCxn id="9" idx="2"/>
+          </p:cNvCxnSpPr>
+          <p:nvPr/>
+        </p:nvCxnSpPr>
+        <p:spPr>
+          <a:xfrm flipH="1">
+            <a:off x="4880344" y="3058632"/>
+            <a:ext cx="531628" cy="330236"/>
+          </a:xfrm>
+          <a:prstGeom prst="straightConnector1">
+            <a:avLst/>
+          </a:prstGeom>
+          <a:ln>
+            <a:tailEnd type="triangle"/>
+          </a:ln>
+        </p:spPr>
+        <p:style>
+          <a:lnRef idx="2">
+            <a:schemeClr val="accent1"/>
+          </a:lnRef>
+          <a:fillRef idx="0">
+            <a:schemeClr val="accent1"/>
+          </a:fillRef>
+          <a:effectRef idx="1">
+            <a:schemeClr val="accent1"/>
+          </a:effectRef>
+          <a:fontRef idx="minor">
+            <a:schemeClr val="tx1"/>
+          </a:fontRef>
+        </p:style>
+      </p:cxnSp>
+      <p:cxnSp>
+        <p:nvCxnSpPr>
+          <p:cNvPr id="14" name="Straight Arrow Connector 13">
+            <a:extLst>
+              <a:ext uri="{FF2B5EF4-FFF2-40B4-BE49-F238E27FC236}">
+                <a16:creationId xmlns:a16="http://schemas.microsoft.com/office/drawing/2014/main" id="{A095CD25-7653-562F-100D-1718C6087C60}"/>
+              </a:ext>
+            </a:extLst>
+          </p:cNvPr>
+          <p:cNvCxnSpPr>
+            <a:cxnSpLocks/>
+            <a:stCxn id="10" idx="2"/>
+          </p:cNvCxnSpPr>
+          <p:nvPr/>
+        </p:nvCxnSpPr>
+        <p:spPr>
+          <a:xfrm flipH="1">
+            <a:off x="5582093" y="3058632"/>
+            <a:ext cx="161259" cy="330236"/>
+          </a:xfrm>
+          <a:prstGeom prst="straightConnector1">
+            <a:avLst/>
+          </a:prstGeom>
+          <a:ln>
+            <a:tailEnd type="triangle"/>
+          </a:ln>
+        </p:spPr>
+        <p:style>
+          <a:lnRef idx="2">
+            <a:schemeClr val="accent1"/>
+          </a:lnRef>
+          <a:fillRef idx="0">
+            <a:schemeClr val="accent1"/>
+          </a:fillRef>
+          <a:effectRef idx="1">
+            <a:schemeClr val="accent1"/>
+          </a:effectRef>
+          <a:fontRef idx="minor">
+            <a:schemeClr val="tx1"/>
+          </a:fontRef>
+        </p:style>
+      </p:cxnSp>
+      <p:cxnSp>
+        <p:nvCxnSpPr>
+          <p:cNvPr id="17" name="Straight Arrow Connector 16">
+            <a:extLst>
+              <a:ext uri="{FF2B5EF4-FFF2-40B4-BE49-F238E27FC236}">
+                <a16:creationId xmlns:a16="http://schemas.microsoft.com/office/drawing/2014/main" id="{0A99FB7C-D806-7012-A6B1-699528B501A5}"/>
+              </a:ext>
+            </a:extLst>
+          </p:cNvPr>
+          <p:cNvCxnSpPr>
+            <a:cxnSpLocks/>
+          </p:cNvCxnSpPr>
+          <p:nvPr/>
+        </p:nvCxnSpPr>
+        <p:spPr>
+          <a:xfrm>
+            <a:off x="6128781" y="3058632"/>
+            <a:ext cx="312782" cy="330236"/>
+          </a:xfrm>
+          <a:prstGeom prst="straightConnector1">
+            <a:avLst/>
+          </a:prstGeom>
+          <a:ln>
+            <a:tailEnd type="triangle"/>
+          </a:ln>
+        </p:spPr>
+        <p:style>
+          <a:lnRef idx="2">
+            <a:schemeClr val="accent1"/>
+          </a:lnRef>
+          <a:fillRef idx="0">
+            <a:schemeClr val="accent1"/>
+          </a:fillRef>
+          <a:effectRef idx="1">
+            <a:schemeClr val="accent1"/>
+          </a:effectRef>
+          <a:fontRef idx="minor">
+            <a:schemeClr val="tx1"/>
+          </a:fontRef>
+        </p:style>
+      </p:cxnSp>
+      <p:sp>
+        <p:nvSpPr>
+          <p:cNvPr id="19" name="Rectangle 18">
+            <a:extLst>
+              <a:ext uri="{FF2B5EF4-FFF2-40B4-BE49-F238E27FC236}">
+                <a16:creationId xmlns:a16="http://schemas.microsoft.com/office/drawing/2014/main" id="{487280E4-0284-34B2-3EEB-B565FB39571B}"/>
+              </a:ext>
+            </a:extLst>
+          </p:cNvPr>
+          <p:cNvSpPr/>
+          <p:nvPr/>
+        </p:nvSpPr>
+        <p:spPr>
+          <a:xfrm>
+            <a:off x="4901607" y="3434317"/>
+            <a:ext cx="680486" cy="326064"/>
+          </a:xfrm>
+          <a:prstGeom prst="rect">
+            <a:avLst/>
+          </a:prstGeom>
+        </p:spPr>
+        <p:style>
+          <a:lnRef idx="2">
+            <a:schemeClr val="dk1"/>
+          </a:lnRef>
+          <a:fillRef idx="1">
+            <a:schemeClr val="lt1"/>
+          </a:fillRef>
+          <a:effectRef idx="0">
+            <a:schemeClr val="dk1"/>
+          </a:effectRef>
+          <a:fontRef idx="minor">
+            <a:schemeClr val="dk1"/>
+          </a:fontRef>
+        </p:style>
+        <p:txBody>
+          <a:bodyPr rtlCol="0" anchor="ctr"/>
+          <a:lstStyle/>
+          <a:p>
+            <a:pPr algn="ctr"/>
+            <a:r>
+              <a:rPr lang="en-US" dirty="0"/>
+              <a:t>S</a:t>
+            </a:r>
+          </a:p>
+        </p:txBody>
+      </p:sp>
+      <p:sp>
+        <p:nvSpPr>
+          <p:cNvPr id="20" name="Rectangle 19">
+            <a:extLst>
+              <a:ext uri="{FF2B5EF4-FFF2-40B4-BE49-F238E27FC236}">
+                <a16:creationId xmlns:a16="http://schemas.microsoft.com/office/drawing/2014/main" id="{25B4C3A5-B3BE-170A-99D2-8B0856E5E500}"/>
+              </a:ext>
+            </a:extLst>
+          </p:cNvPr>
+          <p:cNvSpPr/>
+          <p:nvPr/>
+        </p:nvSpPr>
+        <p:spPr>
+          <a:xfrm>
+            <a:off x="5583419" y="3426601"/>
+            <a:ext cx="858143" cy="333779"/>
+          </a:xfrm>
+          <a:prstGeom prst="rect">
+            <a:avLst/>
+          </a:prstGeom>
+        </p:spPr>
+        <p:style>
+          <a:lnRef idx="2">
+            <a:schemeClr val="dk1"/>
+          </a:lnRef>
+          <a:fillRef idx="1">
+            <a:schemeClr val="lt1"/>
+          </a:fillRef>
+          <a:effectRef idx="0">
+            <a:schemeClr val="dk1"/>
+          </a:effectRef>
+          <a:fontRef idx="minor">
+            <a:schemeClr val="dk1"/>
+          </a:fontRef>
+        </p:style>
+        <p:txBody>
+          <a:bodyPr rtlCol="0" anchor="ctr"/>
+          <a:lstStyle/>
+          <a:p>
+            <a:pPr algn="ctr"/>
+            <a:r>
+              <a:rPr lang="en-US" dirty="0"/>
+              <a:t>C</a:t>
+            </a:r>
+          </a:p>
+        </p:txBody>
+      </p:sp>
+      <p:sp>
+        <p:nvSpPr>
+          <p:cNvPr id="21" name="TextBox 20">
+            <a:extLst>
+              <a:ext uri="{FF2B5EF4-FFF2-40B4-BE49-F238E27FC236}">
+                <a16:creationId xmlns:a16="http://schemas.microsoft.com/office/drawing/2014/main" id="{9CE7B755-A61D-574A-7B33-7CF52DA71D78}"/>
+              </a:ext>
+            </a:extLst>
+          </p:cNvPr>
+          <p:cNvSpPr txBox="1"/>
+          <p:nvPr/>
+        </p:nvSpPr>
+        <p:spPr>
+          <a:xfrm>
+            <a:off x="659219" y="2743200"/>
+            <a:ext cx="947760" cy="369332"/>
+          </a:xfrm>
+          <a:prstGeom prst="rect">
+            <a:avLst/>
+          </a:prstGeom>
+          <a:noFill/>
+        </p:spPr>
+        <p:txBody>
+          <a:bodyPr wrap="none" rtlCol="0">
+            <a:spAutoFit/>
+          </a:bodyPr>
+          <a:lstStyle/>
+          <a:p>
+            <a:r>
+              <a:rPr lang="en-US" dirty="0"/>
+              <a:t>Current</a:t>
+            </a:r>
+          </a:p>
+        </p:txBody>
+      </p:sp>
+    </p:spTree>
+    <p:extLst>
+      <p:ext uri="{BB962C8B-B14F-4D97-AF65-F5344CB8AC3E}">
+        <p14:creationId xmlns:p14="http://schemas.microsoft.com/office/powerpoint/2010/main" val="3140495341"/>
+      </p:ext>
+    </p:extLst>
+  </p:cSld>
+  <p:clrMapOvr>
+    <a:masterClrMapping/>
+  </p:clrMapOvr>
+</p:sld>
+</file>
+
 <file path=ppt/theme/theme1.xml><?xml version="1.0" encoding="utf-8"?>
 <a:theme xmlns:a="http://schemas.openxmlformats.org/drawingml/2006/main" name="Office Theme">
   <a:themeElements>

</xml_diff>

<commit_message>
auto commit 2026-06-28 15:20:34
</commit_message>
<xml_diff>
--- a/revision [Autosaved].pptx
+++ b/revision [Autosaved].pptx
@@ -15,6 +15,10 @@
     <p:sldId id="263" r:id="rId9"/>
     <p:sldId id="264" r:id="rId10"/>
     <p:sldId id="265" r:id="rId11"/>
+    <p:sldId id="266" r:id="rId12"/>
+    <p:sldId id="267" r:id="rId13"/>
+    <p:sldId id="268" r:id="rId14"/>
+    <p:sldId id="269" r:id="rId15"/>
   </p:sldIdLst>
   <p:sldSz cx="12192000" cy="6858000"/>
   <p:notesSz cx="6858000" cy="9144000"/>
@@ -5555,6 +5559,1969 @@
     <p:extLst>
       <p:ext uri="{BB962C8B-B14F-4D97-AF65-F5344CB8AC3E}">
         <p14:creationId xmlns:p14="http://schemas.microsoft.com/office/powerpoint/2010/main" val="1485236632"/>
+      </p:ext>
+    </p:extLst>
+  </p:cSld>
+  <p:clrMapOvr>
+    <a:masterClrMapping/>
+  </p:clrMapOvr>
+</p:sld>
+</file>
+
+<file path=ppt/slides/slide11.xml><?xml version="1.0" encoding="utf-8"?>
+<p:sld xmlns:a="http://schemas.openxmlformats.org/drawingml/2006/main" xmlns:r="http://schemas.openxmlformats.org/officeDocument/2006/relationships" xmlns:p="http://schemas.openxmlformats.org/presentationml/2006/main">
+  <p:cSld>
+    <p:spTree>
+      <p:nvGrpSpPr>
+        <p:cNvPr id="1" name=""/>
+        <p:cNvGrpSpPr/>
+        <p:nvPr/>
+      </p:nvGrpSpPr>
+      <p:grpSpPr>
+        <a:xfrm>
+          <a:off x="0" y="0"/>
+          <a:ext cx="0" cy="0"/>
+          <a:chOff x="0" y="0"/>
+          <a:chExt cx="0" cy="0"/>
+        </a:xfrm>
+      </p:grpSpPr>
+      <p:pic>
+        <p:nvPicPr>
+          <p:cNvPr id="36" name="Picture 35">
+            <a:extLst>
+              <a:ext uri="{FF2B5EF4-FFF2-40B4-BE49-F238E27FC236}">
+                <a16:creationId xmlns:a16="http://schemas.microsoft.com/office/drawing/2014/main" id="{E5CE3626-FB0A-692A-F035-A1DF78C2178A}"/>
+              </a:ext>
+            </a:extLst>
+          </p:cNvPr>
+          <p:cNvPicPr>
+            <a:picLocks noChangeAspect="1"/>
+          </p:cNvPicPr>
+          <p:nvPr/>
+        </p:nvPicPr>
+        <p:blipFill>
+          <a:blip r:embed="rId2"/>
+          <a:stretch>
+            <a:fillRect/>
+          </a:stretch>
+        </p:blipFill>
+        <p:spPr>
+          <a:xfrm>
+            <a:off x="5098602" y="0"/>
+            <a:ext cx="6603274" cy="6858000"/>
+          </a:xfrm>
+          <a:prstGeom prst="rect">
+            <a:avLst/>
+          </a:prstGeom>
+        </p:spPr>
+      </p:pic>
+      <p:sp>
+        <p:nvSpPr>
+          <p:cNvPr id="2" name="Title 1">
+            <a:extLst>
+              <a:ext uri="{FF2B5EF4-FFF2-40B4-BE49-F238E27FC236}">
+                <a16:creationId xmlns:a16="http://schemas.microsoft.com/office/drawing/2014/main" id="{34150E0C-EF31-9E3B-653E-154243818C07}"/>
+              </a:ext>
+            </a:extLst>
+          </p:cNvPr>
+          <p:cNvSpPr>
+            <a:spLocks noGrp="1"/>
+          </p:cNvSpPr>
+          <p:nvPr>
+            <p:ph type="title"/>
+          </p:nvPr>
+        </p:nvSpPr>
+        <p:spPr/>
+        <p:txBody>
+          <a:bodyPr/>
+          <a:lstStyle/>
+          <a:p>
+            <a:r>
+              <a:rPr lang="en-US" dirty="0"/>
+              <a:t>Scratch Buffer</a:t>
+            </a:r>
+          </a:p>
+        </p:txBody>
+      </p:sp>
+      <p:graphicFrame>
+        <p:nvGraphicFramePr>
+          <p:cNvPr id="31" name="Content Placeholder 3">
+            <a:extLst>
+              <a:ext uri="{FF2B5EF4-FFF2-40B4-BE49-F238E27FC236}">
+                <a16:creationId xmlns:a16="http://schemas.microsoft.com/office/drawing/2014/main" id="{19DFFE26-B75F-43CD-55F5-9E3EA43815AA}"/>
+              </a:ext>
+            </a:extLst>
+          </p:cNvPr>
+          <p:cNvGraphicFramePr>
+            <a:graphicFrameLocks/>
+          </p:cNvGraphicFramePr>
+          <p:nvPr>
+            <p:extLst>
+              <p:ext uri="{D42A27DB-BD31-4B8C-83A1-F6EECF244321}">
+                <p14:modId xmlns:p14="http://schemas.microsoft.com/office/powerpoint/2010/main" val="2542223225"/>
+              </p:ext>
+            </p:extLst>
+          </p:nvPr>
+        </p:nvGraphicFramePr>
+        <p:xfrm>
+          <a:off x="5219609" y="860756"/>
+          <a:ext cx="3180630" cy="438359"/>
+        </p:xfrm>
+        <a:graphic>
+          <a:graphicData uri="http://schemas.openxmlformats.org/drawingml/2006/table">
+            <a:tbl>
+              <a:tblPr firstRow="1" bandRow="1">
+                <a:tableStyleId>{5940675A-B579-460E-94D1-54222C63F5DA}</a:tableStyleId>
+              </a:tblPr>
+              <a:tblGrid>
+                <a:gridCol w="636126">
+                  <a:extLst>
+                    <a:ext uri="{9D8B030D-6E8A-4147-A177-3AD203B41FA5}">
+                      <a16:colId xmlns:a16="http://schemas.microsoft.com/office/drawing/2014/main" val="194980701"/>
+                    </a:ext>
+                  </a:extLst>
+                </a:gridCol>
+                <a:gridCol w="636126">
+                  <a:extLst>
+                    <a:ext uri="{9D8B030D-6E8A-4147-A177-3AD203B41FA5}">
+                      <a16:colId xmlns:a16="http://schemas.microsoft.com/office/drawing/2014/main" val="2814616541"/>
+                    </a:ext>
+                  </a:extLst>
+                </a:gridCol>
+                <a:gridCol w="636126">
+                  <a:extLst>
+                    <a:ext uri="{9D8B030D-6E8A-4147-A177-3AD203B41FA5}">
+                      <a16:colId xmlns:a16="http://schemas.microsoft.com/office/drawing/2014/main" val="3925629564"/>
+                    </a:ext>
+                  </a:extLst>
+                </a:gridCol>
+                <a:gridCol w="636126">
+                  <a:extLst>
+                    <a:ext uri="{9D8B030D-6E8A-4147-A177-3AD203B41FA5}">
+                      <a16:colId xmlns:a16="http://schemas.microsoft.com/office/drawing/2014/main" val="505726368"/>
+                    </a:ext>
+                  </a:extLst>
+                </a:gridCol>
+                <a:gridCol w="636126">
+                  <a:extLst>
+                    <a:ext uri="{9D8B030D-6E8A-4147-A177-3AD203B41FA5}">
+                      <a16:colId xmlns:a16="http://schemas.microsoft.com/office/drawing/2014/main" val="3268241414"/>
+                    </a:ext>
+                  </a:extLst>
+                </a:gridCol>
+              </a:tblGrid>
+              <a:tr h="438359">
+                <a:tc>
+                  <a:txBody>
+                    <a:bodyPr/>
+                    <a:lstStyle/>
+                    <a:p>
+                      <a:pPr algn="ctr"/>
+                      <a:endParaRPr lang="en-US"/>
+                    </a:p>
+                  </a:txBody>
+                  <a:tcPr/>
+                </a:tc>
+                <a:tc>
+                  <a:txBody>
+                    <a:bodyPr/>
+                    <a:lstStyle/>
+                    <a:p>
+                      <a:pPr algn="ctr"/>
+                      <a:endParaRPr lang="en-US" dirty="0"/>
+                    </a:p>
+                  </a:txBody>
+                  <a:tcPr/>
+                </a:tc>
+                <a:tc>
+                  <a:txBody>
+                    <a:bodyPr/>
+                    <a:lstStyle/>
+                    <a:p>
+                      <a:pPr algn="ctr"/>
+                      <a:r>
+                        <a:rPr lang="en-US" dirty="0"/>
+                        <a:t>v</a:t>
+                      </a:r>
+                    </a:p>
+                  </a:txBody>
+                  <a:tcPr/>
+                </a:tc>
+                <a:tc>
+                  <a:txBody>
+                    <a:bodyPr/>
+                    <a:lstStyle/>
+                    <a:p>
+                      <a:pPr algn="ctr"/>
+                      <a:endParaRPr lang="en-US" dirty="0"/>
+                    </a:p>
+                  </a:txBody>
+                  <a:tcPr/>
+                </a:tc>
+                <a:tc>
+                  <a:txBody>
+                    <a:bodyPr/>
+                    <a:lstStyle/>
+                    <a:p>
+                      <a:pPr algn="ctr"/>
+                      <a:endParaRPr lang="en-US" dirty="0"/>
+                    </a:p>
+                  </a:txBody>
+                  <a:tcPr/>
+                </a:tc>
+                <a:extLst>
+                  <a:ext uri="{0D108BD9-81ED-4DB2-BD59-A6C34878D82A}">
+                    <a16:rowId xmlns:a16="http://schemas.microsoft.com/office/drawing/2014/main" val="2287342528"/>
+                  </a:ext>
+                </a:extLst>
+              </a:tr>
+            </a:tbl>
+          </a:graphicData>
+        </a:graphic>
+      </p:graphicFrame>
+      <p:sp>
+        <p:nvSpPr>
+          <p:cNvPr id="32" name="TextBox 31">
+            <a:extLst>
+              <a:ext uri="{FF2B5EF4-FFF2-40B4-BE49-F238E27FC236}">
+                <a16:creationId xmlns:a16="http://schemas.microsoft.com/office/drawing/2014/main" id="{CD8A8E56-B852-AB89-A094-0ABE1BBE77BC}"/>
+              </a:ext>
+            </a:extLst>
+          </p:cNvPr>
+          <p:cNvSpPr txBox="1"/>
+          <p:nvPr/>
+        </p:nvSpPr>
+        <p:spPr>
+          <a:xfrm>
+            <a:off x="5993706" y="374835"/>
+            <a:ext cx="1756127" cy="369332"/>
+          </a:xfrm>
+          <a:prstGeom prst="rect">
+            <a:avLst/>
+          </a:prstGeom>
+          <a:noFill/>
+        </p:spPr>
+        <p:txBody>
+          <a:bodyPr wrap="square" rtlCol="0">
+            <a:spAutoFit/>
+          </a:bodyPr>
+          <a:lstStyle/>
+          <a:p>
+            <a:r>
+              <a:rPr lang="en-US" dirty="0"/>
+              <a:t>top level tasks</a:t>
+            </a:r>
+          </a:p>
+        </p:txBody>
+      </p:sp>
+      <p:sp>
+        <p:nvSpPr>
+          <p:cNvPr id="33" name="Rectangle 32">
+            <a:extLst>
+              <a:ext uri="{FF2B5EF4-FFF2-40B4-BE49-F238E27FC236}">
+                <a16:creationId xmlns:a16="http://schemas.microsoft.com/office/drawing/2014/main" id="{2B306A4D-FDE3-C800-7E1C-84906394F217}"/>
+              </a:ext>
+            </a:extLst>
+          </p:cNvPr>
+          <p:cNvSpPr/>
+          <p:nvPr/>
+        </p:nvSpPr>
+        <p:spPr>
+          <a:xfrm>
+            <a:off x="6358791" y="1515328"/>
+            <a:ext cx="908197" cy="558836"/>
+          </a:xfrm>
+          <a:prstGeom prst="rect">
+            <a:avLst/>
+          </a:prstGeom>
+          <a:ln>
+            <a:prstDash val="dash"/>
+          </a:ln>
+        </p:spPr>
+        <p:style>
+          <a:lnRef idx="2">
+            <a:schemeClr val="dk1"/>
+          </a:lnRef>
+          <a:fillRef idx="1">
+            <a:schemeClr val="lt1"/>
+          </a:fillRef>
+          <a:effectRef idx="0">
+            <a:schemeClr val="dk1"/>
+          </a:effectRef>
+          <a:fontRef idx="minor">
+            <a:schemeClr val="dk1"/>
+          </a:fontRef>
+        </p:style>
+        <p:txBody>
+          <a:bodyPr rtlCol="0" anchor="ctr"/>
+          <a:lstStyle/>
+          <a:p>
+            <a:pPr algn="ctr"/>
+            <a:r>
+              <a:rPr lang="en-US" dirty="0"/>
+              <a:t>2-hop neigh</a:t>
+            </a:r>
+          </a:p>
+        </p:txBody>
+      </p:sp>
+      <p:cxnSp>
+        <p:nvCxnSpPr>
+          <p:cNvPr id="34" name="Straight Connector 33">
+            <a:extLst>
+              <a:ext uri="{FF2B5EF4-FFF2-40B4-BE49-F238E27FC236}">
+                <a16:creationId xmlns:a16="http://schemas.microsoft.com/office/drawing/2014/main" id="{ADA448AB-F1BC-2284-B2BB-209FB2E9000F}"/>
+              </a:ext>
+            </a:extLst>
+          </p:cNvPr>
+          <p:cNvCxnSpPr>
+            <a:cxnSpLocks/>
+            <a:stCxn id="31" idx="2"/>
+            <a:endCxn id="33" idx="0"/>
+          </p:cNvCxnSpPr>
+          <p:nvPr/>
+        </p:nvCxnSpPr>
+        <p:spPr>
+          <a:xfrm>
+            <a:off x="6809924" y="1299115"/>
+            <a:ext cx="2966" cy="216213"/>
+          </a:xfrm>
+          <a:prstGeom prst="line">
+            <a:avLst/>
+          </a:prstGeom>
+        </p:spPr>
+        <p:style>
+          <a:lnRef idx="2">
+            <a:schemeClr val="accent1"/>
+          </a:lnRef>
+          <a:fillRef idx="0">
+            <a:schemeClr val="accent1"/>
+          </a:fillRef>
+          <a:effectRef idx="1">
+            <a:schemeClr val="accent1"/>
+          </a:effectRef>
+          <a:fontRef idx="minor">
+            <a:schemeClr val="tx1"/>
+          </a:fontRef>
+        </p:style>
+      </p:cxnSp>
+    </p:spTree>
+    <p:extLst>
+      <p:ext uri="{BB962C8B-B14F-4D97-AF65-F5344CB8AC3E}">
+        <p14:creationId xmlns:p14="http://schemas.microsoft.com/office/powerpoint/2010/main" val="79774286"/>
+      </p:ext>
+    </p:extLst>
+  </p:cSld>
+  <p:clrMapOvr>
+    <a:masterClrMapping/>
+  </p:clrMapOvr>
+</p:sld>
+</file>
+
+<file path=ppt/slides/slide12.xml><?xml version="1.0" encoding="utf-8"?>
+<p:sld xmlns:a="http://schemas.openxmlformats.org/drawingml/2006/main" xmlns:r="http://schemas.openxmlformats.org/officeDocument/2006/relationships" xmlns:p="http://schemas.openxmlformats.org/presentationml/2006/main">
+  <p:cSld>
+    <p:spTree>
+      <p:nvGrpSpPr>
+        <p:cNvPr id="1" name="">
+          <a:extLst>
+            <a:ext uri="{FF2B5EF4-FFF2-40B4-BE49-F238E27FC236}">
+              <a16:creationId xmlns:a16="http://schemas.microsoft.com/office/drawing/2014/main" id="{CEA5A725-C0FB-AFBB-BD77-C989D1102897}"/>
+            </a:ext>
+          </a:extLst>
+        </p:cNvPr>
+        <p:cNvGrpSpPr/>
+        <p:nvPr/>
+      </p:nvGrpSpPr>
+      <p:grpSpPr>
+        <a:xfrm>
+          <a:off x="0" y="0"/>
+          <a:ext cx="0" cy="0"/>
+          <a:chOff x="0" y="0"/>
+          <a:chExt cx="0" cy="0"/>
+        </a:xfrm>
+      </p:grpSpPr>
+      <p:pic>
+        <p:nvPicPr>
+          <p:cNvPr id="36" name="Picture 35">
+            <a:extLst>
+              <a:ext uri="{FF2B5EF4-FFF2-40B4-BE49-F238E27FC236}">
+                <a16:creationId xmlns:a16="http://schemas.microsoft.com/office/drawing/2014/main" id="{F65E09FD-86C3-B452-444F-53A4F6F7658F}"/>
+              </a:ext>
+            </a:extLst>
+          </p:cNvPr>
+          <p:cNvPicPr>
+            <a:picLocks noChangeAspect="1"/>
+          </p:cNvPicPr>
+          <p:nvPr/>
+        </p:nvPicPr>
+        <p:blipFill>
+          <a:blip r:embed="rId2"/>
+          <a:stretch>
+            <a:fillRect/>
+          </a:stretch>
+        </p:blipFill>
+        <p:spPr>
+          <a:xfrm>
+            <a:off x="5098602" y="0"/>
+            <a:ext cx="6603274" cy="6858000"/>
+          </a:xfrm>
+          <a:prstGeom prst="rect">
+            <a:avLst/>
+          </a:prstGeom>
+        </p:spPr>
+      </p:pic>
+      <p:sp>
+        <p:nvSpPr>
+          <p:cNvPr id="2" name="Title 1">
+            <a:extLst>
+              <a:ext uri="{FF2B5EF4-FFF2-40B4-BE49-F238E27FC236}">
+                <a16:creationId xmlns:a16="http://schemas.microsoft.com/office/drawing/2014/main" id="{252F1B3E-B919-6AAB-EBA8-2232CDA90401}"/>
+              </a:ext>
+            </a:extLst>
+          </p:cNvPr>
+          <p:cNvSpPr>
+            <a:spLocks noGrp="1"/>
+          </p:cNvSpPr>
+          <p:nvPr>
+            <p:ph type="title"/>
+          </p:nvPr>
+        </p:nvSpPr>
+        <p:spPr/>
+        <p:txBody>
+          <a:bodyPr/>
+          <a:lstStyle/>
+          <a:p>
+            <a:r>
+              <a:rPr lang="en-US" dirty="0"/>
+              <a:t>Scratch Buffer</a:t>
+            </a:r>
+          </a:p>
+        </p:txBody>
+      </p:sp>
+      <p:graphicFrame>
+        <p:nvGraphicFramePr>
+          <p:cNvPr id="31" name="Content Placeholder 3">
+            <a:extLst>
+              <a:ext uri="{FF2B5EF4-FFF2-40B4-BE49-F238E27FC236}">
+                <a16:creationId xmlns:a16="http://schemas.microsoft.com/office/drawing/2014/main" id="{F7BEEAA0-DB71-CB33-8F1C-7F30FD0FB0F1}"/>
+              </a:ext>
+            </a:extLst>
+          </p:cNvPr>
+          <p:cNvGraphicFramePr>
+            <a:graphicFrameLocks/>
+          </p:cNvGraphicFramePr>
+          <p:nvPr/>
+        </p:nvGraphicFramePr>
+        <p:xfrm>
+          <a:off x="5219609" y="860756"/>
+          <a:ext cx="3180630" cy="438359"/>
+        </p:xfrm>
+        <a:graphic>
+          <a:graphicData uri="http://schemas.openxmlformats.org/drawingml/2006/table">
+            <a:tbl>
+              <a:tblPr firstRow="1" bandRow="1">
+                <a:tableStyleId>{5940675A-B579-460E-94D1-54222C63F5DA}</a:tableStyleId>
+              </a:tblPr>
+              <a:tblGrid>
+                <a:gridCol w="636126">
+                  <a:extLst>
+                    <a:ext uri="{9D8B030D-6E8A-4147-A177-3AD203B41FA5}">
+                      <a16:colId xmlns:a16="http://schemas.microsoft.com/office/drawing/2014/main" val="194980701"/>
+                    </a:ext>
+                  </a:extLst>
+                </a:gridCol>
+                <a:gridCol w="636126">
+                  <a:extLst>
+                    <a:ext uri="{9D8B030D-6E8A-4147-A177-3AD203B41FA5}">
+                      <a16:colId xmlns:a16="http://schemas.microsoft.com/office/drawing/2014/main" val="2814616541"/>
+                    </a:ext>
+                  </a:extLst>
+                </a:gridCol>
+                <a:gridCol w="636126">
+                  <a:extLst>
+                    <a:ext uri="{9D8B030D-6E8A-4147-A177-3AD203B41FA5}">
+                      <a16:colId xmlns:a16="http://schemas.microsoft.com/office/drawing/2014/main" val="3925629564"/>
+                    </a:ext>
+                  </a:extLst>
+                </a:gridCol>
+                <a:gridCol w="636126">
+                  <a:extLst>
+                    <a:ext uri="{9D8B030D-6E8A-4147-A177-3AD203B41FA5}">
+                      <a16:colId xmlns:a16="http://schemas.microsoft.com/office/drawing/2014/main" val="505726368"/>
+                    </a:ext>
+                  </a:extLst>
+                </a:gridCol>
+                <a:gridCol w="636126">
+                  <a:extLst>
+                    <a:ext uri="{9D8B030D-6E8A-4147-A177-3AD203B41FA5}">
+                      <a16:colId xmlns:a16="http://schemas.microsoft.com/office/drawing/2014/main" val="3268241414"/>
+                    </a:ext>
+                  </a:extLst>
+                </a:gridCol>
+              </a:tblGrid>
+              <a:tr h="438359">
+                <a:tc>
+                  <a:txBody>
+                    <a:bodyPr/>
+                    <a:lstStyle/>
+                    <a:p>
+                      <a:pPr algn="ctr"/>
+                      <a:endParaRPr lang="en-US"/>
+                    </a:p>
+                  </a:txBody>
+                  <a:tcPr/>
+                </a:tc>
+                <a:tc>
+                  <a:txBody>
+                    <a:bodyPr/>
+                    <a:lstStyle/>
+                    <a:p>
+                      <a:pPr algn="ctr"/>
+                      <a:endParaRPr lang="en-US" dirty="0"/>
+                    </a:p>
+                  </a:txBody>
+                  <a:tcPr/>
+                </a:tc>
+                <a:tc>
+                  <a:txBody>
+                    <a:bodyPr/>
+                    <a:lstStyle/>
+                    <a:p>
+                      <a:pPr algn="ctr"/>
+                      <a:r>
+                        <a:rPr lang="en-US" dirty="0"/>
+                        <a:t>v</a:t>
+                      </a:r>
+                    </a:p>
+                  </a:txBody>
+                  <a:tcPr/>
+                </a:tc>
+                <a:tc>
+                  <a:txBody>
+                    <a:bodyPr/>
+                    <a:lstStyle/>
+                    <a:p>
+                      <a:pPr algn="ctr"/>
+                      <a:endParaRPr lang="en-US" dirty="0"/>
+                    </a:p>
+                  </a:txBody>
+                  <a:tcPr/>
+                </a:tc>
+                <a:tc>
+                  <a:txBody>
+                    <a:bodyPr/>
+                    <a:lstStyle/>
+                    <a:p>
+                      <a:pPr algn="ctr"/>
+                      <a:endParaRPr lang="en-US" dirty="0"/>
+                    </a:p>
+                  </a:txBody>
+                  <a:tcPr/>
+                </a:tc>
+                <a:extLst>
+                  <a:ext uri="{0D108BD9-81ED-4DB2-BD59-A6C34878D82A}">
+                    <a16:rowId xmlns:a16="http://schemas.microsoft.com/office/drawing/2014/main" val="2287342528"/>
+                  </a:ext>
+                </a:extLst>
+              </a:tr>
+            </a:tbl>
+          </a:graphicData>
+        </a:graphic>
+      </p:graphicFrame>
+      <p:sp>
+        <p:nvSpPr>
+          <p:cNvPr id="32" name="TextBox 31">
+            <a:extLst>
+              <a:ext uri="{FF2B5EF4-FFF2-40B4-BE49-F238E27FC236}">
+                <a16:creationId xmlns:a16="http://schemas.microsoft.com/office/drawing/2014/main" id="{DD450443-76AA-47EF-8518-82CDF232C420}"/>
+              </a:ext>
+            </a:extLst>
+          </p:cNvPr>
+          <p:cNvSpPr txBox="1"/>
+          <p:nvPr/>
+        </p:nvSpPr>
+        <p:spPr>
+          <a:xfrm>
+            <a:off x="5993706" y="374835"/>
+            <a:ext cx="1756127" cy="369332"/>
+          </a:xfrm>
+          <a:prstGeom prst="rect">
+            <a:avLst/>
+          </a:prstGeom>
+          <a:noFill/>
+        </p:spPr>
+        <p:txBody>
+          <a:bodyPr wrap="square" rtlCol="0">
+            <a:spAutoFit/>
+          </a:bodyPr>
+          <a:lstStyle/>
+          <a:p>
+            <a:r>
+              <a:rPr lang="en-US" dirty="0"/>
+              <a:t>top level tasks</a:t>
+            </a:r>
+          </a:p>
+        </p:txBody>
+      </p:sp>
+      <p:sp>
+        <p:nvSpPr>
+          <p:cNvPr id="33" name="Rectangle 32">
+            <a:extLst>
+              <a:ext uri="{FF2B5EF4-FFF2-40B4-BE49-F238E27FC236}">
+                <a16:creationId xmlns:a16="http://schemas.microsoft.com/office/drawing/2014/main" id="{F3DF527D-D515-F294-E1EC-14ED18FFC723}"/>
+              </a:ext>
+            </a:extLst>
+          </p:cNvPr>
+          <p:cNvSpPr/>
+          <p:nvPr/>
+        </p:nvSpPr>
+        <p:spPr>
+          <a:xfrm>
+            <a:off x="6358791" y="1515328"/>
+            <a:ext cx="908197" cy="558836"/>
+          </a:xfrm>
+          <a:prstGeom prst="rect">
+            <a:avLst/>
+          </a:prstGeom>
+          <a:ln>
+            <a:prstDash val="dash"/>
+          </a:ln>
+        </p:spPr>
+        <p:style>
+          <a:lnRef idx="2">
+            <a:schemeClr val="dk1"/>
+          </a:lnRef>
+          <a:fillRef idx="1">
+            <a:schemeClr val="lt1"/>
+          </a:fillRef>
+          <a:effectRef idx="0">
+            <a:schemeClr val="dk1"/>
+          </a:effectRef>
+          <a:fontRef idx="minor">
+            <a:schemeClr val="dk1"/>
+          </a:fontRef>
+        </p:style>
+        <p:txBody>
+          <a:bodyPr rtlCol="0" anchor="ctr"/>
+          <a:lstStyle/>
+          <a:p>
+            <a:pPr algn="ctr"/>
+            <a:r>
+              <a:rPr lang="en-US" dirty="0"/>
+              <a:t>2-hop neigh</a:t>
+            </a:r>
+          </a:p>
+        </p:txBody>
+      </p:sp>
+      <p:cxnSp>
+        <p:nvCxnSpPr>
+          <p:cNvPr id="34" name="Straight Connector 33">
+            <a:extLst>
+              <a:ext uri="{FF2B5EF4-FFF2-40B4-BE49-F238E27FC236}">
+                <a16:creationId xmlns:a16="http://schemas.microsoft.com/office/drawing/2014/main" id="{F4BC0C70-8964-A7F5-37A8-04C08D4E0EBC}"/>
+              </a:ext>
+            </a:extLst>
+          </p:cNvPr>
+          <p:cNvCxnSpPr>
+            <a:cxnSpLocks/>
+            <a:stCxn id="31" idx="2"/>
+            <a:endCxn id="33" idx="0"/>
+          </p:cNvCxnSpPr>
+          <p:nvPr/>
+        </p:nvCxnSpPr>
+        <p:spPr>
+          <a:xfrm>
+            <a:off x="6809924" y="1299115"/>
+            <a:ext cx="2966" cy="216213"/>
+          </a:xfrm>
+          <a:prstGeom prst="line">
+            <a:avLst/>
+          </a:prstGeom>
+        </p:spPr>
+        <p:style>
+          <a:lnRef idx="2">
+            <a:schemeClr val="accent1"/>
+          </a:lnRef>
+          <a:fillRef idx="0">
+            <a:schemeClr val="accent1"/>
+          </a:fillRef>
+          <a:effectRef idx="1">
+            <a:schemeClr val="accent1"/>
+          </a:effectRef>
+          <a:fontRef idx="minor">
+            <a:schemeClr val="tx1"/>
+          </a:fontRef>
+        </p:style>
+      </p:cxnSp>
+      <p:sp>
+        <p:nvSpPr>
+          <p:cNvPr id="4" name="TextBox 3">
+            <a:extLst>
+              <a:ext uri="{FF2B5EF4-FFF2-40B4-BE49-F238E27FC236}">
+                <a16:creationId xmlns:a16="http://schemas.microsoft.com/office/drawing/2014/main" id="{59088A7C-78EB-F510-6A5A-607DA4322B1B}"/>
+              </a:ext>
+            </a:extLst>
+          </p:cNvPr>
+          <p:cNvSpPr txBox="1"/>
+          <p:nvPr/>
+        </p:nvSpPr>
+        <p:spPr>
+          <a:xfrm>
+            <a:off x="1709998" y="3289727"/>
+            <a:ext cx="1850571" cy="369332"/>
+          </a:xfrm>
+          <a:prstGeom prst="rect">
+            <a:avLst/>
+          </a:prstGeom>
+          <a:noFill/>
+        </p:spPr>
+        <p:txBody>
+          <a:bodyPr wrap="square" rtlCol="0">
+            <a:spAutoFit/>
+          </a:bodyPr>
+          <a:lstStyle/>
+          <a:p>
+            <a:r>
+              <a:rPr lang="en-US" dirty="0"/>
+              <a:t>per warp scratch</a:t>
+            </a:r>
+          </a:p>
+        </p:txBody>
+      </p:sp>
+      <p:sp>
+        <p:nvSpPr>
+          <p:cNvPr id="5" name="TextBox 4">
+            <a:extLst>
+              <a:ext uri="{FF2B5EF4-FFF2-40B4-BE49-F238E27FC236}">
+                <a16:creationId xmlns:a16="http://schemas.microsoft.com/office/drawing/2014/main" id="{58D53A03-19D4-3309-7501-A43EB6713F89}"/>
+              </a:ext>
+            </a:extLst>
+          </p:cNvPr>
+          <p:cNvSpPr txBox="1"/>
+          <p:nvPr/>
+        </p:nvSpPr>
+        <p:spPr>
+          <a:xfrm>
+            <a:off x="1172184" y="3576806"/>
+            <a:ext cx="2953501" cy="369332"/>
+          </a:xfrm>
+          <a:prstGeom prst="rect">
+            <a:avLst/>
+          </a:prstGeom>
+          <a:noFill/>
+        </p:spPr>
+        <p:txBody>
+          <a:bodyPr wrap="none" rtlCol="0">
+            <a:spAutoFit/>
+          </a:bodyPr>
+          <a:lstStyle/>
+          <a:p>
+            <a:r>
+              <a:rPr lang="en-US" dirty="0"/>
+              <a:t>with 32000 it sums to 6.5GB</a:t>
+            </a:r>
+          </a:p>
+        </p:txBody>
+      </p:sp>
+    </p:spTree>
+    <p:extLst>
+      <p:ext uri="{BB962C8B-B14F-4D97-AF65-F5344CB8AC3E}">
+        <p14:creationId xmlns:p14="http://schemas.microsoft.com/office/powerpoint/2010/main" val="167228868"/>
+      </p:ext>
+    </p:extLst>
+  </p:cSld>
+  <p:clrMapOvr>
+    <a:masterClrMapping/>
+  </p:clrMapOvr>
+</p:sld>
+</file>
+
+<file path=ppt/slides/slide13.xml><?xml version="1.0" encoding="utf-8"?>
+<p:sld xmlns:a="http://schemas.openxmlformats.org/drawingml/2006/main" xmlns:r="http://schemas.openxmlformats.org/officeDocument/2006/relationships" xmlns:p="http://schemas.openxmlformats.org/presentationml/2006/main">
+  <p:cSld>
+    <p:spTree>
+      <p:nvGrpSpPr>
+        <p:cNvPr id="1" name=""/>
+        <p:cNvGrpSpPr/>
+        <p:nvPr/>
+      </p:nvGrpSpPr>
+      <p:grpSpPr>
+        <a:xfrm>
+          <a:off x="0" y="0"/>
+          <a:ext cx="0" cy="0"/>
+          <a:chOff x="0" y="0"/>
+          <a:chExt cx="0" cy="0"/>
+        </a:xfrm>
+      </p:grpSpPr>
+      <p:sp>
+        <p:nvSpPr>
+          <p:cNvPr id="2" name="Title 1">
+            <a:extLst>
+              <a:ext uri="{FF2B5EF4-FFF2-40B4-BE49-F238E27FC236}">
+                <a16:creationId xmlns:a16="http://schemas.microsoft.com/office/drawing/2014/main" id="{767B744D-A139-FB1A-B60B-51B6E6286C0D}"/>
+              </a:ext>
+            </a:extLst>
+          </p:cNvPr>
+          <p:cNvSpPr>
+            <a:spLocks noGrp="1"/>
+          </p:cNvSpPr>
+          <p:nvPr>
+            <p:ph type="title"/>
+          </p:nvPr>
+        </p:nvSpPr>
+        <p:spPr/>
+        <p:txBody>
+          <a:bodyPr/>
+          <a:lstStyle/>
+          <a:p>
+            <a:r>
+              <a:rPr lang="en-US" dirty="0"/>
+              <a:t>Handlink Big Tasks</a:t>
+            </a:r>
+          </a:p>
+        </p:txBody>
+      </p:sp>
+      <p:graphicFrame>
+        <p:nvGraphicFramePr>
+          <p:cNvPr id="4" name="Content Placeholder 3">
+            <a:extLst>
+              <a:ext uri="{FF2B5EF4-FFF2-40B4-BE49-F238E27FC236}">
+                <a16:creationId xmlns:a16="http://schemas.microsoft.com/office/drawing/2014/main" id="{F923482F-EE93-313A-EB53-C79917AA892F}"/>
+              </a:ext>
+            </a:extLst>
+          </p:cNvPr>
+          <p:cNvGraphicFramePr>
+            <a:graphicFrameLocks/>
+          </p:cNvGraphicFramePr>
+          <p:nvPr>
+            <p:extLst>
+              <p:ext uri="{D42A27DB-BD31-4B8C-83A1-F6EECF244321}">
+                <p14:modId xmlns:p14="http://schemas.microsoft.com/office/powerpoint/2010/main" val="3037645106"/>
+              </p:ext>
+            </p:extLst>
+          </p:nvPr>
+        </p:nvGraphicFramePr>
+        <p:xfrm>
+          <a:off x="4092558" y="2098718"/>
+          <a:ext cx="3180630" cy="438359"/>
+        </p:xfrm>
+        <a:graphic>
+          <a:graphicData uri="http://schemas.openxmlformats.org/drawingml/2006/table">
+            <a:tbl>
+              <a:tblPr firstRow="1" bandRow="1">
+                <a:tableStyleId>{5940675A-B579-460E-94D1-54222C63F5DA}</a:tableStyleId>
+              </a:tblPr>
+              <a:tblGrid>
+                <a:gridCol w="636126">
+                  <a:extLst>
+                    <a:ext uri="{9D8B030D-6E8A-4147-A177-3AD203B41FA5}">
+                      <a16:colId xmlns:a16="http://schemas.microsoft.com/office/drawing/2014/main" val="194980701"/>
+                    </a:ext>
+                  </a:extLst>
+                </a:gridCol>
+                <a:gridCol w="636126">
+                  <a:extLst>
+                    <a:ext uri="{9D8B030D-6E8A-4147-A177-3AD203B41FA5}">
+                      <a16:colId xmlns:a16="http://schemas.microsoft.com/office/drawing/2014/main" val="2814616541"/>
+                    </a:ext>
+                  </a:extLst>
+                </a:gridCol>
+                <a:gridCol w="636126">
+                  <a:extLst>
+                    <a:ext uri="{9D8B030D-6E8A-4147-A177-3AD203B41FA5}">
+                      <a16:colId xmlns:a16="http://schemas.microsoft.com/office/drawing/2014/main" val="3925629564"/>
+                    </a:ext>
+                  </a:extLst>
+                </a:gridCol>
+                <a:gridCol w="636126">
+                  <a:extLst>
+                    <a:ext uri="{9D8B030D-6E8A-4147-A177-3AD203B41FA5}">
+                      <a16:colId xmlns:a16="http://schemas.microsoft.com/office/drawing/2014/main" val="505726368"/>
+                    </a:ext>
+                  </a:extLst>
+                </a:gridCol>
+                <a:gridCol w="636126">
+                  <a:extLst>
+                    <a:ext uri="{9D8B030D-6E8A-4147-A177-3AD203B41FA5}">
+                      <a16:colId xmlns:a16="http://schemas.microsoft.com/office/drawing/2014/main" val="3268241414"/>
+                    </a:ext>
+                  </a:extLst>
+                </a:gridCol>
+              </a:tblGrid>
+              <a:tr h="438359">
+                <a:tc>
+                  <a:txBody>
+                    <a:bodyPr/>
+                    <a:lstStyle/>
+                    <a:p>
+                      <a:pPr algn="ctr"/>
+                      <a:endParaRPr lang="en-US" dirty="0"/>
+                    </a:p>
+                  </a:txBody>
+                  <a:tcPr/>
+                </a:tc>
+                <a:tc>
+                  <a:txBody>
+                    <a:bodyPr/>
+                    <a:lstStyle/>
+                    <a:p>
+                      <a:pPr algn="ctr"/>
+                      <a:endParaRPr lang="en-US" dirty="0"/>
+                    </a:p>
+                  </a:txBody>
+                  <a:tcPr/>
+                </a:tc>
+                <a:tc>
+                  <a:txBody>
+                    <a:bodyPr/>
+                    <a:lstStyle/>
+                    <a:p>
+                      <a:pPr algn="ctr"/>
+                      <a:r>
+                        <a:rPr lang="en-US" dirty="0"/>
+                        <a:t>v</a:t>
+                      </a:r>
+                    </a:p>
+                  </a:txBody>
+                  <a:tcPr/>
+                </a:tc>
+                <a:tc>
+                  <a:txBody>
+                    <a:bodyPr/>
+                    <a:lstStyle/>
+                    <a:p>
+                      <a:pPr algn="ctr"/>
+                      <a:endParaRPr lang="en-US" dirty="0"/>
+                    </a:p>
+                  </a:txBody>
+                  <a:tcPr/>
+                </a:tc>
+                <a:tc>
+                  <a:txBody>
+                    <a:bodyPr/>
+                    <a:lstStyle/>
+                    <a:p>
+                      <a:pPr algn="ctr"/>
+                      <a:endParaRPr lang="en-US" dirty="0"/>
+                    </a:p>
+                  </a:txBody>
+                  <a:tcPr/>
+                </a:tc>
+                <a:extLst>
+                  <a:ext uri="{0D108BD9-81ED-4DB2-BD59-A6C34878D82A}">
+                    <a16:rowId xmlns:a16="http://schemas.microsoft.com/office/drawing/2014/main" val="2287342528"/>
+                  </a:ext>
+                </a:extLst>
+              </a:tr>
+            </a:tbl>
+          </a:graphicData>
+        </a:graphic>
+      </p:graphicFrame>
+      <p:sp>
+        <p:nvSpPr>
+          <p:cNvPr id="5" name="TextBox 4">
+            <a:extLst>
+              <a:ext uri="{FF2B5EF4-FFF2-40B4-BE49-F238E27FC236}">
+                <a16:creationId xmlns:a16="http://schemas.microsoft.com/office/drawing/2014/main" id="{DA5B80B6-EC4E-F048-0038-CFF6411D550E}"/>
+              </a:ext>
+            </a:extLst>
+          </p:cNvPr>
+          <p:cNvSpPr txBox="1"/>
+          <p:nvPr/>
+        </p:nvSpPr>
+        <p:spPr>
+          <a:xfrm>
+            <a:off x="4866655" y="1612797"/>
+            <a:ext cx="1756127" cy="369332"/>
+          </a:xfrm>
+          <a:prstGeom prst="rect">
+            <a:avLst/>
+          </a:prstGeom>
+          <a:noFill/>
+        </p:spPr>
+        <p:txBody>
+          <a:bodyPr wrap="square" rtlCol="0">
+            <a:spAutoFit/>
+          </a:bodyPr>
+          <a:lstStyle/>
+          <a:p>
+            <a:r>
+              <a:rPr lang="en-US" dirty="0"/>
+              <a:t>root vertices</a:t>
+            </a:r>
+          </a:p>
+        </p:txBody>
+      </p:sp>
+      <p:sp>
+        <p:nvSpPr>
+          <p:cNvPr id="6" name="Rectangle 5">
+            <a:extLst>
+              <a:ext uri="{FF2B5EF4-FFF2-40B4-BE49-F238E27FC236}">
+                <a16:creationId xmlns:a16="http://schemas.microsoft.com/office/drawing/2014/main" id="{E25991E7-EBD9-411B-061E-6EB77AADD304}"/>
+              </a:ext>
+            </a:extLst>
+          </p:cNvPr>
+          <p:cNvSpPr/>
+          <p:nvPr/>
+        </p:nvSpPr>
+        <p:spPr>
+          <a:xfrm>
+            <a:off x="5231740" y="2753290"/>
+            <a:ext cx="908197" cy="558836"/>
+          </a:xfrm>
+          <a:prstGeom prst="rect">
+            <a:avLst/>
+          </a:prstGeom>
+          <a:ln>
+            <a:prstDash val="dash"/>
+          </a:ln>
+        </p:spPr>
+        <p:style>
+          <a:lnRef idx="2">
+            <a:schemeClr val="dk1"/>
+          </a:lnRef>
+          <a:fillRef idx="1">
+            <a:schemeClr val="lt1"/>
+          </a:fillRef>
+          <a:effectRef idx="0">
+            <a:schemeClr val="dk1"/>
+          </a:effectRef>
+          <a:fontRef idx="minor">
+            <a:schemeClr val="dk1"/>
+          </a:fontRef>
+        </p:style>
+        <p:txBody>
+          <a:bodyPr rtlCol="0" anchor="ctr"/>
+          <a:lstStyle/>
+          <a:p>
+            <a:pPr algn="ctr"/>
+            <a:r>
+              <a:rPr lang="en-US" dirty="0"/>
+              <a:t>2-hop neigh</a:t>
+            </a:r>
+          </a:p>
+        </p:txBody>
+      </p:sp>
+      <p:cxnSp>
+        <p:nvCxnSpPr>
+          <p:cNvPr id="7" name="Straight Connector 6">
+            <a:extLst>
+              <a:ext uri="{FF2B5EF4-FFF2-40B4-BE49-F238E27FC236}">
+                <a16:creationId xmlns:a16="http://schemas.microsoft.com/office/drawing/2014/main" id="{4B12D79D-DB24-5704-F564-5A38DEC648E9}"/>
+              </a:ext>
+            </a:extLst>
+          </p:cNvPr>
+          <p:cNvCxnSpPr>
+            <a:cxnSpLocks/>
+            <a:stCxn id="4" idx="2"/>
+            <a:endCxn id="6" idx="0"/>
+          </p:cNvCxnSpPr>
+          <p:nvPr/>
+        </p:nvCxnSpPr>
+        <p:spPr>
+          <a:xfrm>
+            <a:off x="5682873" y="2537077"/>
+            <a:ext cx="2966" cy="216213"/>
+          </a:xfrm>
+          <a:prstGeom prst="line">
+            <a:avLst/>
+          </a:prstGeom>
+        </p:spPr>
+        <p:style>
+          <a:lnRef idx="2">
+            <a:schemeClr val="accent1"/>
+          </a:lnRef>
+          <a:fillRef idx="0">
+            <a:schemeClr val="accent1"/>
+          </a:fillRef>
+          <a:effectRef idx="1">
+            <a:schemeClr val="accent1"/>
+          </a:effectRef>
+          <a:fontRef idx="minor">
+            <a:schemeClr val="tx1"/>
+          </a:fontRef>
+        </p:style>
+      </p:cxnSp>
+      <p:sp>
+        <p:nvSpPr>
+          <p:cNvPr id="9" name="TextBox 8">
+            <a:extLst>
+              <a:ext uri="{FF2B5EF4-FFF2-40B4-BE49-F238E27FC236}">
+                <a16:creationId xmlns:a16="http://schemas.microsoft.com/office/drawing/2014/main" id="{0C93F2F9-94CF-FE9B-9197-06D4D1F1CD30}"/>
+              </a:ext>
+            </a:extLst>
+          </p:cNvPr>
+          <p:cNvSpPr txBox="1"/>
+          <p:nvPr/>
+        </p:nvSpPr>
+        <p:spPr>
+          <a:xfrm>
+            <a:off x="1214293" y="3528339"/>
+            <a:ext cx="9851287" cy="646331"/>
+          </a:xfrm>
+          <a:prstGeom prst="rect">
+            <a:avLst/>
+          </a:prstGeom>
+          <a:noFill/>
+        </p:spPr>
+        <p:txBody>
+          <a:bodyPr wrap="none" rtlCol="0">
+            <a:spAutoFit/>
+          </a:bodyPr>
+          <a:lstStyle/>
+          <a:p>
+            <a:r>
+              <a:rPr lang="en-US" dirty="0"/>
+              <a:t>root vertices with big tasks are separated at initialization step, using CPU threads (by OpenMP)</a:t>
+            </a:r>
+          </a:p>
+          <a:p>
+            <a:endParaRPr lang="en-US" dirty="0"/>
+          </a:p>
+        </p:txBody>
+      </p:sp>
+      <p:graphicFrame>
+        <p:nvGraphicFramePr>
+          <p:cNvPr id="10" name="Content Placeholder 3">
+            <a:extLst>
+              <a:ext uri="{FF2B5EF4-FFF2-40B4-BE49-F238E27FC236}">
+                <a16:creationId xmlns:a16="http://schemas.microsoft.com/office/drawing/2014/main" id="{BF605D24-416F-9502-BA14-C0F3CB133CFE}"/>
+              </a:ext>
+            </a:extLst>
+          </p:cNvPr>
+          <p:cNvGraphicFramePr>
+            <a:graphicFrameLocks/>
+          </p:cNvGraphicFramePr>
+          <p:nvPr>
+            <p:extLst>
+              <p:ext uri="{D42A27DB-BD31-4B8C-83A1-F6EECF244321}">
+                <p14:modId xmlns:p14="http://schemas.microsoft.com/office/powerpoint/2010/main" val="913953480"/>
+              </p:ext>
+            </p:extLst>
+          </p:nvPr>
+        </p:nvGraphicFramePr>
+        <p:xfrm>
+          <a:off x="2686966" y="4796747"/>
+          <a:ext cx="1908378" cy="438359"/>
+        </p:xfrm>
+        <a:graphic>
+          <a:graphicData uri="http://schemas.openxmlformats.org/drawingml/2006/table">
+            <a:tbl>
+              <a:tblPr firstRow="1" bandRow="1">
+                <a:tableStyleId>{5940675A-B579-460E-94D1-54222C63F5DA}</a:tableStyleId>
+              </a:tblPr>
+              <a:tblGrid>
+                <a:gridCol w="636126">
+                  <a:extLst>
+                    <a:ext uri="{9D8B030D-6E8A-4147-A177-3AD203B41FA5}">
+                      <a16:colId xmlns:a16="http://schemas.microsoft.com/office/drawing/2014/main" val="194980701"/>
+                    </a:ext>
+                  </a:extLst>
+                </a:gridCol>
+                <a:gridCol w="636126">
+                  <a:extLst>
+                    <a:ext uri="{9D8B030D-6E8A-4147-A177-3AD203B41FA5}">
+                      <a16:colId xmlns:a16="http://schemas.microsoft.com/office/drawing/2014/main" val="2814616541"/>
+                    </a:ext>
+                  </a:extLst>
+                </a:gridCol>
+                <a:gridCol w="636126">
+                  <a:extLst>
+                    <a:ext uri="{9D8B030D-6E8A-4147-A177-3AD203B41FA5}">
+                      <a16:colId xmlns:a16="http://schemas.microsoft.com/office/drawing/2014/main" val="3925629564"/>
+                    </a:ext>
+                  </a:extLst>
+                </a:gridCol>
+              </a:tblGrid>
+              <a:tr h="438359">
+                <a:tc>
+                  <a:txBody>
+                    <a:bodyPr/>
+                    <a:lstStyle/>
+                    <a:p>
+                      <a:pPr algn="ctr"/>
+                      <a:endParaRPr lang="en-US" dirty="0"/>
+                    </a:p>
+                  </a:txBody>
+                  <a:tcPr/>
+                </a:tc>
+                <a:tc>
+                  <a:txBody>
+                    <a:bodyPr/>
+                    <a:lstStyle/>
+                    <a:p>
+                      <a:pPr algn="ctr"/>
+                      <a:endParaRPr lang="en-US" dirty="0"/>
+                    </a:p>
+                  </a:txBody>
+                  <a:tcPr/>
+                </a:tc>
+                <a:tc>
+                  <a:txBody>
+                    <a:bodyPr/>
+                    <a:lstStyle/>
+                    <a:p>
+                      <a:pPr algn="ctr"/>
+                      <a:endParaRPr lang="en-US" dirty="0"/>
+                    </a:p>
+                  </a:txBody>
+                  <a:tcPr/>
+                </a:tc>
+                <a:extLst>
+                  <a:ext uri="{0D108BD9-81ED-4DB2-BD59-A6C34878D82A}">
+                    <a16:rowId xmlns:a16="http://schemas.microsoft.com/office/drawing/2014/main" val="2287342528"/>
+                  </a:ext>
+                </a:extLst>
+              </a:tr>
+            </a:tbl>
+          </a:graphicData>
+        </a:graphic>
+      </p:graphicFrame>
+      <p:sp>
+        <p:nvSpPr>
+          <p:cNvPr id="11" name="TextBox 10">
+            <a:extLst>
+              <a:ext uri="{FF2B5EF4-FFF2-40B4-BE49-F238E27FC236}">
+                <a16:creationId xmlns:a16="http://schemas.microsoft.com/office/drawing/2014/main" id="{955C8D13-994B-590F-D315-8769F534E8DE}"/>
+              </a:ext>
+            </a:extLst>
+          </p:cNvPr>
+          <p:cNvSpPr txBox="1"/>
+          <p:nvPr/>
+        </p:nvSpPr>
+        <p:spPr>
+          <a:xfrm>
+            <a:off x="2626729" y="4428363"/>
+            <a:ext cx="2406533" cy="369332"/>
+          </a:xfrm>
+          <a:prstGeom prst="rect">
+            <a:avLst/>
+          </a:prstGeom>
+          <a:noFill/>
+        </p:spPr>
+        <p:txBody>
+          <a:bodyPr wrap="square" rtlCol="0">
+            <a:spAutoFit/>
+          </a:bodyPr>
+          <a:lstStyle/>
+          <a:p>
+            <a:r>
+              <a:rPr lang="en-US" dirty="0"/>
+              <a:t>regular root vertices</a:t>
+            </a:r>
+          </a:p>
+        </p:txBody>
+      </p:sp>
+      <p:graphicFrame>
+        <p:nvGraphicFramePr>
+          <p:cNvPr id="14" name="Content Placeholder 3">
+            <a:extLst>
+              <a:ext uri="{FF2B5EF4-FFF2-40B4-BE49-F238E27FC236}">
+                <a16:creationId xmlns:a16="http://schemas.microsoft.com/office/drawing/2014/main" id="{C6FCD81F-D4A1-BEE8-5E13-FBED0B789AD8}"/>
+              </a:ext>
+            </a:extLst>
+          </p:cNvPr>
+          <p:cNvGraphicFramePr>
+            <a:graphicFrameLocks/>
+          </p:cNvGraphicFramePr>
+          <p:nvPr>
+            <p:extLst>
+              <p:ext uri="{D42A27DB-BD31-4B8C-83A1-F6EECF244321}">
+                <p14:modId xmlns:p14="http://schemas.microsoft.com/office/powerpoint/2010/main" val="1271838108"/>
+              </p:ext>
+            </p:extLst>
+          </p:nvPr>
+        </p:nvGraphicFramePr>
+        <p:xfrm>
+          <a:off x="7885816" y="4809544"/>
+          <a:ext cx="1272252" cy="438359"/>
+        </p:xfrm>
+        <a:graphic>
+          <a:graphicData uri="http://schemas.openxmlformats.org/drawingml/2006/table">
+            <a:tbl>
+              <a:tblPr firstRow="1" bandRow="1">
+                <a:tableStyleId>{5940675A-B579-460E-94D1-54222C63F5DA}</a:tableStyleId>
+              </a:tblPr>
+              <a:tblGrid>
+                <a:gridCol w="636126">
+                  <a:extLst>
+                    <a:ext uri="{9D8B030D-6E8A-4147-A177-3AD203B41FA5}">
+                      <a16:colId xmlns:a16="http://schemas.microsoft.com/office/drawing/2014/main" val="194980701"/>
+                    </a:ext>
+                  </a:extLst>
+                </a:gridCol>
+                <a:gridCol w="636126">
+                  <a:extLst>
+                    <a:ext uri="{9D8B030D-6E8A-4147-A177-3AD203B41FA5}">
+                      <a16:colId xmlns:a16="http://schemas.microsoft.com/office/drawing/2014/main" val="2814616541"/>
+                    </a:ext>
+                  </a:extLst>
+                </a:gridCol>
+              </a:tblGrid>
+              <a:tr h="438359">
+                <a:tc>
+                  <a:txBody>
+                    <a:bodyPr/>
+                    <a:lstStyle/>
+                    <a:p>
+                      <a:pPr algn="ctr"/>
+                      <a:endParaRPr lang="en-US" dirty="0"/>
+                    </a:p>
+                  </a:txBody>
+                  <a:tcPr/>
+                </a:tc>
+                <a:tc>
+                  <a:txBody>
+                    <a:bodyPr/>
+                    <a:lstStyle/>
+                    <a:p>
+                      <a:pPr algn="ctr"/>
+                      <a:endParaRPr lang="en-US" dirty="0"/>
+                    </a:p>
+                  </a:txBody>
+                  <a:tcPr/>
+                </a:tc>
+                <a:extLst>
+                  <a:ext uri="{0D108BD9-81ED-4DB2-BD59-A6C34878D82A}">
+                    <a16:rowId xmlns:a16="http://schemas.microsoft.com/office/drawing/2014/main" val="2287342528"/>
+                  </a:ext>
+                </a:extLst>
+              </a:tr>
+            </a:tbl>
+          </a:graphicData>
+        </a:graphic>
+      </p:graphicFrame>
+      <p:sp>
+        <p:nvSpPr>
+          <p:cNvPr id="15" name="TextBox 14">
+            <a:extLst>
+              <a:ext uri="{FF2B5EF4-FFF2-40B4-BE49-F238E27FC236}">
+                <a16:creationId xmlns:a16="http://schemas.microsoft.com/office/drawing/2014/main" id="{44B4EE0A-6C55-BBED-95D8-E20AFE162E30}"/>
+              </a:ext>
+            </a:extLst>
+          </p:cNvPr>
+          <p:cNvSpPr txBox="1"/>
+          <p:nvPr/>
+        </p:nvSpPr>
+        <p:spPr>
+          <a:xfrm>
+            <a:off x="7596657" y="4427415"/>
+            <a:ext cx="2406533" cy="369332"/>
+          </a:xfrm>
+          <a:prstGeom prst="rect">
+            <a:avLst/>
+          </a:prstGeom>
+          <a:noFill/>
+        </p:spPr>
+        <p:txBody>
+          <a:bodyPr wrap="square" rtlCol="0">
+            <a:spAutoFit/>
+          </a:bodyPr>
+          <a:lstStyle/>
+          <a:p>
+            <a:r>
+              <a:rPr lang="en-US" dirty="0" err="1"/>
+              <a:t>big_root</a:t>
+            </a:r>
+            <a:r>
+              <a:rPr lang="en-US" dirty="0"/>
+              <a:t> vertices</a:t>
+            </a:r>
+          </a:p>
+        </p:txBody>
+      </p:sp>
+      <p:sp>
+        <p:nvSpPr>
+          <p:cNvPr id="19" name="TextBox 18">
+            <a:extLst>
+              <a:ext uri="{FF2B5EF4-FFF2-40B4-BE49-F238E27FC236}">
+                <a16:creationId xmlns:a16="http://schemas.microsoft.com/office/drawing/2014/main" id="{04B344CD-3D80-F184-01EF-D60C64B87CD9}"/>
+              </a:ext>
+            </a:extLst>
+          </p:cNvPr>
+          <p:cNvSpPr txBox="1"/>
+          <p:nvPr/>
+        </p:nvSpPr>
+        <p:spPr>
+          <a:xfrm>
+            <a:off x="7227116" y="5365990"/>
+            <a:ext cx="3034677" cy="646331"/>
+          </a:xfrm>
+          <a:prstGeom prst="rect">
+            <a:avLst/>
+          </a:prstGeom>
+          <a:noFill/>
+        </p:spPr>
+        <p:txBody>
+          <a:bodyPr wrap="none" rtlCol="0">
+            <a:spAutoFit/>
+          </a:bodyPr>
+          <a:lstStyle/>
+          <a:p>
+            <a:r>
+              <a:rPr lang="en-US" dirty="0"/>
+              <a:t>master schedules </a:t>
+            </a:r>
+            <a:r>
+              <a:rPr lang="en-US" dirty="0" err="1"/>
+              <a:t>big_root</a:t>
+            </a:r>
+            <a:r>
+              <a:rPr lang="en-US" dirty="0"/>
+              <a:t> </a:t>
+            </a:r>
+          </a:p>
+          <a:p>
+            <a:r>
+              <a:rPr lang="en-US" dirty="0"/>
+              <a:t>vertices to CPU threads only </a:t>
+            </a:r>
+          </a:p>
+        </p:txBody>
+      </p:sp>
+    </p:spTree>
+    <p:extLst>
+      <p:ext uri="{BB962C8B-B14F-4D97-AF65-F5344CB8AC3E}">
+        <p14:creationId xmlns:p14="http://schemas.microsoft.com/office/powerpoint/2010/main" val="760717346"/>
+      </p:ext>
+    </p:extLst>
+  </p:cSld>
+  <p:clrMapOvr>
+    <a:masterClrMapping/>
+  </p:clrMapOvr>
+</p:sld>
+</file>
+
+<file path=ppt/slides/slide14.xml><?xml version="1.0" encoding="utf-8"?>
+<p:sld xmlns:a="http://schemas.openxmlformats.org/drawingml/2006/main" xmlns:r="http://schemas.openxmlformats.org/officeDocument/2006/relationships" xmlns:p="http://schemas.openxmlformats.org/presentationml/2006/main">
+  <p:cSld>
+    <p:spTree>
+      <p:nvGrpSpPr>
+        <p:cNvPr id="1" name=""/>
+        <p:cNvGrpSpPr/>
+        <p:nvPr/>
+      </p:nvGrpSpPr>
+      <p:grpSpPr>
+        <a:xfrm>
+          <a:off x="0" y="0"/>
+          <a:ext cx="0" cy="0"/>
+          <a:chOff x="0" y="0"/>
+          <a:chExt cx="0" cy="0"/>
+        </a:xfrm>
+      </p:grpSpPr>
+      <p:sp>
+        <p:nvSpPr>
+          <p:cNvPr id="2" name="Title 1">
+            <a:extLst>
+              <a:ext uri="{FF2B5EF4-FFF2-40B4-BE49-F238E27FC236}">
+                <a16:creationId xmlns:a16="http://schemas.microsoft.com/office/drawing/2014/main" id="{7D291E18-9DFD-BE05-AAD5-88906D182AFF}"/>
+              </a:ext>
+            </a:extLst>
+          </p:cNvPr>
+          <p:cNvSpPr>
+            <a:spLocks noGrp="1"/>
+          </p:cNvSpPr>
+          <p:nvPr>
+            <p:ph type="title"/>
+          </p:nvPr>
+        </p:nvSpPr>
+        <p:spPr/>
+        <p:txBody>
+          <a:bodyPr/>
+          <a:lstStyle/>
+          <a:p>
+            <a:r>
+              <a:rPr lang="en-US" dirty="0"/>
+              <a:t>Update CPU Worker</a:t>
+            </a:r>
+          </a:p>
+        </p:txBody>
+      </p:sp>
+      <p:pic>
+        <p:nvPicPr>
+          <p:cNvPr id="4" name="Picture 3">
+            <a:extLst>
+              <a:ext uri="{FF2B5EF4-FFF2-40B4-BE49-F238E27FC236}">
+                <a16:creationId xmlns:a16="http://schemas.microsoft.com/office/drawing/2014/main" id="{B34F3316-7270-F1BB-A82C-E34019F8BAEE}"/>
+              </a:ext>
+            </a:extLst>
+          </p:cNvPr>
+          <p:cNvPicPr>
+            <a:picLocks noChangeAspect="1"/>
+          </p:cNvPicPr>
+          <p:nvPr/>
+        </p:nvPicPr>
+        <p:blipFill>
+          <a:blip r:embed="rId2"/>
+          <a:srcRect b="9091"/>
+          <a:stretch>
+            <a:fillRect/>
+          </a:stretch>
+        </p:blipFill>
+        <p:spPr>
+          <a:xfrm>
+            <a:off x="2349500" y="1955631"/>
+            <a:ext cx="7950200" cy="2603669"/>
+          </a:xfrm>
+          <a:prstGeom prst="rect">
+            <a:avLst/>
+          </a:prstGeom>
+        </p:spPr>
+      </p:pic>
+      <p:pic>
+        <p:nvPicPr>
+          <p:cNvPr id="7" name="Picture 6">
+            <a:extLst>
+              <a:ext uri="{FF2B5EF4-FFF2-40B4-BE49-F238E27FC236}">
+                <a16:creationId xmlns:a16="http://schemas.microsoft.com/office/drawing/2014/main" id="{0887BFF7-624C-257F-6649-8B778DD7D07F}"/>
+              </a:ext>
+            </a:extLst>
+          </p:cNvPr>
+          <p:cNvPicPr>
+            <a:picLocks noChangeAspect="1"/>
+          </p:cNvPicPr>
+          <p:nvPr/>
+        </p:nvPicPr>
+        <p:blipFill>
+          <a:blip r:embed="rId3"/>
+          <a:srcRect l="53140"/>
+          <a:stretch>
+            <a:fillRect/>
+          </a:stretch>
+        </p:blipFill>
+        <p:spPr>
+          <a:xfrm>
+            <a:off x="7412901" y="5259645"/>
+            <a:ext cx="390360" cy="730728"/>
+          </a:xfrm>
+          <a:prstGeom prst="rect">
+            <a:avLst/>
+          </a:prstGeom>
+        </p:spPr>
+      </p:pic>
+      <p:sp>
+        <p:nvSpPr>
+          <p:cNvPr id="8" name="TextBox 7">
+            <a:extLst>
+              <a:ext uri="{FF2B5EF4-FFF2-40B4-BE49-F238E27FC236}">
+                <a16:creationId xmlns:a16="http://schemas.microsoft.com/office/drawing/2014/main" id="{8D916048-DF75-1452-4265-9D9A582345D9}"/>
+              </a:ext>
+            </a:extLst>
+          </p:cNvPr>
+          <p:cNvSpPr txBox="1"/>
+          <p:nvPr/>
+        </p:nvSpPr>
+        <p:spPr>
+          <a:xfrm>
+            <a:off x="7412901" y="5259645"/>
+            <a:ext cx="626006" cy="276999"/>
+          </a:xfrm>
+          <a:prstGeom prst="rect">
+            <a:avLst/>
+          </a:prstGeom>
+          <a:noFill/>
+        </p:spPr>
+        <p:txBody>
+          <a:bodyPr wrap="square" rtlCol="0">
+            <a:spAutoFit/>
+          </a:bodyPr>
+          <a:lstStyle/>
+          <a:p>
+            <a:r>
+              <a:rPr lang="en-US" sz="1200" b="1" i="1" dirty="0"/>
+              <a:t>big</a:t>
+            </a:r>
+          </a:p>
+        </p:txBody>
+      </p:sp>
+      <p:pic>
+        <p:nvPicPr>
+          <p:cNvPr id="15" name="Picture 14">
+            <a:extLst>
+              <a:ext uri="{FF2B5EF4-FFF2-40B4-BE49-F238E27FC236}">
+                <a16:creationId xmlns:a16="http://schemas.microsoft.com/office/drawing/2014/main" id="{190DF368-E8DA-C66C-E90C-77DD0DB2C4F5}"/>
+              </a:ext>
+            </a:extLst>
+          </p:cNvPr>
+          <p:cNvPicPr>
+            <a:picLocks noChangeAspect="1"/>
+          </p:cNvPicPr>
+          <p:nvPr/>
+        </p:nvPicPr>
+        <p:blipFill>
+          <a:blip r:embed="rId4"/>
+          <a:stretch>
+            <a:fillRect/>
+          </a:stretch>
+        </p:blipFill>
+        <p:spPr>
+          <a:xfrm>
+            <a:off x="5721350" y="1663531"/>
+            <a:ext cx="2527300" cy="292100"/>
+          </a:xfrm>
+          <a:prstGeom prst="rect">
+            <a:avLst/>
+          </a:prstGeom>
+        </p:spPr>
+      </p:pic>
+      <p:sp>
+        <p:nvSpPr>
+          <p:cNvPr id="16" name="TextBox 15">
+            <a:extLst>
+              <a:ext uri="{FF2B5EF4-FFF2-40B4-BE49-F238E27FC236}">
+                <a16:creationId xmlns:a16="http://schemas.microsoft.com/office/drawing/2014/main" id="{132A7DEC-0ED2-99D7-C858-3C74D3068193}"/>
+              </a:ext>
+            </a:extLst>
+          </p:cNvPr>
+          <p:cNvSpPr txBox="1"/>
+          <p:nvPr/>
+        </p:nvSpPr>
+        <p:spPr>
+          <a:xfrm>
+            <a:off x="5721350" y="1321356"/>
+            <a:ext cx="954107" cy="369332"/>
+          </a:xfrm>
+          <a:prstGeom prst="rect">
+            <a:avLst/>
+          </a:prstGeom>
+          <a:noFill/>
+        </p:spPr>
+        <p:txBody>
+          <a:bodyPr wrap="none" rtlCol="0">
+            <a:spAutoFit/>
+          </a:bodyPr>
+          <a:lstStyle/>
+          <a:p>
+            <a:r>
+              <a:rPr lang="en-US" dirty="0"/>
+              <a:t>CPU </a:t>
+            </a:r>
+            <a:r>
+              <a:rPr lang="en-US" dirty="0">
+                <a:sym typeface="Wingdings" pitchFamily="2" charset="2"/>
+              </a:rPr>
+              <a:t> </a:t>
+            </a:r>
+            <a:endParaRPr lang="en-US" dirty="0"/>
+          </a:p>
+        </p:txBody>
+      </p:sp>
+      <p:sp>
+        <p:nvSpPr>
+          <p:cNvPr id="17" name="TextBox 16">
+            <a:extLst>
+              <a:ext uri="{FF2B5EF4-FFF2-40B4-BE49-F238E27FC236}">
+                <a16:creationId xmlns:a16="http://schemas.microsoft.com/office/drawing/2014/main" id="{12E7DE85-92A7-A7EA-AE7C-F1B776E35B2C}"/>
+              </a:ext>
+            </a:extLst>
+          </p:cNvPr>
+          <p:cNvSpPr txBox="1"/>
+          <p:nvPr/>
+        </p:nvSpPr>
+        <p:spPr>
+          <a:xfrm>
+            <a:off x="4622800" y="1586299"/>
+            <a:ext cx="989438" cy="369332"/>
+          </a:xfrm>
+          <a:prstGeom prst="rect">
+            <a:avLst/>
+          </a:prstGeom>
+          <a:noFill/>
+        </p:spPr>
+        <p:txBody>
+          <a:bodyPr wrap="none" rtlCol="0">
+            <a:spAutoFit/>
+          </a:bodyPr>
+          <a:lstStyle/>
+          <a:p>
+            <a:r>
+              <a:rPr lang="en-US" dirty="0" err="1"/>
+              <a:t>big_root</a:t>
+            </a:r>
+            <a:endParaRPr lang="en-US" dirty="0"/>
+          </a:p>
+        </p:txBody>
+      </p:sp>
+      <p:cxnSp>
+        <p:nvCxnSpPr>
+          <p:cNvPr id="19" name="Straight Arrow Connector 18">
+            <a:extLst>
+              <a:ext uri="{FF2B5EF4-FFF2-40B4-BE49-F238E27FC236}">
+                <a16:creationId xmlns:a16="http://schemas.microsoft.com/office/drawing/2014/main" id="{77C7BAF6-FF5F-E302-0365-0CAF2AAD1F7C}"/>
+              </a:ext>
+            </a:extLst>
+          </p:cNvPr>
+          <p:cNvCxnSpPr>
+            <a:stCxn id="15" idx="2"/>
+          </p:cNvCxnSpPr>
+          <p:nvPr/>
+        </p:nvCxnSpPr>
+        <p:spPr>
+          <a:xfrm>
+            <a:off x="6985000" y="1955631"/>
+            <a:ext cx="1263650" cy="1168569"/>
+          </a:xfrm>
+          <a:prstGeom prst="straightConnector1">
+            <a:avLst/>
+          </a:prstGeom>
+          <a:ln>
+            <a:tailEnd type="triangle"/>
+          </a:ln>
+        </p:spPr>
+        <p:style>
+          <a:lnRef idx="2">
+            <a:schemeClr val="accent1"/>
+          </a:lnRef>
+          <a:fillRef idx="0">
+            <a:schemeClr val="accent1"/>
+          </a:fillRef>
+          <a:effectRef idx="1">
+            <a:schemeClr val="accent1"/>
+          </a:effectRef>
+          <a:fontRef idx="minor">
+            <a:schemeClr val="tx1"/>
+          </a:fontRef>
+        </p:style>
+      </p:cxnSp>
+      <p:cxnSp>
+        <p:nvCxnSpPr>
+          <p:cNvPr id="20" name="Straight Arrow Connector 19">
+            <a:extLst>
+              <a:ext uri="{FF2B5EF4-FFF2-40B4-BE49-F238E27FC236}">
+                <a16:creationId xmlns:a16="http://schemas.microsoft.com/office/drawing/2014/main" id="{A188E86F-74E4-1777-90C5-96968350B754}"/>
+              </a:ext>
+            </a:extLst>
+          </p:cNvPr>
+          <p:cNvCxnSpPr>
+            <a:cxnSpLocks/>
+          </p:cNvCxnSpPr>
+          <p:nvPr/>
+        </p:nvCxnSpPr>
+        <p:spPr>
+          <a:xfrm>
+            <a:off x="7539468" y="3572171"/>
+            <a:ext cx="27025" cy="1687473"/>
+          </a:xfrm>
+          <a:prstGeom prst="straightConnector1">
+            <a:avLst/>
+          </a:prstGeom>
+          <a:ln>
+            <a:prstDash val="dash"/>
+            <a:tailEnd type="triangle"/>
+          </a:ln>
+        </p:spPr>
+        <p:style>
+          <a:lnRef idx="2">
+            <a:schemeClr val="accent1"/>
+          </a:lnRef>
+          <a:fillRef idx="0">
+            <a:schemeClr val="accent1"/>
+          </a:fillRef>
+          <a:effectRef idx="1">
+            <a:schemeClr val="accent1"/>
+          </a:effectRef>
+          <a:fontRef idx="minor">
+            <a:schemeClr val="tx1"/>
+          </a:fontRef>
+        </p:style>
+      </p:cxnSp>
+      <p:sp>
+        <p:nvSpPr>
+          <p:cNvPr id="22" name="TextBox 21">
+            <a:extLst>
+              <a:ext uri="{FF2B5EF4-FFF2-40B4-BE49-F238E27FC236}">
+                <a16:creationId xmlns:a16="http://schemas.microsoft.com/office/drawing/2014/main" id="{953AEAA8-B890-570B-D908-E2423BC4FBAA}"/>
+              </a:ext>
+            </a:extLst>
+          </p:cNvPr>
+          <p:cNvSpPr txBox="1"/>
+          <p:nvPr/>
+        </p:nvSpPr>
+        <p:spPr>
+          <a:xfrm>
+            <a:off x="6592907" y="4618895"/>
+            <a:ext cx="950004" cy="646331"/>
+          </a:xfrm>
+          <a:prstGeom prst="rect">
+            <a:avLst/>
+          </a:prstGeom>
+          <a:noFill/>
+        </p:spPr>
+        <p:txBody>
+          <a:bodyPr wrap="none" rtlCol="0">
+            <a:spAutoFit/>
+          </a:bodyPr>
+          <a:lstStyle/>
+          <a:p>
+            <a:r>
+              <a:rPr lang="en-US" dirty="0"/>
+              <a:t>still a </a:t>
+            </a:r>
+          </a:p>
+          <a:p>
+            <a:r>
+              <a:rPr lang="en-US" dirty="0"/>
+              <a:t>big task</a:t>
+            </a:r>
+          </a:p>
+        </p:txBody>
+      </p:sp>
+      <p:pic>
+        <p:nvPicPr>
+          <p:cNvPr id="25" name="Picture 24">
+            <a:extLst>
+              <a:ext uri="{FF2B5EF4-FFF2-40B4-BE49-F238E27FC236}">
+                <a16:creationId xmlns:a16="http://schemas.microsoft.com/office/drawing/2014/main" id="{93D4A19A-2EDE-CB25-E141-9CEF122CCFC2}"/>
+              </a:ext>
+            </a:extLst>
+          </p:cNvPr>
+          <p:cNvPicPr>
+            <a:picLocks noChangeAspect="1"/>
+          </p:cNvPicPr>
+          <p:nvPr/>
+        </p:nvPicPr>
+        <p:blipFill>
+          <a:blip r:embed="rId5"/>
+          <a:srcRect r="28414" b="18252"/>
+          <a:stretch>
+            <a:fillRect/>
+          </a:stretch>
+        </p:blipFill>
+        <p:spPr>
+          <a:xfrm>
+            <a:off x="8038907" y="5756778"/>
+            <a:ext cx="736405" cy="467190"/>
+          </a:xfrm>
+          <a:prstGeom prst="rect">
+            <a:avLst/>
+          </a:prstGeom>
+        </p:spPr>
+      </p:pic>
+      <p:cxnSp>
+        <p:nvCxnSpPr>
+          <p:cNvPr id="26" name="Straight Arrow Connector 25">
+            <a:extLst>
+              <a:ext uri="{FF2B5EF4-FFF2-40B4-BE49-F238E27FC236}">
+                <a16:creationId xmlns:a16="http://schemas.microsoft.com/office/drawing/2014/main" id="{F8B99B4F-A683-F981-B0B5-E57FAF0629D9}"/>
+              </a:ext>
+            </a:extLst>
+          </p:cNvPr>
+          <p:cNvCxnSpPr>
+            <a:cxnSpLocks/>
+            <a:endCxn id="25" idx="1"/>
+          </p:cNvCxnSpPr>
+          <p:nvPr/>
+        </p:nvCxnSpPr>
+        <p:spPr>
+          <a:xfrm>
+            <a:off x="7632312" y="5990373"/>
+            <a:ext cx="406595" cy="0"/>
+          </a:xfrm>
+          <a:prstGeom prst="straightConnector1">
+            <a:avLst/>
+          </a:prstGeom>
+          <a:ln>
+            <a:prstDash val="dash"/>
+            <a:tailEnd type="triangle"/>
+          </a:ln>
+        </p:spPr>
+        <p:style>
+          <a:lnRef idx="2">
+            <a:schemeClr val="accent1"/>
+          </a:lnRef>
+          <a:fillRef idx="0">
+            <a:schemeClr val="accent1"/>
+          </a:fillRef>
+          <a:effectRef idx="1">
+            <a:schemeClr val="accent1"/>
+          </a:effectRef>
+          <a:fontRef idx="minor">
+            <a:schemeClr val="tx1"/>
+          </a:fontRef>
+        </p:style>
+      </p:cxnSp>
+      <p:sp>
+        <p:nvSpPr>
+          <p:cNvPr id="31" name="TextBox 30">
+            <a:extLst>
+              <a:ext uri="{FF2B5EF4-FFF2-40B4-BE49-F238E27FC236}">
+                <a16:creationId xmlns:a16="http://schemas.microsoft.com/office/drawing/2014/main" id="{089AF7A7-23FB-40B7-63F6-C7FA798F1045}"/>
+              </a:ext>
+            </a:extLst>
+          </p:cNvPr>
+          <p:cNvSpPr txBox="1"/>
+          <p:nvPr/>
+        </p:nvSpPr>
+        <p:spPr>
+          <a:xfrm>
+            <a:off x="8700988" y="5805707"/>
+            <a:ext cx="716863" cy="369332"/>
+          </a:xfrm>
+          <a:prstGeom prst="rect">
+            <a:avLst/>
+          </a:prstGeom>
+          <a:noFill/>
+        </p:spPr>
+        <p:txBody>
+          <a:bodyPr wrap="none" rtlCol="0">
+            <a:spAutoFit/>
+          </a:bodyPr>
+          <a:lstStyle/>
+          <a:p>
+            <a:r>
+              <a:rPr lang="en-US" i="1" dirty="0" err="1"/>
+              <a:t>big_S</a:t>
+            </a:r>
+            <a:endParaRPr lang="en-US" i="1" dirty="0"/>
+          </a:p>
+        </p:txBody>
+      </p:sp>
+      <p:cxnSp>
+        <p:nvCxnSpPr>
+          <p:cNvPr id="33" name="Straight Arrow Connector 32">
+            <a:extLst>
+              <a:ext uri="{FF2B5EF4-FFF2-40B4-BE49-F238E27FC236}">
+                <a16:creationId xmlns:a16="http://schemas.microsoft.com/office/drawing/2014/main" id="{11A66878-DAE4-281F-4E7A-65095BA631A9}"/>
+              </a:ext>
+            </a:extLst>
+          </p:cNvPr>
+          <p:cNvCxnSpPr>
+            <a:cxnSpLocks/>
+            <a:stCxn id="25" idx="1"/>
+          </p:cNvCxnSpPr>
+          <p:nvPr/>
+        </p:nvCxnSpPr>
+        <p:spPr>
+          <a:xfrm flipV="1">
+            <a:off x="8038907" y="3552586"/>
+            <a:ext cx="474147" cy="2437787"/>
+          </a:xfrm>
+          <a:prstGeom prst="straightConnector1">
+            <a:avLst/>
+          </a:prstGeom>
+          <a:ln>
+            <a:tailEnd type="triangle"/>
+          </a:ln>
+        </p:spPr>
+        <p:style>
+          <a:lnRef idx="2">
+            <a:schemeClr val="accent1"/>
+          </a:lnRef>
+          <a:fillRef idx="0">
+            <a:schemeClr val="accent1"/>
+          </a:fillRef>
+          <a:effectRef idx="1">
+            <a:schemeClr val="accent1"/>
+          </a:effectRef>
+          <a:fontRef idx="minor">
+            <a:schemeClr val="tx1"/>
+          </a:fontRef>
+        </p:style>
+      </p:cxnSp>
+    </p:spTree>
+    <p:extLst>
+      <p:ext uri="{BB962C8B-B14F-4D97-AF65-F5344CB8AC3E}">
+        <p14:creationId xmlns:p14="http://schemas.microsoft.com/office/powerpoint/2010/main" val="567586229"/>
       </p:ext>
     </p:extLst>
   </p:cSld>

</xml_diff>